<commit_message>
Add technical diagrams to AI Agents deck
</commit_message>
<xml_diff>
--- a/agentes-de-ia/agentes-intro.pptx
+++ b/agentes-de-ia/agentes-intro.pptx
@@ -710,7 +710,7 @@
             <a:r>
               <a:rPr lang="en-US" dirty="0"/>
               <a:t>"Veámoslo con un ejemplo: '¿Cuánto vendimos en marzo?'. En cuatro pasos: el modelo no sabe el dato; pide la herramienta; tu código consulta la base de datos; y solo entonces responde."
-"Abajo está el turno por dentro, como lista de mensajes: system (las reglas), user (la pregunta), assistant (pide execute_sql), tool (el resultado: 42150) y assistant (la respuesta: 42.150)."
+"Por debajo, el turno es una lista de mensajes que crece: system (las reglas), user (la pregunta), assistant (pide execute_sql), tool (el resultado: 42150) y assistant (la respuesta: 42.150)."
 "Y esto no es solo para una tool: si la tarea lo pide, el agente encadena varias en el mismo turno. Como pedirle '¿cuánto es 312.5 × 4.2 y cuántas palabras tiene este texto?': primero llama a una calculadora, recibe 1312.5; luego a un contador, recibe 5; y solo entonces, con ambos resultados, redacta. Dos herramientas, un solo turno, sin que el modelo ejecute nada."
 "Conclusión: el modelo solo pidió la consulta; la ejecutó tu código, con tus permisos."
 [acum 9:50]</a:t>
@@ -1525,7 +1525,7 @@
           <a:p>
             <a:r>
               <a:rPr lang="en-US" dirty="0"/>
-              <a:t>"Vengo de construir agentes conversacionales en producción: LangChain, LangGraph, RAG. Pero hoy no hablo de mis proyectos: hablo de la base, para que al salir entiendan qué hay debajo de la palabra 'agente'."
+              <a:t>"Vengo de construir agentes conversacionales en producción: LangChain, LangGraph, RAG. Llevo tres años en esto. Hoy no hablo de mis proyectos: comparto los fundamentos, para que puedan construir su primer agente."
 [acum 1:30]</a:t>
             </a:r>
             <a:endParaRPr lang="en-US" dirty="0"/>
@@ -4834,654 +4834,9 @@
           </a:p>
         </p:txBody>
       </p:sp>
-      <p:sp>
-        <p:nvSpPr>
-          <p:cNvPr id="9" name="Shape 7"/>
-          <p:cNvSpPr/>
-          <p:nvPr/>
-        </p:nvSpPr>
-        <p:spPr>
-          <a:xfrm>
-            <a:off x="658368" y="2011680"/>
-            <a:ext cx="2444420" cy="749808"/>
-          </a:xfrm>
-          <a:prstGeom prst="roundRect">
-            <a:avLst>
-              <a:gd name="adj" fmla="val 7317"/>
-            </a:avLst>
-          </a:prstGeom>
-          <a:solidFill>
-            <a:srgbClr val="FFFFFF"/>
-          </a:solidFill>
-          <a:ln w="12700">
-            <a:solidFill>
-              <a:srgbClr val="DFE6F0"/>
-            </a:solidFill>
-            <a:prstDash val="solid"/>
-          </a:ln>
-        </p:spPr>
-      </p:sp>
-      <p:sp>
-        <p:nvSpPr>
-          <p:cNvPr id="10" name="Shape 8"/>
-          <p:cNvSpPr/>
-          <p:nvPr/>
-        </p:nvSpPr>
-        <p:spPr>
-          <a:xfrm>
-            <a:off x="658368" y="2011680"/>
-            <a:ext cx="2444420" cy="54864"/>
-          </a:xfrm>
-          <a:prstGeom prst="roundRect">
-            <a:avLst>
-              <a:gd name="adj" fmla="val 50000"/>
-            </a:avLst>
-          </a:prstGeom>
-          <a:solidFill>
-            <a:srgbClr val="12245B"/>
-          </a:solidFill>
-          <a:ln w="12700">
-            <a:solidFill>
-              <a:srgbClr val="333333"/>
-            </a:solidFill>
-            <a:prstDash val="solid"/>
-          </a:ln>
-        </p:spPr>
-      </p:sp>
-      <p:sp>
-        <p:nvSpPr>
-          <p:cNvPr id="11" name="Text 9"/>
-          <p:cNvSpPr/>
-          <p:nvPr/>
-        </p:nvSpPr>
-        <p:spPr>
-          <a:xfrm>
-            <a:off x="804672" y="2093976"/>
-            <a:ext cx="365760" cy="274320"/>
-          </a:xfrm>
-          <a:prstGeom prst="rect">
-            <a:avLst/>
-          </a:prstGeom>
-          <a:noFill/>
-          <a:ln/>
-        </p:spPr>
-        <p:txBody>
-          <a:bodyPr wrap="square" rtlCol="0" anchor="ctr"/>
-          <a:lstStyle/>
-          <a:p>
-            <a:pPr indent="0" marL="0">
-              <a:buNone/>
-            </a:pPr>
-            <a:r>
-              <a:rPr lang="en-US" sz="1200" b="1" dirty="0">
-                <a:solidFill>
-                  <a:srgbClr val="12245B"/>
-                </a:solidFill>
-                <a:latin typeface="Montserrat" pitchFamily="34" charset="0"/>
-                <a:ea typeface="Montserrat" pitchFamily="34" charset="-122"/>
-                <a:cs typeface="Montserrat" pitchFamily="34" charset="-120"/>
-              </a:rPr>
-              <a:t>1</a:t>
-            </a:r>
-            <a:endParaRPr lang="en-US" sz="1200" dirty="0"/>
-          </a:p>
-        </p:txBody>
-      </p:sp>
-      <p:sp>
-        <p:nvSpPr>
-          <p:cNvPr id="12" name="Text 10"/>
-          <p:cNvSpPr/>
-          <p:nvPr/>
-        </p:nvSpPr>
-        <p:spPr>
-          <a:xfrm>
-            <a:off x="804672" y="2377440"/>
-            <a:ext cx="2170100" cy="365760"/>
-          </a:xfrm>
-          <a:prstGeom prst="rect">
-            <a:avLst/>
-          </a:prstGeom>
-          <a:noFill/>
-          <a:ln/>
-        </p:spPr>
-        <p:txBody>
-          <a:bodyPr wrap="square" rtlCol="0" anchor="t"/>
-          <a:lstStyle/>
-          <a:p>
-            <a:pPr indent="0" marL="0">
-              <a:buNone/>
-            </a:pPr>
-            <a:r>
-              <a:rPr lang="en-US" sz="1050" b="1" dirty="0">
-                <a:solidFill>
-                  <a:srgbClr val="0F1B33"/>
-                </a:solidFill>
-                <a:latin typeface="Inter" pitchFamily="34" charset="0"/>
-                <a:ea typeface="Inter" pitchFamily="34" charset="-122"/>
-                <a:cs typeface="Inter" pitchFamily="34" charset="-120"/>
-              </a:rPr>
-              <a:t>No sabe el dato</a:t>
-            </a:r>
-            <a:endParaRPr lang="en-US" sz="1050" dirty="0"/>
-          </a:p>
-        </p:txBody>
-      </p:sp>
-      <p:sp>
-        <p:nvSpPr>
-          <p:cNvPr id="13" name="Text 11"/>
-          <p:cNvSpPr/>
-          <p:nvPr/>
-        </p:nvSpPr>
-        <p:spPr>
-          <a:xfrm>
-            <a:off x="3102788" y="2011680"/>
-            <a:ext cx="365760" cy="749808"/>
-          </a:xfrm>
-          <a:prstGeom prst="rect">
-            <a:avLst/>
-          </a:prstGeom>
-          <a:noFill/>
-          <a:ln/>
-        </p:spPr>
-        <p:txBody>
-          <a:bodyPr wrap="square" rtlCol="0" anchor="ctr"/>
-          <a:lstStyle/>
-          <a:p>
-            <a:pPr algn="ctr" indent="0" marL="0">
-              <a:buNone/>
-            </a:pPr>
-            <a:r>
-              <a:rPr lang="en-US" sz="1800" b="1" dirty="0">
-                <a:solidFill>
-                  <a:srgbClr val="1E9BD7"/>
-                </a:solidFill>
-                <a:latin typeface="Montserrat" pitchFamily="34" charset="0"/>
-                <a:ea typeface="Montserrat" pitchFamily="34" charset="-122"/>
-                <a:cs typeface="Montserrat" pitchFamily="34" charset="-120"/>
-              </a:rPr>
-              <a:t>→</a:t>
-            </a:r>
-            <a:endParaRPr lang="en-US" sz="1800" dirty="0"/>
-          </a:p>
-        </p:txBody>
-      </p:sp>
-      <p:sp>
-        <p:nvSpPr>
-          <p:cNvPr id="14" name="Shape 12"/>
-          <p:cNvSpPr/>
-          <p:nvPr/>
-        </p:nvSpPr>
-        <p:spPr>
-          <a:xfrm>
-            <a:off x="3468548" y="2011680"/>
-            <a:ext cx="2444420" cy="749808"/>
-          </a:xfrm>
-          <a:prstGeom prst="roundRect">
-            <a:avLst>
-              <a:gd name="adj" fmla="val 7317"/>
-            </a:avLst>
-          </a:prstGeom>
-          <a:solidFill>
-            <a:srgbClr val="FFFFFF"/>
-          </a:solidFill>
-          <a:ln w="12700">
-            <a:solidFill>
-              <a:srgbClr val="DFE6F0"/>
-            </a:solidFill>
-            <a:prstDash val="solid"/>
-          </a:ln>
-        </p:spPr>
-      </p:sp>
-      <p:sp>
-        <p:nvSpPr>
-          <p:cNvPr id="15" name="Shape 13"/>
-          <p:cNvSpPr/>
-          <p:nvPr/>
-        </p:nvSpPr>
-        <p:spPr>
-          <a:xfrm>
-            <a:off x="3468548" y="2011680"/>
-            <a:ext cx="2444420" cy="54864"/>
-          </a:xfrm>
-          <a:prstGeom prst="roundRect">
-            <a:avLst>
-              <a:gd name="adj" fmla="val 50000"/>
-            </a:avLst>
-          </a:prstGeom>
-          <a:solidFill>
-            <a:srgbClr val="D9820A"/>
-          </a:solidFill>
-          <a:ln w="12700">
-            <a:solidFill>
-              <a:srgbClr val="333333"/>
-            </a:solidFill>
-            <a:prstDash val="solid"/>
-          </a:ln>
-        </p:spPr>
-      </p:sp>
-      <p:sp>
-        <p:nvSpPr>
-          <p:cNvPr id="16" name="Text 14"/>
-          <p:cNvSpPr/>
-          <p:nvPr/>
-        </p:nvSpPr>
-        <p:spPr>
-          <a:xfrm>
-            <a:off x="3614852" y="2093976"/>
-            <a:ext cx="365760" cy="274320"/>
-          </a:xfrm>
-          <a:prstGeom prst="rect">
-            <a:avLst/>
-          </a:prstGeom>
-          <a:noFill/>
-          <a:ln/>
-        </p:spPr>
-        <p:txBody>
-          <a:bodyPr wrap="square" rtlCol="0" anchor="ctr"/>
-          <a:lstStyle/>
-          <a:p>
-            <a:pPr indent="0" marL="0">
-              <a:buNone/>
-            </a:pPr>
-            <a:r>
-              <a:rPr lang="en-US" sz="1200" b="1" dirty="0">
-                <a:solidFill>
-                  <a:srgbClr val="D9820A"/>
-                </a:solidFill>
-                <a:latin typeface="Montserrat" pitchFamily="34" charset="0"/>
-                <a:ea typeface="Montserrat" pitchFamily="34" charset="-122"/>
-                <a:cs typeface="Montserrat" pitchFamily="34" charset="-120"/>
-              </a:rPr>
-              <a:t>2</a:t>
-            </a:r>
-            <a:endParaRPr lang="en-US" sz="1200" dirty="0"/>
-          </a:p>
-        </p:txBody>
-      </p:sp>
-      <p:sp>
-        <p:nvSpPr>
-          <p:cNvPr id="17" name="Text 15"/>
-          <p:cNvSpPr/>
-          <p:nvPr/>
-        </p:nvSpPr>
-        <p:spPr>
-          <a:xfrm>
-            <a:off x="3614852" y="2377440"/>
-            <a:ext cx="2170100" cy="365760"/>
-          </a:xfrm>
-          <a:prstGeom prst="rect">
-            <a:avLst/>
-          </a:prstGeom>
-          <a:noFill/>
-          <a:ln/>
-        </p:spPr>
-        <p:txBody>
-          <a:bodyPr wrap="square" rtlCol="0" anchor="t"/>
-          <a:lstStyle/>
-          <a:p>
-            <a:pPr indent="0" marL="0">
-              <a:buNone/>
-            </a:pPr>
-            <a:r>
-              <a:rPr lang="en-US" sz="1050" b="1" dirty="0">
-                <a:solidFill>
-                  <a:srgbClr val="0F1B33"/>
-                </a:solidFill>
-                <a:latin typeface="Inter" pitchFamily="34" charset="0"/>
-                <a:ea typeface="Inter" pitchFamily="34" charset="-122"/>
-                <a:cs typeface="Inter" pitchFamily="34" charset="-120"/>
-              </a:rPr>
-              <a:t>Pide la herramienta</a:t>
-            </a:r>
-            <a:endParaRPr lang="en-US" sz="1050" dirty="0"/>
-          </a:p>
-        </p:txBody>
-      </p:sp>
-      <p:sp>
-        <p:nvSpPr>
-          <p:cNvPr id="18" name="Text 16"/>
-          <p:cNvSpPr/>
-          <p:nvPr/>
-        </p:nvSpPr>
-        <p:spPr>
-          <a:xfrm>
-            <a:off x="5912968" y="2011680"/>
-            <a:ext cx="365760" cy="749808"/>
-          </a:xfrm>
-          <a:prstGeom prst="rect">
-            <a:avLst/>
-          </a:prstGeom>
-          <a:noFill/>
-          <a:ln/>
-        </p:spPr>
-        <p:txBody>
-          <a:bodyPr wrap="square" rtlCol="0" anchor="ctr"/>
-          <a:lstStyle/>
-          <a:p>
-            <a:pPr algn="ctr" indent="0" marL="0">
-              <a:buNone/>
-            </a:pPr>
-            <a:r>
-              <a:rPr lang="en-US" sz="1800" b="1" dirty="0">
-                <a:solidFill>
-                  <a:srgbClr val="1E9BD7"/>
-                </a:solidFill>
-                <a:latin typeface="Montserrat" pitchFamily="34" charset="0"/>
-                <a:ea typeface="Montserrat" pitchFamily="34" charset="-122"/>
-                <a:cs typeface="Montserrat" pitchFamily="34" charset="-120"/>
-              </a:rPr>
-              <a:t>→</a:t>
-            </a:r>
-            <a:endParaRPr lang="en-US" sz="1800" dirty="0"/>
-          </a:p>
-        </p:txBody>
-      </p:sp>
-      <p:sp>
-        <p:nvSpPr>
-          <p:cNvPr id="19" name="Shape 17"/>
-          <p:cNvSpPr/>
-          <p:nvPr/>
-        </p:nvSpPr>
-        <p:spPr>
-          <a:xfrm>
-            <a:off x="6278728" y="2011680"/>
-            <a:ext cx="2444420" cy="749808"/>
-          </a:xfrm>
-          <a:prstGeom prst="roundRect">
-            <a:avLst>
-              <a:gd name="adj" fmla="val 7317"/>
-            </a:avLst>
-          </a:prstGeom>
-          <a:solidFill>
-            <a:srgbClr val="FFFFFF"/>
-          </a:solidFill>
-          <a:ln w="12700">
-            <a:solidFill>
-              <a:srgbClr val="DFE6F0"/>
-            </a:solidFill>
-            <a:prstDash val="solid"/>
-          </a:ln>
-        </p:spPr>
-      </p:sp>
-      <p:sp>
-        <p:nvSpPr>
-          <p:cNvPr id="20" name="Shape 18"/>
-          <p:cNvSpPr/>
-          <p:nvPr/>
-        </p:nvSpPr>
-        <p:spPr>
-          <a:xfrm>
-            <a:off x="6278728" y="2011680"/>
-            <a:ext cx="2444420" cy="54864"/>
-          </a:xfrm>
-          <a:prstGeom prst="roundRect">
-            <a:avLst>
-              <a:gd name="adj" fmla="val 50000"/>
-            </a:avLst>
-          </a:prstGeom>
-          <a:solidFill>
-            <a:srgbClr val="1E9BD7"/>
-          </a:solidFill>
-          <a:ln w="12700">
-            <a:solidFill>
-              <a:srgbClr val="333333"/>
-            </a:solidFill>
-            <a:prstDash val="solid"/>
-          </a:ln>
-        </p:spPr>
-      </p:sp>
-      <p:sp>
-        <p:nvSpPr>
-          <p:cNvPr id="21" name="Text 19"/>
-          <p:cNvSpPr/>
-          <p:nvPr/>
-        </p:nvSpPr>
-        <p:spPr>
-          <a:xfrm>
-            <a:off x="6425032" y="2093976"/>
-            <a:ext cx="365760" cy="274320"/>
-          </a:xfrm>
-          <a:prstGeom prst="rect">
-            <a:avLst/>
-          </a:prstGeom>
-          <a:noFill/>
-          <a:ln/>
-        </p:spPr>
-        <p:txBody>
-          <a:bodyPr wrap="square" rtlCol="0" anchor="ctr"/>
-          <a:lstStyle/>
-          <a:p>
-            <a:pPr indent="0" marL="0">
-              <a:buNone/>
-            </a:pPr>
-            <a:r>
-              <a:rPr lang="en-US" sz="1200" b="1" dirty="0">
-                <a:solidFill>
-                  <a:srgbClr val="1E9BD7"/>
-                </a:solidFill>
-                <a:latin typeface="Montserrat" pitchFamily="34" charset="0"/>
-                <a:ea typeface="Montserrat" pitchFamily="34" charset="-122"/>
-                <a:cs typeface="Montserrat" pitchFamily="34" charset="-120"/>
-              </a:rPr>
-              <a:t>3</a:t>
-            </a:r>
-            <a:endParaRPr lang="en-US" sz="1200" dirty="0"/>
-          </a:p>
-        </p:txBody>
-      </p:sp>
-      <p:sp>
-        <p:nvSpPr>
-          <p:cNvPr id="22" name="Text 20"/>
-          <p:cNvSpPr/>
-          <p:nvPr/>
-        </p:nvSpPr>
-        <p:spPr>
-          <a:xfrm>
-            <a:off x="6425032" y="2377440"/>
-            <a:ext cx="2170100" cy="365760"/>
-          </a:xfrm>
-          <a:prstGeom prst="rect">
-            <a:avLst/>
-          </a:prstGeom>
-          <a:noFill/>
-          <a:ln/>
-        </p:spPr>
-        <p:txBody>
-          <a:bodyPr wrap="square" rtlCol="0" anchor="t"/>
-          <a:lstStyle/>
-          <a:p>
-            <a:pPr indent="0" marL="0">
-              <a:buNone/>
-            </a:pPr>
-            <a:r>
-              <a:rPr lang="en-US" sz="1050" b="1" dirty="0">
-                <a:solidFill>
-                  <a:srgbClr val="0F1B33"/>
-                </a:solidFill>
-                <a:latin typeface="Inter" pitchFamily="34" charset="0"/>
-                <a:ea typeface="Inter" pitchFamily="34" charset="-122"/>
-                <a:cs typeface="Inter" pitchFamily="34" charset="-120"/>
-              </a:rPr>
-              <a:t>Tu código consulta</a:t>
-            </a:r>
-            <a:endParaRPr lang="en-US" sz="1050" dirty="0"/>
-          </a:p>
-        </p:txBody>
-      </p:sp>
-      <p:sp>
-        <p:nvSpPr>
-          <p:cNvPr id="23" name="Text 21"/>
-          <p:cNvSpPr/>
-          <p:nvPr/>
-        </p:nvSpPr>
-        <p:spPr>
-          <a:xfrm>
-            <a:off x="8723147" y="2011680"/>
-            <a:ext cx="365760" cy="749808"/>
-          </a:xfrm>
-          <a:prstGeom prst="rect">
-            <a:avLst/>
-          </a:prstGeom>
-          <a:noFill/>
-          <a:ln/>
-        </p:spPr>
-        <p:txBody>
-          <a:bodyPr wrap="square" rtlCol="0" anchor="ctr"/>
-          <a:lstStyle/>
-          <a:p>
-            <a:pPr algn="ctr" indent="0" marL="0">
-              <a:buNone/>
-            </a:pPr>
-            <a:r>
-              <a:rPr lang="en-US" sz="1800" b="1" dirty="0">
-                <a:solidFill>
-                  <a:srgbClr val="1E9BD7"/>
-                </a:solidFill>
-                <a:latin typeface="Montserrat" pitchFamily="34" charset="0"/>
-                <a:ea typeface="Montserrat" pitchFamily="34" charset="-122"/>
-                <a:cs typeface="Montserrat" pitchFamily="34" charset="-120"/>
-              </a:rPr>
-              <a:t>→</a:t>
-            </a:r>
-            <a:endParaRPr lang="en-US" sz="1800" dirty="0"/>
-          </a:p>
-        </p:txBody>
-      </p:sp>
-      <p:sp>
-        <p:nvSpPr>
-          <p:cNvPr id="24" name="Shape 22"/>
-          <p:cNvSpPr/>
-          <p:nvPr/>
-        </p:nvSpPr>
-        <p:spPr>
-          <a:xfrm>
-            <a:off x="9088907" y="2011680"/>
-            <a:ext cx="2444420" cy="749808"/>
-          </a:xfrm>
-          <a:prstGeom prst="roundRect">
-            <a:avLst>
-              <a:gd name="adj" fmla="val 7317"/>
-            </a:avLst>
-          </a:prstGeom>
-          <a:solidFill>
-            <a:srgbClr val="FFFFFF"/>
-          </a:solidFill>
-          <a:ln w="12700">
-            <a:solidFill>
-              <a:srgbClr val="DFE6F0"/>
-            </a:solidFill>
-            <a:prstDash val="solid"/>
-          </a:ln>
-        </p:spPr>
-      </p:sp>
-      <p:sp>
-        <p:nvSpPr>
-          <p:cNvPr id="25" name="Shape 23"/>
-          <p:cNvSpPr/>
-          <p:nvPr/>
-        </p:nvSpPr>
-        <p:spPr>
-          <a:xfrm>
-            <a:off x="9088907" y="2011680"/>
-            <a:ext cx="2444420" cy="54864"/>
-          </a:xfrm>
-          <a:prstGeom prst="roundRect">
-            <a:avLst>
-              <a:gd name="adj" fmla="val 50000"/>
-            </a:avLst>
-          </a:prstGeom>
-          <a:solidFill>
-            <a:srgbClr val="4FA82F"/>
-          </a:solidFill>
-          <a:ln w="12700">
-            <a:solidFill>
-              <a:srgbClr val="333333"/>
-            </a:solidFill>
-            <a:prstDash val="solid"/>
-          </a:ln>
-        </p:spPr>
-      </p:sp>
-      <p:sp>
-        <p:nvSpPr>
-          <p:cNvPr id="26" name="Text 24"/>
-          <p:cNvSpPr/>
-          <p:nvPr/>
-        </p:nvSpPr>
-        <p:spPr>
-          <a:xfrm>
-            <a:off x="9235211" y="2093976"/>
-            <a:ext cx="365760" cy="274320"/>
-          </a:xfrm>
-          <a:prstGeom prst="rect">
-            <a:avLst/>
-          </a:prstGeom>
-          <a:noFill/>
-          <a:ln/>
-        </p:spPr>
-        <p:txBody>
-          <a:bodyPr wrap="square" rtlCol="0" anchor="ctr"/>
-          <a:lstStyle/>
-          <a:p>
-            <a:pPr indent="0" marL="0">
-              <a:buNone/>
-            </a:pPr>
-            <a:r>
-              <a:rPr lang="en-US" sz="1200" b="1" dirty="0">
-                <a:solidFill>
-                  <a:srgbClr val="4FA82F"/>
-                </a:solidFill>
-                <a:latin typeface="Montserrat" pitchFamily="34" charset="0"/>
-                <a:ea typeface="Montserrat" pitchFamily="34" charset="-122"/>
-                <a:cs typeface="Montserrat" pitchFamily="34" charset="-120"/>
-              </a:rPr>
-              <a:t>4</a:t>
-            </a:r>
-            <a:endParaRPr lang="en-US" sz="1200" dirty="0"/>
-          </a:p>
-        </p:txBody>
-      </p:sp>
-      <p:sp>
-        <p:nvSpPr>
-          <p:cNvPr id="27" name="Text 25"/>
-          <p:cNvSpPr/>
-          <p:nvPr/>
-        </p:nvSpPr>
-        <p:spPr>
-          <a:xfrm>
-            <a:off x="9235211" y="2377440"/>
-            <a:ext cx="2170100" cy="365760"/>
-          </a:xfrm>
-          <a:prstGeom prst="rect">
-            <a:avLst/>
-          </a:prstGeom>
-          <a:noFill/>
-          <a:ln/>
-        </p:spPr>
-        <p:txBody>
-          <a:bodyPr wrap="square" rtlCol="0" anchor="t"/>
-          <a:lstStyle/>
-          <a:p>
-            <a:pPr indent="0" marL="0">
-              <a:buNone/>
-            </a:pPr>
-            <a:r>
-              <a:rPr lang="en-US" sz="1050" b="1" dirty="0">
-                <a:solidFill>
-                  <a:srgbClr val="0F1B33"/>
-                </a:solidFill>
-                <a:latin typeface="Inter" pitchFamily="34" charset="0"/>
-                <a:ea typeface="Inter" pitchFamily="34" charset="-122"/>
-                <a:cs typeface="Inter" pitchFamily="34" charset="-120"/>
-              </a:rPr>
-              <a:t>Responde con el dato</a:t>
-            </a:r>
-            <a:endParaRPr lang="en-US" sz="1050" dirty="0"/>
-          </a:p>
-        </p:txBody>
-      </p:sp>
       <p:pic>
         <p:nvPicPr>
-          <p:cNvPr id="28" name="Image 0" descr="/home/jamaya/PiuraAI/fundamentos-agentes/assets/img/term-messages.png">    </p:cNvPr>
+          <p:cNvPr id="9" name="Image 0" descr="/home/jamaya/PiuraAI/fundamentos-agentes/assets/img/diagram-turn.png">    </p:cNvPr>
           <p:cNvPicPr>
             <a:picLocks noChangeAspect="1"/>
           </p:cNvPicPr>
@@ -5494,8 +4849,8 @@
         </p:blipFill>
         <p:spPr>
           <a:xfrm>
-            <a:off x="3094993" y="2926080"/>
-            <a:ext cx="6001710" cy="2606040"/>
+            <a:off x="1137520" y="1965960"/>
+            <a:ext cx="9916654" cy="3977640"/>
           </a:xfrm>
           <a:prstGeom prst="rect">
             <a:avLst/>
@@ -5504,13 +4859,13 @@
       </p:pic>
       <p:sp>
         <p:nvSpPr>
-          <p:cNvPr id="29" name="Text 26"/>
-          <p:cNvSpPr/>
-          <p:nvPr/>
-        </p:nvSpPr>
-        <p:spPr>
-          <a:xfrm>
-            <a:off x="658368" y="5715000"/>
+          <p:cNvPr id="10" name="Text 7"/>
+          <p:cNvSpPr/>
+          <p:nvPr/>
+        </p:nvSpPr>
+        <p:spPr>
+          <a:xfrm>
+            <a:off x="658368" y="6035040"/>
             <a:ext cx="10874959" cy="457200"/>
           </a:xfrm>
           <a:prstGeom prst="rect">
@@ -12636,7 +11991,7 @@
                 <a:ea typeface="Inter" pitchFamily="34" charset="-122"/>
                 <a:cs typeface="Inter" pitchFamily="34" charset="-120"/>
               </a:rPr>
-              <a:t>Hoy no hablo de mis proyectos: hablo de la base, para que entiendan qué hay debajo de la palabra 'agente'.</a:t>
+              <a:t>Tres años construyendo agentes conversacionales.</a:t>
             </a:r>
             <a:endParaRPr lang="en-US" sz="1792" dirty="0"/>
           </a:p>
@@ -13703,555 +13058,38 @@
           </a:p>
         </p:txBody>
       </p:sp>
-      <p:sp>
-        <p:nvSpPr>
-          <p:cNvPr id="8" name="Shape 6"/>
-          <p:cNvSpPr/>
-          <p:nvPr/>
-        </p:nvSpPr>
-        <p:spPr>
-          <a:xfrm>
-            <a:off x="658368" y="2286000"/>
-            <a:ext cx="5327752" cy="1188720"/>
-          </a:xfrm>
-          <a:prstGeom prst="roundRect">
-            <a:avLst>
-              <a:gd name="adj" fmla="val 4615"/>
-            </a:avLst>
-          </a:prstGeom>
-          <a:solidFill>
-            <a:srgbClr val="FFFFFF"/>
-          </a:solidFill>
-          <a:ln w="12700">
-            <a:solidFill>
-              <a:srgbClr val="DFE6F0"/>
-            </a:solidFill>
-            <a:prstDash val="solid"/>
-          </a:ln>
-        </p:spPr>
-      </p:sp>
-      <p:sp>
-        <p:nvSpPr>
-          <p:cNvPr id="9" name="Shape 7"/>
-          <p:cNvSpPr/>
-          <p:nvPr/>
-        </p:nvSpPr>
-        <p:spPr>
-          <a:xfrm>
-            <a:off x="658368" y="2286000"/>
-            <a:ext cx="73152" cy="1188720"/>
-          </a:xfrm>
-          <a:prstGeom prst="roundRect">
-            <a:avLst>
-              <a:gd name="adj" fmla="val 50000"/>
-            </a:avLst>
-          </a:prstGeom>
-          <a:solidFill>
-            <a:srgbClr val="1E9BD7"/>
-          </a:solidFill>
-          <a:ln w="12700">
-            <a:solidFill>
-              <a:srgbClr val="333333"/>
-            </a:solidFill>
-            <a:prstDash val="solid"/>
-          </a:ln>
-        </p:spPr>
-      </p:sp>
-      <p:sp>
-        <p:nvSpPr>
-          <p:cNvPr id="10" name="Text 8"/>
-          <p:cNvSpPr/>
-          <p:nvPr/>
-        </p:nvSpPr>
-        <p:spPr>
-          <a:xfrm>
-            <a:off x="932688" y="2432304"/>
-            <a:ext cx="4870552" cy="365760"/>
-          </a:xfrm>
-          <a:prstGeom prst="rect">
-            <a:avLst/>
-          </a:prstGeom>
-          <a:noFill/>
-          <a:ln/>
-        </p:spPr>
-        <p:txBody>
-          <a:bodyPr wrap="square" rtlCol="0" anchor="ctr"/>
-          <a:lstStyle/>
-          <a:p>
-            <a:pPr indent="0" marL="0">
-              <a:buNone/>
-            </a:pPr>
-            <a:r>
-              <a:rPr lang="en-US" sz="1600" b="1" dirty="0">
-                <a:solidFill>
-                  <a:srgbClr val="0F1B33"/>
-                </a:solidFill>
-                <a:latin typeface="Montserrat" pitchFamily="34" charset="0"/>
-                <a:ea typeface="Montserrat" pitchFamily="34" charset="-122"/>
-                <a:cs typeface="Montserrat" pitchFamily="34" charset="-120"/>
-              </a:rPr>
-              <a:t>Cuándo bajar</a:t>
-            </a:r>
-            <a:endParaRPr lang="en-US" sz="1600" dirty="0"/>
-          </a:p>
-        </p:txBody>
-      </p:sp>
-      <p:sp>
-        <p:nvSpPr>
-          <p:cNvPr id="11" name="Text 9"/>
-          <p:cNvSpPr/>
-          <p:nvPr/>
-        </p:nvSpPr>
-        <p:spPr>
-          <a:xfrm>
-            <a:off x="932688" y="2816352"/>
-            <a:ext cx="4870552" cy="594360"/>
-          </a:xfrm>
-          <a:prstGeom prst="rect">
-            <a:avLst/>
-          </a:prstGeom>
-          <a:noFill/>
-          <a:ln/>
-        </p:spPr>
-        <p:txBody>
-          <a:bodyPr wrap="square" rtlCol="0" anchor="t"/>
-          <a:lstStyle/>
-          <a:p>
-            <a:pPr indent="0" marL="0">
-              <a:lnSpc>
-                <a:spcPct val="105000"/>
-              </a:lnSpc>
-              <a:buNone/>
-            </a:pPr>
-            <a:r>
-              <a:rPr lang="en-US" sz="1150" dirty="0">
-                <a:solidFill>
-                  <a:srgbClr val="2B3A55"/>
-                </a:solidFill>
-                <a:latin typeface="Inter" pitchFamily="34" charset="0"/>
-                <a:ea typeface="Inter" pitchFamily="34" charset="-122"/>
-                <a:cs typeface="Inter" pitchFamily="34" charset="-120"/>
-              </a:rPr>
-              <a:t>Ramas condicionales, varios agentes, ciclos con reglas propias o interrupciones en puntos exactos.</a:t>
-            </a:r>
-            <a:endParaRPr lang="en-US" sz="1150" dirty="0"/>
-          </a:p>
-        </p:txBody>
-      </p:sp>
-      <p:sp>
-        <p:nvSpPr>
-          <p:cNvPr id="12" name="Shape 10"/>
-          <p:cNvSpPr/>
-          <p:nvPr/>
-        </p:nvSpPr>
-        <p:spPr>
-          <a:xfrm>
-            <a:off x="6205576" y="2286000"/>
-            <a:ext cx="5327752" cy="1188720"/>
-          </a:xfrm>
-          <a:prstGeom prst="roundRect">
-            <a:avLst>
-              <a:gd name="adj" fmla="val 4615"/>
-            </a:avLst>
-          </a:prstGeom>
-          <a:solidFill>
-            <a:srgbClr val="FFFFFF"/>
-          </a:solidFill>
-          <a:ln w="12700">
-            <a:solidFill>
-              <a:srgbClr val="DFE6F0"/>
-            </a:solidFill>
-            <a:prstDash val="solid"/>
-          </a:ln>
-        </p:spPr>
-      </p:sp>
-      <p:sp>
-        <p:nvSpPr>
-          <p:cNvPr id="13" name="Shape 11"/>
-          <p:cNvSpPr/>
-          <p:nvPr/>
-        </p:nvSpPr>
-        <p:spPr>
-          <a:xfrm>
-            <a:off x="6205576" y="2286000"/>
-            <a:ext cx="73152" cy="1188720"/>
-          </a:xfrm>
-          <a:prstGeom prst="roundRect">
-            <a:avLst>
-              <a:gd name="adj" fmla="val 50000"/>
-            </a:avLst>
-          </a:prstGeom>
-          <a:solidFill>
-            <a:srgbClr val="12245B"/>
-          </a:solidFill>
-          <a:ln w="12700">
-            <a:solidFill>
-              <a:srgbClr val="333333"/>
-            </a:solidFill>
-            <a:prstDash val="solid"/>
-          </a:ln>
-        </p:spPr>
-      </p:sp>
-      <p:sp>
-        <p:nvSpPr>
-          <p:cNvPr id="14" name="Text 12"/>
-          <p:cNvSpPr/>
-          <p:nvPr/>
-        </p:nvSpPr>
-        <p:spPr>
-          <a:xfrm>
-            <a:off x="6479896" y="2432304"/>
-            <a:ext cx="4870552" cy="365760"/>
-          </a:xfrm>
-          <a:prstGeom prst="rect">
-            <a:avLst/>
-          </a:prstGeom>
-          <a:noFill/>
-          <a:ln/>
-        </p:spPr>
-        <p:txBody>
-          <a:bodyPr wrap="square" rtlCol="0" anchor="ctr"/>
-          <a:lstStyle/>
-          <a:p>
-            <a:pPr indent="0" marL="0">
-              <a:buNone/>
-            </a:pPr>
-            <a:r>
-              <a:rPr lang="en-US" sz="1600" b="1" dirty="0">
-                <a:solidFill>
-                  <a:srgbClr val="0F1B33"/>
-                </a:solidFill>
-                <a:latin typeface="Montserrat" pitchFamily="34" charset="0"/>
-                <a:ea typeface="Montserrat" pitchFamily="34" charset="-122"/>
-                <a:cs typeface="Montserrat" pitchFamily="34" charset="-120"/>
-              </a:rPr>
-              <a:t>Grafo con estado</a:t>
-            </a:r>
-            <a:endParaRPr lang="en-US" sz="1600" dirty="0"/>
-          </a:p>
-        </p:txBody>
-      </p:sp>
-      <p:sp>
-        <p:nvSpPr>
-          <p:cNvPr id="15" name="Text 13"/>
-          <p:cNvSpPr/>
-          <p:nvPr/>
-        </p:nvSpPr>
-        <p:spPr>
-          <a:xfrm>
-            <a:off x="6479896" y="2816352"/>
-            <a:ext cx="4870552" cy="594360"/>
-          </a:xfrm>
-          <a:prstGeom prst="rect">
-            <a:avLst/>
-          </a:prstGeom>
-          <a:noFill/>
-          <a:ln/>
-        </p:spPr>
-        <p:txBody>
-          <a:bodyPr wrap="square" rtlCol="0" anchor="t"/>
-          <a:lstStyle/>
-          <a:p>
-            <a:pPr indent="0" marL="0">
-              <a:lnSpc>
-                <a:spcPct val="105000"/>
-              </a:lnSpc>
-              <a:buNone/>
-            </a:pPr>
-            <a:r>
-              <a:rPr lang="en-US" sz="1150" dirty="0">
-                <a:solidFill>
-                  <a:srgbClr val="2B3A55"/>
-                </a:solidFill>
-                <a:latin typeface="Inter" pitchFamily="34" charset="0"/>
-                <a:ea typeface="Inter" pitchFamily="34" charset="-122"/>
-                <a:cs typeface="Inter" pitchFamily="34" charset="-120"/>
-              </a:rPr>
-              <a:t>Estado tipado, nodos (pasos) y aristas que deciden a dónde ir según el estado.</a:t>
-            </a:r>
-            <a:endParaRPr lang="en-US" sz="1150" dirty="0"/>
-          </a:p>
-        </p:txBody>
-      </p:sp>
-      <p:sp>
-        <p:nvSpPr>
-          <p:cNvPr id="16" name="Shape 14"/>
-          <p:cNvSpPr/>
-          <p:nvPr/>
-        </p:nvSpPr>
-        <p:spPr>
-          <a:xfrm>
-            <a:off x="658368" y="3611880"/>
-            <a:ext cx="5327752" cy="1188720"/>
-          </a:xfrm>
-          <a:prstGeom prst="roundRect">
-            <a:avLst>
-              <a:gd name="adj" fmla="val 4615"/>
-            </a:avLst>
-          </a:prstGeom>
-          <a:solidFill>
-            <a:srgbClr val="FFFFFF"/>
-          </a:solidFill>
-          <a:ln w="12700">
-            <a:solidFill>
-              <a:srgbClr val="DFE6F0"/>
-            </a:solidFill>
-            <a:prstDash val="solid"/>
-          </a:ln>
-        </p:spPr>
-      </p:sp>
-      <p:sp>
-        <p:nvSpPr>
-          <p:cNvPr id="17" name="Shape 15"/>
-          <p:cNvSpPr/>
-          <p:nvPr/>
-        </p:nvSpPr>
-        <p:spPr>
-          <a:xfrm>
-            <a:off x="658368" y="3611880"/>
-            <a:ext cx="73152" cy="1188720"/>
-          </a:xfrm>
-          <a:prstGeom prst="roundRect">
-            <a:avLst>
-              <a:gd name="adj" fmla="val 50000"/>
-            </a:avLst>
-          </a:prstGeom>
-          <a:solidFill>
-            <a:srgbClr val="D9820A"/>
-          </a:solidFill>
-          <a:ln w="12700">
-            <a:solidFill>
-              <a:srgbClr val="333333"/>
-            </a:solidFill>
-            <a:prstDash val="solid"/>
-          </a:ln>
-        </p:spPr>
-      </p:sp>
-      <p:sp>
-        <p:nvSpPr>
-          <p:cNvPr id="18" name="Text 16"/>
-          <p:cNvSpPr/>
-          <p:nvPr/>
-        </p:nvSpPr>
-        <p:spPr>
-          <a:xfrm>
-            <a:off x="932688" y="3758184"/>
-            <a:ext cx="4870552" cy="365760"/>
-          </a:xfrm>
-          <a:prstGeom prst="rect">
-            <a:avLst/>
-          </a:prstGeom>
-          <a:noFill/>
-          <a:ln/>
-        </p:spPr>
-        <p:txBody>
-          <a:bodyPr wrap="square" rtlCol="0" anchor="ctr"/>
-          <a:lstStyle/>
-          <a:p>
-            <a:pPr indent="0" marL="0">
-              <a:buNone/>
-            </a:pPr>
-            <a:r>
-              <a:rPr lang="en-US" sz="1600" b="1" dirty="0">
-                <a:solidFill>
-                  <a:srgbClr val="0F1B33"/>
-                </a:solidFill>
-                <a:latin typeface="Montserrat" pitchFamily="34" charset="0"/>
-                <a:ea typeface="Montserrat" pitchFamily="34" charset="-122"/>
-                <a:cs typeface="Montserrat" pitchFamily="34" charset="-120"/>
-              </a:rPr>
-              <a:t>Memoria</a:t>
-            </a:r>
-            <a:endParaRPr lang="en-US" sz="1600" dirty="0"/>
-          </a:p>
-        </p:txBody>
-      </p:sp>
-      <p:sp>
-        <p:nvSpPr>
-          <p:cNvPr id="19" name="Text 17"/>
-          <p:cNvSpPr/>
-          <p:nvPr/>
-        </p:nvSpPr>
-        <p:spPr>
-          <a:xfrm>
-            <a:off x="932688" y="4142232"/>
-            <a:ext cx="4870552" cy="594360"/>
-          </a:xfrm>
-          <a:prstGeom prst="rect">
-            <a:avLst/>
-          </a:prstGeom>
-          <a:noFill/>
-          <a:ln/>
-        </p:spPr>
-        <p:txBody>
-          <a:bodyPr wrap="square" rtlCol="0" anchor="t"/>
-          <a:lstStyle/>
-          <a:p>
-            <a:pPr indent="0" marL="0">
-              <a:lnSpc>
-                <a:spcPct val="105000"/>
-              </a:lnSpc>
-              <a:buNone/>
-            </a:pPr>
-            <a:r>
-              <a:rPr lang="en-US" sz="1150" dirty="0">
-                <a:solidFill>
-                  <a:srgbClr val="2B3A55"/>
-                </a:solidFill>
-                <a:latin typeface="Inter" pitchFamily="34" charset="0"/>
-                <a:ea typeface="Inter" pitchFamily="34" charset="-122"/>
-                <a:cs typeface="Inter" pitchFamily="34" charset="-120"/>
-              </a:rPr>
-              <a:t>Un checkpointer guarda el hilo; el store, lo que cruza conversaciones. El thread_id separa charlas.</a:t>
-            </a:r>
-            <a:endParaRPr lang="en-US" sz="1150" dirty="0"/>
-          </a:p>
-        </p:txBody>
-      </p:sp>
-      <p:sp>
-        <p:nvSpPr>
-          <p:cNvPr id="20" name="Shape 18"/>
-          <p:cNvSpPr/>
-          <p:nvPr/>
-        </p:nvSpPr>
-        <p:spPr>
-          <a:xfrm>
-            <a:off x="6205576" y="3611880"/>
-            <a:ext cx="5327752" cy="1188720"/>
-          </a:xfrm>
-          <a:prstGeom prst="roundRect">
-            <a:avLst>
-              <a:gd name="adj" fmla="val 4615"/>
-            </a:avLst>
-          </a:prstGeom>
-          <a:solidFill>
-            <a:srgbClr val="FFFFFF"/>
-          </a:solidFill>
-          <a:ln w="12700">
-            <a:solidFill>
-              <a:srgbClr val="DFE6F0"/>
-            </a:solidFill>
-            <a:prstDash val="solid"/>
-          </a:ln>
-        </p:spPr>
-      </p:sp>
-      <p:sp>
-        <p:nvSpPr>
-          <p:cNvPr id="21" name="Shape 19"/>
-          <p:cNvSpPr/>
-          <p:nvPr/>
-        </p:nvSpPr>
-        <p:spPr>
-          <a:xfrm>
-            <a:off x="6205576" y="3611880"/>
-            <a:ext cx="73152" cy="1188720"/>
-          </a:xfrm>
-          <a:prstGeom prst="roundRect">
-            <a:avLst>
-              <a:gd name="adj" fmla="val 50000"/>
-            </a:avLst>
-          </a:prstGeom>
-          <a:solidFill>
-            <a:srgbClr val="4FA82F"/>
-          </a:solidFill>
-          <a:ln w="12700">
-            <a:solidFill>
-              <a:srgbClr val="333333"/>
-            </a:solidFill>
-            <a:prstDash val="solid"/>
-          </a:ln>
-        </p:spPr>
-      </p:sp>
-      <p:sp>
-        <p:nvSpPr>
-          <p:cNvPr id="22" name="Text 20"/>
-          <p:cNvSpPr/>
-          <p:nvPr/>
-        </p:nvSpPr>
-        <p:spPr>
-          <a:xfrm>
-            <a:off x="6479896" y="3758184"/>
-            <a:ext cx="4870552" cy="365760"/>
-          </a:xfrm>
-          <a:prstGeom prst="rect">
-            <a:avLst/>
-          </a:prstGeom>
-          <a:noFill/>
-          <a:ln/>
-        </p:spPr>
-        <p:txBody>
-          <a:bodyPr wrap="square" rtlCol="0" anchor="ctr"/>
-          <a:lstStyle/>
-          <a:p>
-            <a:pPr indent="0" marL="0">
-              <a:buNone/>
-            </a:pPr>
-            <a:r>
-              <a:rPr lang="en-US" sz="1600" b="1" dirty="0">
-                <a:solidFill>
-                  <a:srgbClr val="0F1B33"/>
-                </a:solidFill>
-                <a:latin typeface="Montserrat" pitchFamily="34" charset="0"/>
-                <a:ea typeface="Montserrat" pitchFamily="34" charset="-122"/>
-                <a:cs typeface="Montserrat" pitchFamily="34" charset="-120"/>
-              </a:rPr>
-              <a:t>Humano en el bucle</a:t>
-            </a:r>
-            <a:endParaRPr lang="en-US" sz="1600" dirty="0"/>
-          </a:p>
-        </p:txBody>
-      </p:sp>
-      <p:sp>
-        <p:nvSpPr>
-          <p:cNvPr id="23" name="Text 21"/>
-          <p:cNvSpPr/>
-          <p:nvPr/>
-        </p:nvSpPr>
-        <p:spPr>
-          <a:xfrm>
-            <a:off x="6479896" y="4142232"/>
-            <a:ext cx="4870552" cy="594360"/>
-          </a:xfrm>
-          <a:prstGeom prst="rect">
-            <a:avLst/>
-          </a:prstGeom>
-          <a:noFill/>
-          <a:ln/>
-        </p:spPr>
-        <p:txBody>
-          <a:bodyPr wrap="square" rtlCol="0" anchor="t"/>
-          <a:lstStyle/>
-          <a:p>
-            <a:pPr indent="0" marL="0">
-              <a:lnSpc>
-                <a:spcPct val="105000"/>
-              </a:lnSpc>
-              <a:buNone/>
-            </a:pPr>
-            <a:r>
-              <a:rPr lang="en-US" sz="1150" dirty="0">
-                <a:solidFill>
-                  <a:srgbClr val="2B3A55"/>
-                </a:solidFill>
-                <a:latin typeface="Inter" pitchFamily="34" charset="0"/>
-                <a:ea typeface="Inter" pitchFamily="34" charset="-122"/>
-                <a:cs typeface="Inter" pitchFamily="34" charset="-120"/>
-              </a:rPr>
-              <a:t>El grafo se pausa antes de una tool sensible; apruebas o editas y reanuda con resume.</a:t>
-            </a:r>
-            <a:endParaRPr lang="en-US" sz="1150" dirty="0"/>
-          </a:p>
-        </p:txBody>
-      </p:sp>
-      <p:sp>
-        <p:nvSpPr>
-          <p:cNvPr id="24" name="Text 22"/>
-          <p:cNvSpPr/>
-          <p:nvPr/>
-        </p:nvSpPr>
-        <p:spPr>
-          <a:xfrm>
-            <a:off x="658368" y="5074920"/>
+      <p:pic>
+        <p:nvPicPr>
+          <p:cNvPr id="8" name="Image 0" descr="/home/jamaya/PiuraAI/fundamentos-agentes/assets/img/diagram-langgraph.png">    </p:cNvPr>
+          <p:cNvPicPr>
+            <a:picLocks noChangeAspect="1"/>
+          </p:cNvPicPr>
+          <p:nvPr/>
+        </p:nvPicPr>
+        <p:blipFill>
+          <a:blip r:embed="rId1"/>
+          <a:srcRect l="0" r="0" t="0" b="0"/>
+          <a:stretch/>
+        </p:blipFill>
+        <p:spPr>
+          <a:xfrm>
+            <a:off x="1080528" y="1874520"/>
+            <a:ext cx="10030639" cy="4023360"/>
+          </a:xfrm>
+          <a:prstGeom prst="rect">
+            <a:avLst/>
+          </a:prstGeom>
+        </p:spPr>
+      </p:pic>
+      <p:sp>
+        <p:nvSpPr>
+          <p:cNvPr id="9" name="Text 6"/>
+          <p:cNvSpPr/>
+          <p:nvPr/>
+        </p:nvSpPr>
+        <p:spPr>
+          <a:xfrm>
+            <a:off x="658368" y="5989320"/>
             <a:ext cx="10874959" cy="548640"/>
           </a:xfrm>
           <a:prstGeom prst="rect">
@@ -14526,665 +13364,43 @@
           </a:p>
         </p:txBody>
       </p:sp>
-      <p:sp>
-        <p:nvSpPr>
-          <p:cNvPr id="8" name="Shape 6"/>
-          <p:cNvSpPr/>
-          <p:nvPr/>
-        </p:nvSpPr>
-        <p:spPr>
-          <a:xfrm>
-            <a:off x="658368" y="2286000"/>
-            <a:ext cx="2375840" cy="1463040"/>
+      <p:pic>
+        <p:nvPicPr>
+          <p:cNvPr id="8" name="Image 0" descr="/home/jamaya/PiuraAI/fundamentos-agentes/assets/img/diagram-rag.png">    </p:cNvPr>
+          <p:cNvPicPr>
+            <a:picLocks noChangeAspect="1"/>
+          </p:cNvPicPr>
+          <p:nvPr/>
+        </p:nvPicPr>
+        <p:blipFill>
+          <a:blip r:embed="rId1"/>
+          <a:srcRect l="0" r="0" t="0" b="0"/>
+          <a:stretch/>
+        </p:blipFill>
+        <p:spPr>
+          <a:xfrm>
+            <a:off x="1172192" y="1737360"/>
+            <a:ext cx="9847311" cy="3200400"/>
+          </a:xfrm>
+          <a:prstGeom prst="rect">
+            <a:avLst/>
+          </a:prstGeom>
+        </p:spPr>
+      </p:pic>
+      <p:sp>
+        <p:nvSpPr>
+          <p:cNvPr id="9" name="Shape 6"/>
+          <p:cNvSpPr/>
+          <p:nvPr/>
+        </p:nvSpPr>
+        <p:spPr>
+          <a:xfrm>
+            <a:off x="658368" y="5074920"/>
+            <a:ext cx="10874959" cy="1051560"/>
           </a:xfrm>
           <a:prstGeom prst="roundRect">
             <a:avLst>
-              <a:gd name="adj" fmla="val 5000"/>
-            </a:avLst>
-          </a:prstGeom>
-          <a:solidFill>
-            <a:srgbClr val="FFFFFF"/>
-          </a:solidFill>
-          <a:ln w="12700">
-            <a:solidFill>
-              <a:srgbClr val="DFE6F0"/>
-            </a:solidFill>
-            <a:prstDash val="solid"/>
-          </a:ln>
-        </p:spPr>
-      </p:sp>
-      <p:sp>
-        <p:nvSpPr>
-          <p:cNvPr id="9" name="Shape 7"/>
-          <p:cNvSpPr/>
-          <p:nvPr/>
-        </p:nvSpPr>
-        <p:spPr>
-          <a:xfrm>
-            <a:off x="658368" y="2286000"/>
-            <a:ext cx="2375840" cy="64008"/>
-          </a:xfrm>
-          <a:prstGeom prst="roundRect">
-            <a:avLst>
-              <a:gd name="adj" fmla="val 42857"/>
-            </a:avLst>
-          </a:prstGeom>
-          <a:solidFill>
-            <a:srgbClr val="12245B"/>
-          </a:solidFill>
-          <a:ln w="12700">
-            <a:solidFill>
-              <a:srgbClr val="333333"/>
-            </a:solidFill>
-            <a:prstDash val="solid"/>
-          </a:ln>
-        </p:spPr>
-      </p:sp>
-      <p:sp>
-        <p:nvSpPr>
-          <p:cNvPr id="10" name="Text 8"/>
-          <p:cNvSpPr/>
-          <p:nvPr/>
-        </p:nvSpPr>
-        <p:spPr>
-          <a:xfrm>
-            <a:off x="859536" y="2514600"/>
-            <a:ext cx="1973504" cy="502920"/>
-          </a:xfrm>
-          <a:prstGeom prst="rect">
-            <a:avLst/>
-          </a:prstGeom>
-          <a:noFill/>
-          <a:ln/>
-        </p:spPr>
-        <p:txBody>
-          <a:bodyPr wrap="square" rtlCol="0" anchor="t"/>
-          <a:lstStyle/>
-          <a:p>
-            <a:pPr indent="0" marL="0">
-              <a:buNone/>
-            </a:pPr>
-            <a:r>
-              <a:rPr lang="en-US" sz="1450" b="1" dirty="0">
-                <a:solidFill>
-                  <a:srgbClr val="0F1B33"/>
-                </a:solidFill>
-                <a:latin typeface="Montserrat" pitchFamily="34" charset="0"/>
-                <a:ea typeface="Montserrat" pitchFamily="34" charset="-122"/>
-                <a:cs typeface="Montserrat" pitchFamily="34" charset="-120"/>
-              </a:rPr>
-              <a:t>El modelo</a:t>
-            </a:r>
-            <a:endParaRPr lang="en-US" sz="1450" dirty="0"/>
-          </a:p>
-        </p:txBody>
-      </p:sp>
-      <p:sp>
-        <p:nvSpPr>
-          <p:cNvPr id="11" name="Text 9"/>
-          <p:cNvSpPr/>
-          <p:nvPr/>
-        </p:nvSpPr>
-        <p:spPr>
-          <a:xfrm>
-            <a:off x="859536" y="3063240"/>
-            <a:ext cx="1973504" cy="548640"/>
-          </a:xfrm>
-          <a:prstGeom prst="rect">
-            <a:avLst/>
-          </a:prstGeom>
-          <a:noFill/>
-          <a:ln/>
-        </p:spPr>
-        <p:txBody>
-          <a:bodyPr wrap="square" rtlCol="0" anchor="t"/>
-          <a:lstStyle/>
-          <a:p>
-            <a:pPr indent="0" marL="0">
-              <a:buNone/>
-            </a:pPr>
-            <a:r>
-              <a:rPr lang="en-US" sz="1100" dirty="0">
-                <a:solidFill>
-                  <a:srgbClr val="2B3A55"/>
-                </a:solidFill>
-                <a:latin typeface="Inter" pitchFamily="34" charset="0"/>
-                <a:ea typeface="Inter" pitchFamily="34" charset="-122"/>
-                <a:cs typeface="Inter" pitchFamily="34" charset="-120"/>
-              </a:rPr>
-              <a:t>no sabe el dato</a:t>
-            </a:r>
-            <a:endParaRPr lang="en-US" sz="1100" dirty="0"/>
-          </a:p>
-        </p:txBody>
-      </p:sp>
-      <p:sp>
-        <p:nvSpPr>
-          <p:cNvPr id="12" name="Text 10"/>
-          <p:cNvSpPr/>
-          <p:nvPr/>
-        </p:nvSpPr>
-        <p:spPr>
-          <a:xfrm>
-            <a:off x="3034208" y="2286000"/>
-            <a:ext cx="457200" cy="1463040"/>
-          </a:xfrm>
-          <a:prstGeom prst="rect">
-            <a:avLst/>
-          </a:prstGeom>
-          <a:noFill/>
-          <a:ln/>
-        </p:spPr>
-        <p:txBody>
-          <a:bodyPr wrap="square" rtlCol="0" anchor="ctr"/>
-          <a:lstStyle/>
-          <a:p>
-            <a:pPr algn="ctr" indent="0" marL="0">
-              <a:buNone/>
-            </a:pPr>
-            <a:r>
-              <a:rPr lang="en-US" sz="2400" b="1" dirty="0">
-                <a:solidFill>
-                  <a:srgbClr val="1E9BD7"/>
-                </a:solidFill>
-                <a:latin typeface="Montserrat" pitchFamily="34" charset="0"/>
-                <a:ea typeface="Montserrat" pitchFamily="34" charset="-122"/>
-                <a:cs typeface="Montserrat" pitchFamily="34" charset="-120"/>
-              </a:rPr>
-              <a:t>→</a:t>
-            </a:r>
-            <a:endParaRPr lang="en-US" sz="2400" dirty="0"/>
-          </a:p>
-        </p:txBody>
-      </p:sp>
-      <p:sp>
-        <p:nvSpPr>
-          <p:cNvPr id="13" name="Shape 11"/>
-          <p:cNvSpPr/>
-          <p:nvPr/>
-        </p:nvSpPr>
-        <p:spPr>
-          <a:xfrm>
-            <a:off x="3491408" y="2286000"/>
-            <a:ext cx="2375840" cy="1463040"/>
-          </a:xfrm>
-          <a:prstGeom prst="roundRect">
-            <a:avLst>
-              <a:gd name="adj" fmla="val 5000"/>
-            </a:avLst>
-          </a:prstGeom>
-          <a:solidFill>
-            <a:srgbClr val="FFFFFF"/>
-          </a:solidFill>
-          <a:ln w="12700">
-            <a:solidFill>
-              <a:srgbClr val="DFE6F0"/>
-            </a:solidFill>
-            <a:prstDash val="solid"/>
-          </a:ln>
-        </p:spPr>
-      </p:sp>
-      <p:sp>
-        <p:nvSpPr>
-          <p:cNvPr id="14" name="Shape 12"/>
-          <p:cNvSpPr/>
-          <p:nvPr/>
-        </p:nvSpPr>
-        <p:spPr>
-          <a:xfrm>
-            <a:off x="3491408" y="2286000"/>
-            <a:ext cx="2375840" cy="64008"/>
-          </a:xfrm>
-          <a:prstGeom prst="roundRect">
-            <a:avLst>
-              <a:gd name="adj" fmla="val 42857"/>
-            </a:avLst>
-          </a:prstGeom>
-          <a:solidFill>
-            <a:srgbClr val="1E9BD7"/>
-          </a:solidFill>
-          <a:ln w="12700">
-            <a:solidFill>
-              <a:srgbClr val="333333"/>
-            </a:solidFill>
-            <a:prstDash val="solid"/>
-          </a:ln>
-        </p:spPr>
-      </p:sp>
-      <p:sp>
-        <p:nvSpPr>
-          <p:cNvPr id="15" name="Text 13"/>
-          <p:cNvSpPr/>
-          <p:nvPr/>
-        </p:nvSpPr>
-        <p:spPr>
-          <a:xfrm>
-            <a:off x="3692576" y="2514600"/>
-            <a:ext cx="1973504" cy="502920"/>
-          </a:xfrm>
-          <a:prstGeom prst="rect">
-            <a:avLst/>
-          </a:prstGeom>
-          <a:noFill/>
-          <a:ln/>
-        </p:spPr>
-        <p:txBody>
-          <a:bodyPr wrap="square" rtlCol="0" anchor="t"/>
-          <a:lstStyle/>
-          <a:p>
-            <a:pPr indent="0" marL="0">
-              <a:buNone/>
-            </a:pPr>
-            <a:r>
-              <a:rPr lang="en-US" sz="1450" b="1" dirty="0">
-                <a:solidFill>
-                  <a:srgbClr val="0F1B33"/>
-                </a:solidFill>
-                <a:latin typeface="Montserrat" pitchFamily="34" charset="0"/>
-                <a:ea typeface="Montserrat" pitchFamily="34" charset="-122"/>
-                <a:cs typeface="Montserrat" pitchFamily="34" charset="-120"/>
-              </a:rPr>
-              <a:t>Pide buscar</a:t>
-            </a:r>
-            <a:endParaRPr lang="en-US" sz="1450" dirty="0"/>
-          </a:p>
-        </p:txBody>
-      </p:sp>
-      <p:sp>
-        <p:nvSpPr>
-          <p:cNvPr id="16" name="Text 14"/>
-          <p:cNvSpPr/>
-          <p:nvPr/>
-        </p:nvSpPr>
-        <p:spPr>
-          <a:xfrm>
-            <a:off x="3692576" y="3063240"/>
-            <a:ext cx="1973504" cy="548640"/>
-          </a:xfrm>
-          <a:prstGeom prst="rect">
-            <a:avLst/>
-          </a:prstGeom>
-          <a:noFill/>
-          <a:ln/>
-        </p:spPr>
-        <p:txBody>
-          <a:bodyPr wrap="square" rtlCol="0" anchor="t"/>
-          <a:lstStyle/>
-          <a:p>
-            <a:pPr indent="0" marL="0">
-              <a:buNone/>
-            </a:pPr>
-            <a:r>
-              <a:rPr lang="en-US" sz="1100" dirty="0">
-                <a:solidFill>
-                  <a:srgbClr val="2B3A55"/>
-                </a:solidFill>
-                <a:latin typeface="Inter" pitchFamily="34" charset="0"/>
-                <a:ea typeface="Inter" pitchFamily="34" charset="-122"/>
-                <a:cs typeface="Inter" pitchFamily="34" charset="-120"/>
-              </a:rPr>
-              <a:t>"busca en mis documentos"</a:t>
-            </a:r>
-            <a:endParaRPr lang="en-US" sz="1100" dirty="0"/>
-          </a:p>
-        </p:txBody>
-      </p:sp>
-      <p:sp>
-        <p:nvSpPr>
-          <p:cNvPr id="17" name="Text 15"/>
-          <p:cNvSpPr/>
-          <p:nvPr/>
-        </p:nvSpPr>
-        <p:spPr>
-          <a:xfrm>
-            <a:off x="5867248" y="2286000"/>
-            <a:ext cx="457200" cy="1463040"/>
-          </a:xfrm>
-          <a:prstGeom prst="rect">
-            <a:avLst/>
-          </a:prstGeom>
-          <a:noFill/>
-          <a:ln/>
-        </p:spPr>
-        <p:txBody>
-          <a:bodyPr wrap="square" rtlCol="0" anchor="ctr"/>
-          <a:lstStyle/>
-          <a:p>
-            <a:pPr algn="ctr" indent="0" marL="0">
-              <a:buNone/>
-            </a:pPr>
-            <a:r>
-              <a:rPr lang="en-US" sz="2400" b="1" dirty="0">
-                <a:solidFill>
-                  <a:srgbClr val="1E9BD7"/>
-                </a:solidFill>
-                <a:latin typeface="Montserrat" pitchFamily="34" charset="0"/>
-                <a:ea typeface="Montserrat" pitchFamily="34" charset="-122"/>
-                <a:cs typeface="Montserrat" pitchFamily="34" charset="-120"/>
-              </a:rPr>
-              <a:t>→</a:t>
-            </a:r>
-            <a:endParaRPr lang="en-US" sz="2400" dirty="0"/>
-          </a:p>
-        </p:txBody>
-      </p:sp>
-      <p:sp>
-        <p:nvSpPr>
-          <p:cNvPr id="18" name="Shape 16"/>
-          <p:cNvSpPr/>
-          <p:nvPr/>
-        </p:nvSpPr>
-        <p:spPr>
-          <a:xfrm>
-            <a:off x="6324448" y="2286000"/>
-            <a:ext cx="2375840" cy="1463040"/>
-          </a:xfrm>
-          <a:prstGeom prst="roundRect">
-            <a:avLst>
-              <a:gd name="adj" fmla="val 5000"/>
-            </a:avLst>
-          </a:prstGeom>
-          <a:solidFill>
-            <a:srgbClr val="FFFFFF"/>
-          </a:solidFill>
-          <a:ln w="12700">
-            <a:solidFill>
-              <a:srgbClr val="DFE6F0"/>
-            </a:solidFill>
-            <a:prstDash val="solid"/>
-          </a:ln>
-        </p:spPr>
-      </p:sp>
-      <p:sp>
-        <p:nvSpPr>
-          <p:cNvPr id="19" name="Shape 17"/>
-          <p:cNvSpPr/>
-          <p:nvPr/>
-        </p:nvSpPr>
-        <p:spPr>
-          <a:xfrm>
-            <a:off x="6324448" y="2286000"/>
-            <a:ext cx="2375840" cy="64008"/>
-          </a:xfrm>
-          <a:prstGeom prst="roundRect">
-            <a:avLst>
-              <a:gd name="adj" fmla="val 42857"/>
-            </a:avLst>
-          </a:prstGeom>
-          <a:solidFill>
-            <a:srgbClr val="4FA82F"/>
-          </a:solidFill>
-          <a:ln w="12700">
-            <a:solidFill>
-              <a:srgbClr val="333333"/>
-            </a:solidFill>
-            <a:prstDash val="solid"/>
-          </a:ln>
-        </p:spPr>
-      </p:sp>
-      <p:sp>
-        <p:nvSpPr>
-          <p:cNvPr id="20" name="Text 18"/>
-          <p:cNvSpPr/>
-          <p:nvPr/>
-        </p:nvSpPr>
-        <p:spPr>
-          <a:xfrm>
-            <a:off x="6525616" y="2514600"/>
-            <a:ext cx="1973504" cy="502920"/>
-          </a:xfrm>
-          <a:prstGeom prst="rect">
-            <a:avLst/>
-          </a:prstGeom>
-          <a:noFill/>
-          <a:ln/>
-        </p:spPr>
-        <p:txBody>
-          <a:bodyPr wrap="square" rtlCol="0" anchor="t"/>
-          <a:lstStyle/>
-          <a:p>
-            <a:pPr indent="0" marL="0">
-              <a:buNone/>
-            </a:pPr>
-            <a:r>
-              <a:rPr lang="en-US" sz="1450" b="1" dirty="0">
-                <a:solidFill>
-                  <a:srgbClr val="0F1B33"/>
-                </a:solidFill>
-                <a:latin typeface="Montserrat" pitchFamily="34" charset="0"/>
-                <a:ea typeface="Montserrat" pitchFamily="34" charset="-122"/>
-                <a:cs typeface="Montserrat" pitchFamily="34" charset="-120"/>
-              </a:rPr>
-              <a:t>Recibe pasajes</a:t>
-            </a:r>
-            <a:endParaRPr lang="en-US" sz="1450" dirty="0"/>
-          </a:p>
-        </p:txBody>
-      </p:sp>
-      <p:sp>
-        <p:nvSpPr>
-          <p:cNvPr id="21" name="Text 19"/>
-          <p:cNvSpPr/>
-          <p:nvPr/>
-        </p:nvSpPr>
-        <p:spPr>
-          <a:xfrm>
-            <a:off x="6525616" y="3063240"/>
-            <a:ext cx="1973504" cy="548640"/>
-          </a:xfrm>
-          <a:prstGeom prst="rect">
-            <a:avLst/>
-          </a:prstGeom>
-          <a:noFill/>
-          <a:ln/>
-        </p:spPr>
-        <p:txBody>
-          <a:bodyPr wrap="square" rtlCol="0" anchor="t"/>
-          <a:lstStyle/>
-          <a:p>
-            <a:pPr indent="0" marL="0">
-              <a:buNone/>
-            </a:pPr>
-            <a:r>
-              <a:rPr lang="en-US" sz="1100" dirty="0">
-                <a:solidFill>
-                  <a:srgbClr val="2B3A55"/>
-                </a:solidFill>
-                <a:latin typeface="Inter" pitchFamily="34" charset="0"/>
-                <a:ea typeface="Inter" pitchFamily="34" charset="-122"/>
-                <a:cs typeface="Inter" pitchFamily="34" charset="-120"/>
-              </a:rPr>
-              <a:t>los fragmentos relevantes</a:t>
-            </a:r>
-            <a:endParaRPr lang="en-US" sz="1100" dirty="0"/>
-          </a:p>
-        </p:txBody>
-      </p:sp>
-      <p:sp>
-        <p:nvSpPr>
-          <p:cNvPr id="22" name="Text 20"/>
-          <p:cNvSpPr/>
-          <p:nvPr/>
-        </p:nvSpPr>
-        <p:spPr>
-          <a:xfrm>
-            <a:off x="8700287" y="2286000"/>
-            <a:ext cx="457200" cy="1463040"/>
-          </a:xfrm>
-          <a:prstGeom prst="rect">
-            <a:avLst/>
-          </a:prstGeom>
-          <a:noFill/>
-          <a:ln/>
-        </p:spPr>
-        <p:txBody>
-          <a:bodyPr wrap="square" rtlCol="0" anchor="ctr"/>
-          <a:lstStyle/>
-          <a:p>
-            <a:pPr algn="ctr" indent="0" marL="0">
-              <a:buNone/>
-            </a:pPr>
-            <a:r>
-              <a:rPr lang="en-US" sz="2400" b="1" dirty="0">
-                <a:solidFill>
-                  <a:srgbClr val="1E9BD7"/>
-                </a:solidFill>
-                <a:latin typeface="Montserrat" pitchFamily="34" charset="0"/>
-                <a:ea typeface="Montserrat" pitchFamily="34" charset="-122"/>
-                <a:cs typeface="Montserrat" pitchFamily="34" charset="-120"/>
-              </a:rPr>
-              <a:t>→</a:t>
-            </a:r>
-            <a:endParaRPr lang="en-US" sz="2400" dirty="0"/>
-          </a:p>
-        </p:txBody>
-      </p:sp>
-      <p:sp>
-        <p:nvSpPr>
-          <p:cNvPr id="23" name="Shape 21"/>
-          <p:cNvSpPr/>
-          <p:nvPr/>
-        </p:nvSpPr>
-        <p:spPr>
-          <a:xfrm>
-            <a:off x="9157487" y="2286000"/>
-            <a:ext cx="2375840" cy="1463040"/>
-          </a:xfrm>
-          <a:prstGeom prst="roundRect">
-            <a:avLst>
-              <a:gd name="adj" fmla="val 5000"/>
-            </a:avLst>
-          </a:prstGeom>
-          <a:solidFill>
-            <a:srgbClr val="FFFFFF"/>
-          </a:solidFill>
-          <a:ln w="12700">
-            <a:solidFill>
-              <a:srgbClr val="DFE6F0"/>
-            </a:solidFill>
-            <a:prstDash val="solid"/>
-          </a:ln>
-        </p:spPr>
-      </p:sp>
-      <p:sp>
-        <p:nvSpPr>
-          <p:cNvPr id="24" name="Shape 22"/>
-          <p:cNvSpPr/>
-          <p:nvPr/>
-        </p:nvSpPr>
-        <p:spPr>
-          <a:xfrm>
-            <a:off x="9157487" y="2286000"/>
-            <a:ext cx="2375840" cy="64008"/>
-          </a:xfrm>
-          <a:prstGeom prst="roundRect">
-            <a:avLst>
-              <a:gd name="adj" fmla="val 42857"/>
-            </a:avLst>
-          </a:prstGeom>
-          <a:solidFill>
-            <a:srgbClr val="D9820A"/>
-          </a:solidFill>
-          <a:ln w="12700">
-            <a:solidFill>
-              <a:srgbClr val="333333"/>
-            </a:solidFill>
-            <a:prstDash val="solid"/>
-          </a:ln>
-        </p:spPr>
-      </p:sp>
-      <p:sp>
-        <p:nvSpPr>
-          <p:cNvPr id="25" name="Text 23"/>
-          <p:cNvSpPr/>
-          <p:nvPr/>
-        </p:nvSpPr>
-        <p:spPr>
-          <a:xfrm>
-            <a:off x="9358655" y="2514600"/>
-            <a:ext cx="1973504" cy="502920"/>
-          </a:xfrm>
-          <a:prstGeom prst="rect">
-            <a:avLst/>
-          </a:prstGeom>
-          <a:noFill/>
-          <a:ln/>
-        </p:spPr>
-        <p:txBody>
-          <a:bodyPr wrap="square" rtlCol="0" anchor="t"/>
-          <a:lstStyle/>
-          <a:p>
-            <a:pPr indent="0" marL="0">
-              <a:buNone/>
-            </a:pPr>
-            <a:r>
-              <a:rPr lang="en-US" sz="1450" b="1" dirty="0">
-                <a:solidFill>
-                  <a:srgbClr val="0F1B33"/>
-                </a:solidFill>
-                <a:latin typeface="Montserrat" pitchFamily="34" charset="0"/>
-                <a:ea typeface="Montserrat" pitchFamily="34" charset="-122"/>
-                <a:cs typeface="Montserrat" pitchFamily="34" charset="-120"/>
-              </a:rPr>
-              <a:t>Responde</a:t>
-            </a:r>
-            <a:endParaRPr lang="en-US" sz="1450" dirty="0"/>
-          </a:p>
-        </p:txBody>
-      </p:sp>
-      <p:sp>
-        <p:nvSpPr>
-          <p:cNvPr id="26" name="Text 24"/>
-          <p:cNvSpPr/>
-          <p:nvPr/>
-        </p:nvSpPr>
-        <p:spPr>
-          <a:xfrm>
-            <a:off x="9358655" y="3063240"/>
-            <a:ext cx="1973504" cy="548640"/>
-          </a:xfrm>
-          <a:prstGeom prst="rect">
-            <a:avLst/>
-          </a:prstGeom>
-          <a:noFill/>
-          <a:ln/>
-        </p:spPr>
-        <p:txBody>
-          <a:bodyPr wrap="square" rtlCol="0" anchor="t"/>
-          <a:lstStyle/>
-          <a:p>
-            <a:pPr indent="0" marL="0">
-              <a:buNone/>
-            </a:pPr>
-            <a:r>
-              <a:rPr lang="en-US" sz="1100" dirty="0">
-                <a:solidFill>
-                  <a:srgbClr val="2B3A55"/>
-                </a:solidFill>
-                <a:latin typeface="Inter" pitchFamily="34" charset="0"/>
-                <a:ea typeface="Inter" pitchFamily="34" charset="-122"/>
-                <a:cs typeface="Inter" pitchFamily="34" charset="-120"/>
-              </a:rPr>
-              <a:t>solo con eso</a:t>
-            </a:r>
-            <a:endParaRPr lang="en-US" sz="1100" dirty="0"/>
-          </a:p>
-        </p:txBody>
-      </p:sp>
-      <p:sp>
-        <p:nvSpPr>
-          <p:cNvPr id="27" name="Shape 25"/>
-          <p:cNvSpPr/>
-          <p:nvPr/>
-        </p:nvSpPr>
-        <p:spPr>
-          <a:xfrm>
-            <a:off x="658368" y="4206240"/>
-            <a:ext cx="10874959" cy="1234440"/>
-          </a:xfrm>
-          <a:prstGeom prst="roundRect">
-            <a:avLst>
-              <a:gd name="adj" fmla="val 5926"/>
+              <a:gd name="adj" fmla="val 6957"/>
             </a:avLst>
           </a:prstGeom>
           <a:solidFill>
@@ -15200,14 +13416,14 @@
       </p:sp>
       <p:sp>
         <p:nvSpPr>
-          <p:cNvPr id="28" name="Text 26"/>
-          <p:cNvSpPr/>
-          <p:nvPr/>
-        </p:nvSpPr>
-        <p:spPr>
-          <a:xfrm>
-            <a:off x="978408" y="4206240"/>
-            <a:ext cx="10234879" cy="1234440"/>
+          <p:cNvPr id="10" name="Text 7"/>
+          <p:cNvSpPr/>
+          <p:nvPr/>
+        </p:nvSpPr>
+        <p:spPr>
+          <a:xfrm>
+            <a:off x="978408" y="5074920"/>
+            <a:ext cx="10234879" cy="1051560"/>
           </a:xfrm>
           <a:prstGeom prst="rect">
             <a:avLst/>
@@ -15481,690 +13697,38 @@
           </a:p>
         </p:txBody>
       </p:sp>
-      <p:sp>
-        <p:nvSpPr>
-          <p:cNvPr id="8" name="Shape 6"/>
-          <p:cNvSpPr/>
-          <p:nvPr/>
-        </p:nvSpPr>
-        <p:spPr>
-          <a:xfrm>
-            <a:off x="658368" y="2286000"/>
-            <a:ext cx="2043318" cy="2468880"/>
-          </a:xfrm>
-          <a:prstGeom prst="roundRect">
-            <a:avLst>
-              <a:gd name="adj" fmla="val 3580"/>
-            </a:avLst>
-          </a:prstGeom>
-          <a:solidFill>
-            <a:srgbClr val="FFFFFF"/>
-          </a:solidFill>
-          <a:ln w="12700">
-            <a:solidFill>
-              <a:srgbClr val="DFE6F0"/>
-            </a:solidFill>
-            <a:prstDash val="solid"/>
-          </a:ln>
-        </p:spPr>
-      </p:sp>
-      <p:sp>
-        <p:nvSpPr>
-          <p:cNvPr id="9" name="Shape 7"/>
-          <p:cNvSpPr/>
-          <p:nvPr/>
-        </p:nvSpPr>
-        <p:spPr>
-          <a:xfrm>
-            <a:off x="658368" y="2286000"/>
-            <a:ext cx="2043318" cy="64008"/>
-          </a:xfrm>
-          <a:prstGeom prst="roundRect">
-            <a:avLst>
-              <a:gd name="adj" fmla="val 42857"/>
-            </a:avLst>
-          </a:prstGeom>
-          <a:solidFill>
-            <a:srgbClr val="1E9BD7"/>
-          </a:solidFill>
-          <a:ln w="12700">
-            <a:solidFill>
-              <a:srgbClr val="333333"/>
-            </a:solidFill>
-            <a:prstDash val="solid"/>
-          </a:ln>
-        </p:spPr>
-      </p:sp>
-      <p:sp>
-        <p:nvSpPr>
-          <p:cNvPr id="10" name="Text 8"/>
-          <p:cNvSpPr/>
-          <p:nvPr/>
-        </p:nvSpPr>
-        <p:spPr>
-          <a:xfrm>
-            <a:off x="841248" y="2514600"/>
-            <a:ext cx="1677558" cy="548640"/>
-          </a:xfrm>
-          <a:prstGeom prst="rect">
-            <a:avLst/>
-          </a:prstGeom>
-          <a:noFill/>
-          <a:ln/>
-        </p:spPr>
-        <p:txBody>
-          <a:bodyPr wrap="square" rtlCol="0" anchor="t"/>
-          <a:lstStyle/>
-          <a:p>
-            <a:pPr indent="0" marL="0">
-              <a:buNone/>
-            </a:pPr>
-            <a:r>
-              <a:rPr lang="en-US" sz="1500" b="1" dirty="0">
-                <a:solidFill>
-                  <a:srgbClr val="0F1B33"/>
-                </a:solidFill>
-                <a:latin typeface="Montserrat" pitchFamily="34" charset="0"/>
-                <a:ea typeface="Montserrat" pitchFamily="34" charset="-122"/>
-                <a:cs typeface="Montserrat" pitchFamily="34" charset="-120"/>
-              </a:rPr>
-              <a:t>Modelo</a:t>
-            </a:r>
-            <a:endParaRPr lang="en-US" sz="1500" dirty="0"/>
-          </a:p>
-        </p:txBody>
-      </p:sp>
-      <p:sp>
-        <p:nvSpPr>
-          <p:cNvPr id="11" name="Text 9"/>
-          <p:cNvSpPr/>
-          <p:nvPr/>
-        </p:nvSpPr>
-        <p:spPr>
-          <a:xfrm>
-            <a:off x="841248" y="3154680"/>
-            <a:ext cx="1677558" cy="1371600"/>
-          </a:xfrm>
-          <a:prstGeom prst="rect">
-            <a:avLst/>
-          </a:prstGeom>
-          <a:noFill/>
-          <a:ln/>
-        </p:spPr>
-        <p:txBody>
-          <a:bodyPr wrap="square" rtlCol="0" anchor="t"/>
-          <a:lstStyle/>
-          <a:p>
-            <a:pPr indent="0" marL="0">
-              <a:lnSpc>
-                <a:spcPct val="105000"/>
-              </a:lnSpc>
-              <a:buNone/>
-            </a:pPr>
-            <a:r>
-              <a:rPr lang="en-US" sz="1100" dirty="0">
-                <a:solidFill>
-                  <a:srgbClr val="2B3A55"/>
-                </a:solidFill>
-                <a:latin typeface="Inter" pitchFamily="34" charset="0"/>
-                <a:ea typeface="Inter" pitchFamily="34" charset="-122"/>
-                <a:cs typeface="Inter" pitchFamily="34" charset="-120"/>
-              </a:rPr>
-              <a:t>razona y redacta. Sustituible por configuración.</a:t>
-            </a:r>
-            <a:endParaRPr lang="en-US" sz="1100" dirty="0"/>
-          </a:p>
-        </p:txBody>
-      </p:sp>
-      <p:sp>
-        <p:nvSpPr>
-          <p:cNvPr id="12" name="Shape 10"/>
-          <p:cNvSpPr/>
-          <p:nvPr/>
-        </p:nvSpPr>
-        <p:spPr>
-          <a:xfrm>
-            <a:off x="2866278" y="2286000"/>
-            <a:ext cx="2043318" cy="2468880"/>
-          </a:xfrm>
-          <a:prstGeom prst="roundRect">
-            <a:avLst>
-              <a:gd name="adj" fmla="val 3580"/>
-            </a:avLst>
-          </a:prstGeom>
-          <a:solidFill>
-            <a:srgbClr val="FFFFFF"/>
-          </a:solidFill>
-          <a:ln w="12700">
-            <a:solidFill>
-              <a:srgbClr val="DFE6F0"/>
-            </a:solidFill>
-            <a:prstDash val="solid"/>
-          </a:ln>
-        </p:spPr>
-      </p:sp>
-      <p:sp>
-        <p:nvSpPr>
-          <p:cNvPr id="13" name="Shape 11"/>
-          <p:cNvSpPr/>
-          <p:nvPr/>
-        </p:nvSpPr>
-        <p:spPr>
-          <a:xfrm>
-            <a:off x="2866278" y="2286000"/>
-            <a:ext cx="2043318" cy="64008"/>
-          </a:xfrm>
-          <a:prstGeom prst="roundRect">
-            <a:avLst>
-              <a:gd name="adj" fmla="val 42857"/>
-            </a:avLst>
-          </a:prstGeom>
-          <a:solidFill>
-            <a:srgbClr val="D9820A"/>
-          </a:solidFill>
-          <a:ln w="12700">
-            <a:solidFill>
-              <a:srgbClr val="333333"/>
-            </a:solidFill>
-            <a:prstDash val="solid"/>
-          </a:ln>
-        </p:spPr>
-      </p:sp>
-      <p:sp>
-        <p:nvSpPr>
-          <p:cNvPr id="14" name="Text 12"/>
-          <p:cNvSpPr/>
-          <p:nvPr/>
-        </p:nvSpPr>
-        <p:spPr>
-          <a:xfrm>
-            <a:off x="3049158" y="2514600"/>
-            <a:ext cx="1677558" cy="548640"/>
-          </a:xfrm>
-          <a:prstGeom prst="rect">
-            <a:avLst/>
-          </a:prstGeom>
-          <a:noFill/>
-          <a:ln/>
-        </p:spPr>
-        <p:txBody>
-          <a:bodyPr wrap="square" rtlCol="0" anchor="t"/>
-          <a:lstStyle/>
-          <a:p>
-            <a:pPr indent="0" marL="0">
-              <a:buNone/>
-            </a:pPr>
-            <a:r>
-              <a:rPr lang="en-US" sz="1500" b="1" dirty="0">
-                <a:solidFill>
-                  <a:srgbClr val="0F1B33"/>
-                </a:solidFill>
-                <a:latin typeface="Montserrat" pitchFamily="34" charset="0"/>
-                <a:ea typeface="Montserrat" pitchFamily="34" charset="-122"/>
-                <a:cs typeface="Montserrat" pitchFamily="34" charset="-120"/>
-              </a:rPr>
-              <a:t>Instrucciones</a:t>
-            </a:r>
-            <a:endParaRPr lang="en-US" sz="1500" dirty="0"/>
-          </a:p>
-        </p:txBody>
-      </p:sp>
-      <p:sp>
-        <p:nvSpPr>
-          <p:cNvPr id="15" name="Text 13"/>
-          <p:cNvSpPr/>
-          <p:nvPr/>
-        </p:nvSpPr>
-        <p:spPr>
-          <a:xfrm>
-            <a:off x="3049158" y="3154680"/>
-            <a:ext cx="1677558" cy="1371600"/>
-          </a:xfrm>
-          <a:prstGeom prst="rect">
-            <a:avLst/>
-          </a:prstGeom>
-          <a:noFill/>
-          <a:ln/>
-        </p:spPr>
-        <p:txBody>
-          <a:bodyPr wrap="square" rtlCol="0" anchor="t"/>
-          <a:lstStyle/>
-          <a:p>
-            <a:pPr indent="0" marL="0">
-              <a:lnSpc>
-                <a:spcPct val="105000"/>
-              </a:lnSpc>
-              <a:buNone/>
-            </a:pPr>
-            <a:r>
-              <a:rPr lang="en-US" sz="1100" dirty="0">
-                <a:solidFill>
-                  <a:srgbClr val="2B3A55"/>
-                </a:solidFill>
-                <a:latin typeface="Inter" pitchFamily="34" charset="0"/>
-                <a:ea typeface="Inter" pitchFamily="34" charset="-122"/>
-                <a:cs typeface="Inter" pitchFamily="34" charset="-120"/>
-              </a:rPr>
-              <a:t>el system prompt: rol, reglas y límites.</a:t>
-            </a:r>
-            <a:endParaRPr lang="en-US" sz="1100" dirty="0"/>
-          </a:p>
-        </p:txBody>
-      </p:sp>
-      <p:sp>
-        <p:nvSpPr>
-          <p:cNvPr id="16" name="Shape 14"/>
-          <p:cNvSpPr/>
-          <p:nvPr/>
-        </p:nvSpPr>
-        <p:spPr>
-          <a:xfrm>
-            <a:off x="5074188" y="2286000"/>
-            <a:ext cx="2043318" cy="2468880"/>
-          </a:xfrm>
-          <a:prstGeom prst="roundRect">
-            <a:avLst>
-              <a:gd name="adj" fmla="val 3580"/>
-            </a:avLst>
-          </a:prstGeom>
-          <a:solidFill>
-            <a:srgbClr val="FFFFFF"/>
-          </a:solidFill>
-          <a:ln w="12700">
-            <a:solidFill>
-              <a:srgbClr val="DFE6F0"/>
-            </a:solidFill>
-            <a:prstDash val="solid"/>
-          </a:ln>
-        </p:spPr>
-      </p:sp>
-      <p:sp>
-        <p:nvSpPr>
-          <p:cNvPr id="17" name="Shape 15"/>
-          <p:cNvSpPr/>
-          <p:nvPr/>
-        </p:nvSpPr>
-        <p:spPr>
-          <a:xfrm>
-            <a:off x="5074188" y="2286000"/>
-            <a:ext cx="2043318" cy="64008"/>
-          </a:xfrm>
-          <a:prstGeom prst="roundRect">
-            <a:avLst>
-              <a:gd name="adj" fmla="val 42857"/>
-            </a:avLst>
-          </a:prstGeom>
-          <a:solidFill>
-            <a:srgbClr val="4FA82F"/>
-          </a:solidFill>
-          <a:ln w="12700">
-            <a:solidFill>
-              <a:srgbClr val="333333"/>
-            </a:solidFill>
-            <a:prstDash val="solid"/>
-          </a:ln>
-        </p:spPr>
-      </p:sp>
-      <p:sp>
-        <p:nvSpPr>
-          <p:cNvPr id="18" name="Text 16"/>
-          <p:cNvSpPr/>
-          <p:nvPr/>
-        </p:nvSpPr>
-        <p:spPr>
-          <a:xfrm>
-            <a:off x="5257068" y="2514600"/>
-            <a:ext cx="1677558" cy="548640"/>
-          </a:xfrm>
-          <a:prstGeom prst="rect">
-            <a:avLst/>
-          </a:prstGeom>
-          <a:noFill/>
-          <a:ln/>
-        </p:spPr>
-        <p:txBody>
-          <a:bodyPr wrap="square" rtlCol="0" anchor="t"/>
-          <a:lstStyle/>
-          <a:p>
-            <a:pPr indent="0" marL="0">
-              <a:buNone/>
-            </a:pPr>
-            <a:r>
-              <a:rPr lang="en-US" sz="1500" b="1" dirty="0">
-                <a:solidFill>
-                  <a:srgbClr val="0F1B33"/>
-                </a:solidFill>
-                <a:latin typeface="Montserrat" pitchFamily="34" charset="0"/>
-                <a:ea typeface="Montserrat" pitchFamily="34" charset="-122"/>
-                <a:cs typeface="Montserrat" pitchFamily="34" charset="-120"/>
-              </a:rPr>
-              <a:t>Herramientas</a:t>
-            </a:r>
-            <a:endParaRPr lang="en-US" sz="1500" dirty="0"/>
-          </a:p>
-        </p:txBody>
-      </p:sp>
-      <p:sp>
-        <p:nvSpPr>
-          <p:cNvPr id="19" name="Text 17"/>
-          <p:cNvSpPr/>
-          <p:nvPr/>
-        </p:nvSpPr>
-        <p:spPr>
-          <a:xfrm>
-            <a:off x="5257068" y="3154680"/>
-            <a:ext cx="1677558" cy="1371600"/>
-          </a:xfrm>
-          <a:prstGeom prst="rect">
-            <a:avLst/>
-          </a:prstGeom>
-          <a:noFill/>
-          <a:ln/>
-        </p:spPr>
-        <p:txBody>
-          <a:bodyPr wrap="square" rtlCol="0" anchor="t"/>
-          <a:lstStyle/>
-          <a:p>
-            <a:pPr indent="0" marL="0">
-              <a:lnSpc>
-                <a:spcPct val="105000"/>
-              </a:lnSpc>
-              <a:buNone/>
-            </a:pPr>
-            <a:r>
-              <a:rPr lang="en-US" sz="1100" dirty="0">
-                <a:solidFill>
-                  <a:srgbClr val="2B3A55"/>
-                </a:solidFill>
-                <a:latin typeface="Inter" pitchFamily="34" charset="0"/>
-                <a:ea typeface="Inter" pitchFamily="34" charset="-122"/>
-                <a:cs typeface="Inter" pitchFamily="34" charset="-120"/>
-              </a:rPr>
-              <a:t>actúan; se describen solas con su docstring.</a:t>
-            </a:r>
-            <a:endParaRPr lang="en-US" sz="1100" dirty="0"/>
-          </a:p>
-        </p:txBody>
-      </p:sp>
-      <p:sp>
-        <p:nvSpPr>
-          <p:cNvPr id="20" name="Shape 18"/>
-          <p:cNvSpPr/>
-          <p:nvPr/>
-        </p:nvSpPr>
-        <p:spPr>
-          <a:xfrm>
-            <a:off x="7282099" y="2286000"/>
-            <a:ext cx="2043318" cy="2468880"/>
-          </a:xfrm>
-          <a:prstGeom prst="roundRect">
-            <a:avLst>
-              <a:gd name="adj" fmla="val 3580"/>
-            </a:avLst>
-          </a:prstGeom>
-          <a:solidFill>
-            <a:srgbClr val="FFFFFF"/>
-          </a:solidFill>
-          <a:ln w="12700">
-            <a:solidFill>
-              <a:srgbClr val="DFE6F0"/>
-            </a:solidFill>
-            <a:prstDash val="solid"/>
-          </a:ln>
-        </p:spPr>
-      </p:sp>
-      <p:sp>
-        <p:nvSpPr>
-          <p:cNvPr id="21" name="Shape 19"/>
-          <p:cNvSpPr/>
-          <p:nvPr/>
-        </p:nvSpPr>
-        <p:spPr>
-          <a:xfrm>
-            <a:off x="7282099" y="2286000"/>
-            <a:ext cx="2043318" cy="64008"/>
-          </a:xfrm>
-          <a:prstGeom prst="roundRect">
-            <a:avLst>
-              <a:gd name="adj" fmla="val 42857"/>
-            </a:avLst>
-          </a:prstGeom>
-          <a:solidFill>
-            <a:srgbClr val="12245B"/>
-          </a:solidFill>
-          <a:ln w="12700">
-            <a:solidFill>
-              <a:srgbClr val="333333"/>
-            </a:solidFill>
-            <a:prstDash val="solid"/>
-          </a:ln>
-        </p:spPr>
-      </p:sp>
-      <p:sp>
-        <p:nvSpPr>
-          <p:cNvPr id="22" name="Text 20"/>
-          <p:cNvSpPr/>
-          <p:nvPr/>
-        </p:nvSpPr>
-        <p:spPr>
-          <a:xfrm>
-            <a:off x="7464979" y="2514600"/>
-            <a:ext cx="1677558" cy="548640"/>
-          </a:xfrm>
-          <a:prstGeom prst="rect">
-            <a:avLst/>
-          </a:prstGeom>
-          <a:noFill/>
-          <a:ln/>
-        </p:spPr>
-        <p:txBody>
-          <a:bodyPr wrap="square" rtlCol="0" anchor="t"/>
-          <a:lstStyle/>
-          <a:p>
-            <a:pPr indent="0" marL="0">
-              <a:buNone/>
-            </a:pPr>
-            <a:r>
-              <a:rPr lang="en-US" sz="1500" b="1" dirty="0">
-                <a:solidFill>
-                  <a:srgbClr val="0F1B33"/>
-                </a:solidFill>
-                <a:latin typeface="Montserrat" pitchFamily="34" charset="0"/>
-                <a:ea typeface="Montserrat" pitchFamily="34" charset="-122"/>
-                <a:cs typeface="Montserrat" pitchFamily="34" charset="-120"/>
-              </a:rPr>
-              <a:t>Middleware</a:t>
-            </a:r>
-            <a:endParaRPr lang="en-US" sz="1500" dirty="0"/>
-          </a:p>
-        </p:txBody>
-      </p:sp>
-      <p:sp>
-        <p:nvSpPr>
-          <p:cNvPr id="23" name="Text 21"/>
-          <p:cNvSpPr/>
-          <p:nvPr/>
-        </p:nvSpPr>
-        <p:spPr>
-          <a:xfrm>
-            <a:off x="7464979" y="3154680"/>
-            <a:ext cx="1677558" cy="1371600"/>
-          </a:xfrm>
-          <a:prstGeom prst="rect">
-            <a:avLst/>
-          </a:prstGeom>
-          <a:noFill/>
-          <a:ln/>
-        </p:spPr>
-        <p:txBody>
-          <a:bodyPr wrap="square" rtlCol="0" anchor="t"/>
-          <a:lstStyle/>
-          <a:p>
-            <a:pPr indent="0" marL="0">
-              <a:lnSpc>
-                <a:spcPct val="105000"/>
-              </a:lnSpc>
-              <a:buNone/>
-            </a:pPr>
-            <a:r>
-              <a:rPr lang="en-US" sz="1100" dirty="0">
-                <a:solidFill>
-                  <a:srgbClr val="2B3A55"/>
-                </a:solidFill>
-                <a:latin typeface="Inter" pitchFamily="34" charset="0"/>
-                <a:ea typeface="Inter" pitchFamily="34" charset="-122"/>
-                <a:cs typeface="Inter" pitchFamily="34" charset="-120"/>
-              </a:rPr>
-              <a:t>hooks: contexto, guardrails, resiliencia.</a:t>
-            </a:r>
-            <a:endParaRPr lang="en-US" sz="1100" dirty="0"/>
-          </a:p>
-        </p:txBody>
-      </p:sp>
-      <p:sp>
-        <p:nvSpPr>
-          <p:cNvPr id="24" name="Shape 22"/>
-          <p:cNvSpPr/>
-          <p:nvPr/>
-        </p:nvSpPr>
-        <p:spPr>
-          <a:xfrm>
-            <a:off x="9490009" y="2286000"/>
-            <a:ext cx="2043318" cy="2468880"/>
-          </a:xfrm>
-          <a:prstGeom prst="roundRect">
-            <a:avLst>
-              <a:gd name="adj" fmla="val 3580"/>
-            </a:avLst>
-          </a:prstGeom>
-          <a:solidFill>
-            <a:srgbClr val="FFFFFF"/>
-          </a:solidFill>
-          <a:ln w="12700">
-            <a:solidFill>
-              <a:srgbClr val="DFE6F0"/>
-            </a:solidFill>
-            <a:prstDash val="solid"/>
-          </a:ln>
-        </p:spPr>
-      </p:sp>
-      <p:sp>
-        <p:nvSpPr>
-          <p:cNvPr id="25" name="Shape 23"/>
-          <p:cNvSpPr/>
-          <p:nvPr/>
-        </p:nvSpPr>
-        <p:spPr>
-          <a:xfrm>
-            <a:off x="9490009" y="2286000"/>
-            <a:ext cx="2043318" cy="64008"/>
-          </a:xfrm>
-          <a:prstGeom prst="roundRect">
-            <a:avLst>
-              <a:gd name="adj" fmla="val 42857"/>
-            </a:avLst>
-          </a:prstGeom>
-          <a:solidFill>
-            <a:srgbClr val="1E9BD7"/>
-          </a:solidFill>
-          <a:ln w="12700">
-            <a:solidFill>
-              <a:srgbClr val="333333"/>
-            </a:solidFill>
-            <a:prstDash val="solid"/>
-          </a:ln>
-        </p:spPr>
-      </p:sp>
-      <p:sp>
-        <p:nvSpPr>
-          <p:cNvPr id="26" name="Text 24"/>
-          <p:cNvSpPr/>
-          <p:nvPr/>
-        </p:nvSpPr>
-        <p:spPr>
-          <a:xfrm>
-            <a:off x="9672889" y="2514600"/>
-            <a:ext cx="1677558" cy="548640"/>
-          </a:xfrm>
-          <a:prstGeom prst="rect">
-            <a:avLst/>
-          </a:prstGeom>
-          <a:noFill/>
-          <a:ln/>
-        </p:spPr>
-        <p:txBody>
-          <a:bodyPr wrap="square" rtlCol="0" anchor="t"/>
-          <a:lstStyle/>
-          <a:p>
-            <a:pPr indent="0" marL="0">
-              <a:buNone/>
-            </a:pPr>
-            <a:r>
-              <a:rPr lang="en-US" sz="1500" b="1" dirty="0">
-                <a:solidFill>
-                  <a:srgbClr val="0F1B33"/>
-                </a:solidFill>
-                <a:latin typeface="Montserrat" pitchFamily="34" charset="0"/>
-                <a:ea typeface="Montserrat" pitchFamily="34" charset="-122"/>
-                <a:cs typeface="Montserrat" pitchFamily="34" charset="-120"/>
-              </a:rPr>
-              <a:t>Memoria</a:t>
-            </a:r>
-            <a:endParaRPr lang="en-US" sz="1500" dirty="0"/>
-          </a:p>
-        </p:txBody>
-      </p:sp>
-      <p:sp>
-        <p:nvSpPr>
-          <p:cNvPr id="27" name="Text 25"/>
-          <p:cNvSpPr/>
-          <p:nvPr/>
-        </p:nvSpPr>
-        <p:spPr>
-          <a:xfrm>
-            <a:off x="9672889" y="3154680"/>
-            <a:ext cx="1677558" cy="1371600"/>
-          </a:xfrm>
-          <a:prstGeom prst="rect">
-            <a:avLst/>
-          </a:prstGeom>
-          <a:noFill/>
-          <a:ln/>
-        </p:spPr>
-        <p:txBody>
-          <a:bodyPr wrap="square" rtlCol="0" anchor="t"/>
-          <a:lstStyle/>
-          <a:p>
-            <a:pPr indent="0" marL="0">
-              <a:lnSpc>
-                <a:spcPct val="105000"/>
-              </a:lnSpc>
-              <a:buNone/>
-            </a:pPr>
-            <a:r>
-              <a:rPr lang="en-US" sz="1100" dirty="0">
-                <a:solidFill>
-                  <a:srgbClr val="2B3A55"/>
-                </a:solidFill>
-                <a:latin typeface="Inter" pitchFamily="34" charset="0"/>
-                <a:ea typeface="Inter" pitchFamily="34" charset="-122"/>
-                <a:cs typeface="Inter" pitchFamily="34" charset="-120"/>
-              </a:rPr>
-              <a:t>checkpointer (el hilo) y store (entre hilos).</a:t>
-            </a:r>
-            <a:endParaRPr lang="en-US" sz="1100" dirty="0"/>
-          </a:p>
-        </p:txBody>
-      </p:sp>
-      <p:sp>
-        <p:nvSpPr>
-          <p:cNvPr id="28" name="Text 26"/>
-          <p:cNvSpPr/>
-          <p:nvPr/>
-        </p:nvSpPr>
-        <p:spPr>
-          <a:xfrm>
-            <a:off x="658368" y="5029200"/>
+      <p:pic>
+        <p:nvPicPr>
+          <p:cNvPr id="8" name="Image 0" descr="/home/jamaya/PiuraAI/fundamentos-agentes/assets/img/diagram-blueprint.png">    </p:cNvPr>
+          <p:cNvPicPr>
+            <a:picLocks noChangeAspect="1"/>
+          </p:cNvPicPr>
+          <p:nvPr/>
+        </p:nvPicPr>
+        <p:blipFill>
+          <a:blip r:embed="rId1"/>
+          <a:srcRect l="0" r="0" t="0" b="0"/>
+          <a:stretch/>
+        </p:blipFill>
+        <p:spPr>
+          <a:xfrm>
+            <a:off x="1109121" y="1828800"/>
+            <a:ext cx="9973452" cy="4114800"/>
+          </a:xfrm>
+          <a:prstGeom prst="rect">
+            <a:avLst/>
+          </a:prstGeom>
+        </p:spPr>
+      </p:pic>
+      <p:sp>
+        <p:nvSpPr>
+          <p:cNvPr id="9" name="Text 6"/>
+          <p:cNvSpPr/>
+          <p:nvPr/>
+        </p:nvSpPr>
+        <p:spPr>
+          <a:xfrm>
+            <a:off x="658368" y="6035040"/>
             <a:ext cx="10874959" cy="457200"/>
           </a:xfrm>
           <a:prstGeom prst="rect">
@@ -23372,1059 +20936,38 @@
           </a:p>
         </p:txBody>
       </p:sp>
-      <p:sp>
-        <p:nvSpPr>
-          <p:cNvPr id="9" name="Shape 7"/>
-          <p:cNvSpPr/>
-          <p:nvPr/>
-        </p:nvSpPr>
-        <p:spPr>
-          <a:xfrm>
-            <a:off x="658368" y="2103120"/>
-            <a:ext cx="3478682" cy="1325880"/>
-          </a:xfrm>
-          <a:prstGeom prst="roundRect">
-            <a:avLst>
-              <a:gd name="adj" fmla="val 5517"/>
-            </a:avLst>
-          </a:prstGeom>
-          <a:solidFill>
-            <a:srgbClr val="FFFFFF"/>
-          </a:solidFill>
-          <a:ln w="12700">
-            <a:solidFill>
-              <a:srgbClr val="DFE6F0"/>
-            </a:solidFill>
-            <a:prstDash val="solid"/>
-          </a:ln>
-        </p:spPr>
-      </p:sp>
-      <p:sp>
-        <p:nvSpPr>
-          <p:cNvPr id="10" name="Shape 8"/>
-          <p:cNvSpPr/>
-          <p:nvPr/>
-        </p:nvSpPr>
-        <p:spPr>
-          <a:xfrm>
-            <a:off x="658368" y="2103120"/>
-            <a:ext cx="3478682" cy="64008"/>
-          </a:xfrm>
-          <a:prstGeom prst="roundRect">
-            <a:avLst>
-              <a:gd name="adj" fmla="val 42857"/>
-            </a:avLst>
-          </a:prstGeom>
-          <a:solidFill>
-            <a:srgbClr val="12245B"/>
-          </a:solidFill>
-          <a:ln w="12700">
-            <a:solidFill>
-              <a:srgbClr val="333333"/>
-            </a:solidFill>
-            <a:prstDash val="solid"/>
-          </a:ln>
-        </p:spPr>
-      </p:sp>
-      <p:sp>
-        <p:nvSpPr>
-          <p:cNvPr id="11" name="Text 9"/>
-          <p:cNvSpPr/>
-          <p:nvPr/>
-        </p:nvSpPr>
-        <p:spPr>
-          <a:xfrm>
-            <a:off x="877824" y="2267712"/>
-            <a:ext cx="548640" cy="457200"/>
-          </a:xfrm>
-          <a:prstGeom prst="rect">
-            <a:avLst/>
-          </a:prstGeom>
-          <a:noFill/>
-          <a:ln/>
-        </p:spPr>
-        <p:txBody>
-          <a:bodyPr wrap="square" rtlCol="0" anchor="ctr"/>
-          <a:lstStyle/>
-          <a:p>
-            <a:pPr indent="0" marL="0">
-              <a:buNone/>
-            </a:pPr>
-            <a:r>
-              <a:rPr lang="en-US" sz="2400" b="1" dirty="0">
-                <a:solidFill>
-                  <a:srgbClr val="12245B"/>
-                </a:solidFill>
-                <a:latin typeface="Montserrat" pitchFamily="34" charset="0"/>
-                <a:ea typeface="Montserrat" pitchFamily="34" charset="-122"/>
-                <a:cs typeface="Montserrat" pitchFamily="34" charset="-120"/>
-              </a:rPr>
-              <a:t>1</a:t>
-            </a:r>
-            <a:endParaRPr lang="en-US" sz="2400" dirty="0"/>
-          </a:p>
-        </p:txBody>
-      </p:sp>
-      <p:sp>
-        <p:nvSpPr>
-          <p:cNvPr id="12" name="Text 10"/>
-          <p:cNvSpPr/>
-          <p:nvPr/>
-        </p:nvSpPr>
-        <p:spPr>
-          <a:xfrm>
-            <a:off x="1426464" y="2322576"/>
-            <a:ext cx="2518562" cy="457200"/>
-          </a:xfrm>
-          <a:prstGeom prst="rect">
-            <a:avLst/>
-          </a:prstGeom>
-          <a:noFill/>
-          <a:ln/>
-        </p:spPr>
-        <p:txBody>
-          <a:bodyPr wrap="square" rtlCol="0" anchor="ctr"/>
-          <a:lstStyle/>
-          <a:p>
-            <a:pPr indent="0" marL="0">
-              <a:buNone/>
-            </a:pPr>
-            <a:r>
-              <a:rPr lang="en-US" sz="1600" b="1" dirty="0">
-                <a:solidFill>
-                  <a:srgbClr val="0F1B33"/>
-                </a:solidFill>
-                <a:latin typeface="Montserrat" pitchFamily="34" charset="0"/>
-                <a:ea typeface="Montserrat" pitchFamily="34" charset="-122"/>
-                <a:cs typeface="Montserrat" pitchFamily="34" charset="-120"/>
-              </a:rPr>
-              <a:t>Contexto</a:t>
-            </a:r>
-            <a:endParaRPr lang="en-US" sz="1600" dirty="0"/>
-          </a:p>
-        </p:txBody>
-      </p:sp>
-      <p:sp>
-        <p:nvSpPr>
-          <p:cNvPr id="13" name="Text 11"/>
-          <p:cNvSpPr/>
-          <p:nvPr/>
-        </p:nvSpPr>
-        <p:spPr>
-          <a:xfrm>
-            <a:off x="1426464" y="2761488"/>
-            <a:ext cx="2518562" cy="548640"/>
-          </a:xfrm>
-          <a:prstGeom prst="rect">
-            <a:avLst/>
-          </a:prstGeom>
-          <a:noFill/>
-          <a:ln/>
-        </p:spPr>
-        <p:txBody>
-          <a:bodyPr wrap="square" rtlCol="0" anchor="t"/>
-          <a:lstStyle/>
-          <a:p>
-            <a:pPr indent="0" marL="0">
-              <a:lnSpc>
-                <a:spcPct val="102000"/>
-              </a:lnSpc>
-              <a:buNone/>
-            </a:pPr>
-            <a:r>
-              <a:rPr lang="en-US" sz="1050" dirty="0">
-                <a:solidFill>
-                  <a:srgbClr val="2B3A55"/>
-                </a:solidFill>
-                <a:latin typeface="Inter" pitchFamily="34" charset="0"/>
-                <a:ea typeface="Inter" pitchFamily="34" charset="-122"/>
-                <a:cs typeface="Inter" pitchFamily="34" charset="-120"/>
-              </a:rPr>
-              <a:t>prompt + historial + reglas</a:t>
-            </a:r>
-            <a:endParaRPr lang="en-US" sz="1050" dirty="0"/>
-          </a:p>
-        </p:txBody>
-      </p:sp>
-      <p:sp>
-        <p:nvSpPr>
-          <p:cNvPr id="14" name="Shape 12"/>
-          <p:cNvSpPr/>
-          <p:nvPr/>
-        </p:nvSpPr>
-        <p:spPr>
-          <a:xfrm>
-            <a:off x="4356506" y="2103120"/>
-            <a:ext cx="3478682" cy="1325880"/>
-          </a:xfrm>
-          <a:prstGeom prst="roundRect">
-            <a:avLst>
-              <a:gd name="adj" fmla="val 5517"/>
-            </a:avLst>
-          </a:prstGeom>
-          <a:solidFill>
-            <a:srgbClr val="FFFFFF"/>
-          </a:solidFill>
-          <a:ln w="12700">
-            <a:solidFill>
-              <a:srgbClr val="DFE6F0"/>
-            </a:solidFill>
-            <a:prstDash val="solid"/>
-          </a:ln>
-        </p:spPr>
-      </p:sp>
-      <p:sp>
-        <p:nvSpPr>
-          <p:cNvPr id="15" name="Shape 13"/>
-          <p:cNvSpPr/>
-          <p:nvPr/>
-        </p:nvSpPr>
-        <p:spPr>
-          <a:xfrm>
-            <a:off x="4356506" y="2103120"/>
-            <a:ext cx="3478682" cy="64008"/>
-          </a:xfrm>
-          <a:prstGeom prst="roundRect">
-            <a:avLst>
-              <a:gd name="adj" fmla="val 42857"/>
-            </a:avLst>
-          </a:prstGeom>
-          <a:solidFill>
-            <a:srgbClr val="1E9BD7"/>
-          </a:solidFill>
-          <a:ln w="12700">
-            <a:solidFill>
-              <a:srgbClr val="333333"/>
-            </a:solidFill>
-            <a:prstDash val="solid"/>
-          </a:ln>
-        </p:spPr>
-      </p:sp>
-      <p:sp>
-        <p:nvSpPr>
-          <p:cNvPr id="16" name="Text 14"/>
-          <p:cNvSpPr/>
-          <p:nvPr/>
-        </p:nvSpPr>
-        <p:spPr>
-          <a:xfrm>
-            <a:off x="4575962" y="2267712"/>
-            <a:ext cx="548640" cy="457200"/>
-          </a:xfrm>
-          <a:prstGeom prst="rect">
-            <a:avLst/>
-          </a:prstGeom>
-          <a:noFill/>
-          <a:ln/>
-        </p:spPr>
-        <p:txBody>
-          <a:bodyPr wrap="square" rtlCol="0" anchor="ctr"/>
-          <a:lstStyle/>
-          <a:p>
-            <a:pPr indent="0" marL="0">
-              <a:buNone/>
-            </a:pPr>
-            <a:r>
-              <a:rPr lang="en-US" sz="2400" b="1" dirty="0">
-                <a:solidFill>
-                  <a:srgbClr val="1E9BD7"/>
-                </a:solidFill>
-                <a:latin typeface="Montserrat" pitchFamily="34" charset="0"/>
-                <a:ea typeface="Montserrat" pitchFamily="34" charset="-122"/>
-                <a:cs typeface="Montserrat" pitchFamily="34" charset="-120"/>
-              </a:rPr>
-              <a:t>2</a:t>
-            </a:r>
-            <a:endParaRPr lang="en-US" sz="2400" dirty="0"/>
-          </a:p>
-        </p:txBody>
-      </p:sp>
-      <p:sp>
-        <p:nvSpPr>
-          <p:cNvPr id="17" name="Text 15"/>
-          <p:cNvSpPr/>
-          <p:nvPr/>
-        </p:nvSpPr>
-        <p:spPr>
-          <a:xfrm>
-            <a:off x="5124602" y="2322576"/>
-            <a:ext cx="2518562" cy="457200"/>
-          </a:xfrm>
-          <a:prstGeom prst="rect">
-            <a:avLst/>
-          </a:prstGeom>
-          <a:noFill/>
-          <a:ln/>
-        </p:spPr>
-        <p:txBody>
-          <a:bodyPr wrap="square" rtlCol="0" anchor="ctr"/>
-          <a:lstStyle/>
-          <a:p>
-            <a:pPr indent="0" marL="0">
-              <a:buNone/>
-            </a:pPr>
-            <a:r>
-              <a:rPr lang="en-US" sz="1600" b="1" dirty="0">
-                <a:solidFill>
-                  <a:srgbClr val="0F1B33"/>
-                </a:solidFill>
-                <a:latin typeface="Montserrat" pitchFamily="34" charset="0"/>
-                <a:ea typeface="Montserrat" pitchFamily="34" charset="-122"/>
-                <a:cs typeface="Montserrat" pitchFamily="34" charset="-120"/>
-              </a:rPr>
-              <a:t>Razona</a:t>
-            </a:r>
-            <a:endParaRPr lang="en-US" sz="1600" dirty="0"/>
-          </a:p>
-        </p:txBody>
-      </p:sp>
-      <p:sp>
-        <p:nvSpPr>
-          <p:cNvPr id="18" name="Text 16"/>
-          <p:cNvSpPr/>
-          <p:nvPr/>
-        </p:nvSpPr>
-        <p:spPr>
-          <a:xfrm>
-            <a:off x="5124602" y="2761488"/>
-            <a:ext cx="2518562" cy="548640"/>
-          </a:xfrm>
-          <a:prstGeom prst="rect">
-            <a:avLst/>
-          </a:prstGeom>
-          <a:noFill/>
-          <a:ln/>
-        </p:spPr>
-        <p:txBody>
-          <a:bodyPr wrap="square" rtlCol="0" anchor="t"/>
-          <a:lstStyle/>
-          <a:p>
-            <a:pPr indent="0" marL="0">
-              <a:lnSpc>
-                <a:spcPct val="102000"/>
-              </a:lnSpc>
-              <a:buNone/>
-            </a:pPr>
-            <a:r>
-              <a:rPr lang="en-US" sz="1050" dirty="0">
-                <a:solidFill>
-                  <a:srgbClr val="2B3A55"/>
-                </a:solidFill>
-                <a:latin typeface="Inter" pitchFamily="34" charset="0"/>
-                <a:ea typeface="Inter" pitchFamily="34" charset="-122"/>
-                <a:cs typeface="Inter" pitchFamily="34" charset="-120"/>
-              </a:rPr>
-              <a:t>el modelo decide el paso</a:t>
-            </a:r>
-            <a:endParaRPr lang="en-US" sz="1050" dirty="0"/>
-          </a:p>
-        </p:txBody>
-      </p:sp>
-      <p:sp>
-        <p:nvSpPr>
-          <p:cNvPr id="19" name="Shape 17"/>
-          <p:cNvSpPr/>
-          <p:nvPr/>
-        </p:nvSpPr>
-        <p:spPr>
-          <a:xfrm>
-            <a:off x="8054645" y="2103120"/>
-            <a:ext cx="3478682" cy="1325880"/>
-          </a:xfrm>
-          <a:prstGeom prst="roundRect">
-            <a:avLst>
-              <a:gd name="adj" fmla="val 5517"/>
-            </a:avLst>
-          </a:prstGeom>
-          <a:solidFill>
-            <a:srgbClr val="FFFFFF"/>
-          </a:solidFill>
-          <a:ln w="12700">
-            <a:solidFill>
-              <a:srgbClr val="DFE6F0"/>
-            </a:solidFill>
-            <a:prstDash val="solid"/>
-          </a:ln>
-        </p:spPr>
-      </p:sp>
-      <p:sp>
-        <p:nvSpPr>
-          <p:cNvPr id="20" name="Shape 18"/>
-          <p:cNvSpPr/>
-          <p:nvPr/>
-        </p:nvSpPr>
-        <p:spPr>
-          <a:xfrm>
-            <a:off x="8054645" y="2103120"/>
-            <a:ext cx="3478682" cy="64008"/>
-          </a:xfrm>
-          <a:prstGeom prst="roundRect">
-            <a:avLst>
-              <a:gd name="adj" fmla="val 42857"/>
-            </a:avLst>
-          </a:prstGeom>
-          <a:solidFill>
-            <a:srgbClr val="D9820A"/>
-          </a:solidFill>
-          <a:ln w="12700">
-            <a:solidFill>
-              <a:srgbClr val="333333"/>
-            </a:solidFill>
-            <a:prstDash val="solid"/>
-          </a:ln>
-        </p:spPr>
-      </p:sp>
-      <p:sp>
-        <p:nvSpPr>
-          <p:cNvPr id="21" name="Text 19"/>
-          <p:cNvSpPr/>
-          <p:nvPr/>
-        </p:nvSpPr>
-        <p:spPr>
-          <a:xfrm>
-            <a:off x="8274101" y="2267712"/>
-            <a:ext cx="548640" cy="457200"/>
-          </a:xfrm>
-          <a:prstGeom prst="rect">
-            <a:avLst/>
-          </a:prstGeom>
-          <a:noFill/>
-          <a:ln/>
-        </p:spPr>
-        <p:txBody>
-          <a:bodyPr wrap="square" rtlCol="0" anchor="ctr"/>
-          <a:lstStyle/>
-          <a:p>
-            <a:pPr indent="0" marL="0">
-              <a:buNone/>
-            </a:pPr>
-            <a:r>
-              <a:rPr lang="en-US" sz="2400" b="1" dirty="0">
-                <a:solidFill>
-                  <a:srgbClr val="D9820A"/>
-                </a:solidFill>
-                <a:latin typeface="Montserrat" pitchFamily="34" charset="0"/>
-                <a:ea typeface="Montserrat" pitchFamily="34" charset="-122"/>
-                <a:cs typeface="Montserrat" pitchFamily="34" charset="-120"/>
-              </a:rPr>
-              <a:t>3</a:t>
-            </a:r>
-            <a:endParaRPr lang="en-US" sz="2400" dirty="0"/>
-          </a:p>
-        </p:txBody>
-      </p:sp>
-      <p:sp>
-        <p:nvSpPr>
-          <p:cNvPr id="22" name="Text 20"/>
-          <p:cNvSpPr/>
-          <p:nvPr/>
-        </p:nvSpPr>
-        <p:spPr>
-          <a:xfrm>
-            <a:off x="8822741" y="2322576"/>
-            <a:ext cx="2518562" cy="457200"/>
-          </a:xfrm>
-          <a:prstGeom prst="rect">
-            <a:avLst/>
-          </a:prstGeom>
-          <a:noFill/>
-          <a:ln/>
-        </p:spPr>
-        <p:txBody>
-          <a:bodyPr wrap="square" rtlCol="0" anchor="ctr"/>
-          <a:lstStyle/>
-          <a:p>
-            <a:pPr indent="0" marL="0">
-              <a:buNone/>
-            </a:pPr>
-            <a:r>
-              <a:rPr lang="en-US" sz="1600" b="1" dirty="0">
-                <a:solidFill>
-                  <a:srgbClr val="0F1B33"/>
-                </a:solidFill>
-                <a:latin typeface="Montserrat" pitchFamily="34" charset="0"/>
-                <a:ea typeface="Montserrat" pitchFamily="34" charset="-122"/>
-                <a:cs typeface="Montserrat" pitchFamily="34" charset="-120"/>
-              </a:rPr>
-              <a:t>¿Tool?</a:t>
-            </a:r>
-            <a:endParaRPr lang="en-US" sz="1600" dirty="0"/>
-          </a:p>
-        </p:txBody>
-      </p:sp>
-      <p:sp>
-        <p:nvSpPr>
-          <p:cNvPr id="23" name="Text 21"/>
-          <p:cNvSpPr/>
-          <p:nvPr/>
-        </p:nvSpPr>
-        <p:spPr>
-          <a:xfrm>
-            <a:off x="8822741" y="2761488"/>
-            <a:ext cx="2518562" cy="548640"/>
-          </a:xfrm>
-          <a:prstGeom prst="rect">
-            <a:avLst/>
-          </a:prstGeom>
-          <a:noFill/>
-          <a:ln/>
-        </p:spPr>
-        <p:txBody>
-          <a:bodyPr wrap="square" rtlCol="0" anchor="t"/>
-          <a:lstStyle/>
-          <a:p>
-            <a:pPr indent="0" marL="0">
-              <a:lnSpc>
-                <a:spcPct val="102000"/>
-              </a:lnSpc>
-              <a:buNone/>
-            </a:pPr>
-            <a:r>
-              <a:rPr lang="en-US" sz="1050" dirty="0">
-                <a:solidFill>
-                  <a:srgbClr val="2B3A55"/>
-                </a:solidFill>
-                <a:latin typeface="Inter" pitchFamily="34" charset="0"/>
-                <a:ea typeface="Inter" pitchFamily="34" charset="-122"/>
-                <a:cs typeface="Inter" pitchFamily="34" charset="-120"/>
-              </a:rPr>
-              <a:t>sí o no: la bifurcación</a:t>
-            </a:r>
-            <a:endParaRPr lang="en-US" sz="1050" dirty="0"/>
-          </a:p>
-        </p:txBody>
-      </p:sp>
-      <p:sp>
-        <p:nvSpPr>
-          <p:cNvPr id="24" name="Shape 22"/>
-          <p:cNvSpPr/>
-          <p:nvPr/>
-        </p:nvSpPr>
-        <p:spPr>
-          <a:xfrm>
-            <a:off x="658368" y="3657600"/>
-            <a:ext cx="3478682" cy="1325880"/>
-          </a:xfrm>
-          <a:prstGeom prst="roundRect">
-            <a:avLst>
-              <a:gd name="adj" fmla="val 5517"/>
-            </a:avLst>
-          </a:prstGeom>
-          <a:solidFill>
-            <a:srgbClr val="FFFFFF"/>
-          </a:solidFill>
-          <a:ln w="12700">
-            <a:solidFill>
-              <a:srgbClr val="DFE6F0"/>
-            </a:solidFill>
-            <a:prstDash val="solid"/>
-          </a:ln>
-        </p:spPr>
-      </p:sp>
-      <p:sp>
-        <p:nvSpPr>
-          <p:cNvPr id="25" name="Shape 23"/>
-          <p:cNvSpPr/>
-          <p:nvPr/>
-        </p:nvSpPr>
-        <p:spPr>
-          <a:xfrm>
-            <a:off x="658368" y="3657600"/>
-            <a:ext cx="3478682" cy="64008"/>
-          </a:xfrm>
-          <a:prstGeom prst="roundRect">
-            <a:avLst>
-              <a:gd name="adj" fmla="val 42857"/>
-            </a:avLst>
-          </a:prstGeom>
-          <a:solidFill>
-            <a:srgbClr val="4FA82F"/>
-          </a:solidFill>
-          <a:ln w="12700">
-            <a:solidFill>
-              <a:srgbClr val="333333"/>
-            </a:solidFill>
-            <a:prstDash val="solid"/>
-          </a:ln>
-        </p:spPr>
-      </p:sp>
-      <p:sp>
-        <p:nvSpPr>
-          <p:cNvPr id="26" name="Text 24"/>
-          <p:cNvSpPr/>
-          <p:nvPr/>
-        </p:nvSpPr>
-        <p:spPr>
-          <a:xfrm>
-            <a:off x="877824" y="3822192"/>
-            <a:ext cx="548640" cy="457200"/>
-          </a:xfrm>
-          <a:prstGeom prst="rect">
-            <a:avLst/>
-          </a:prstGeom>
-          <a:noFill/>
-          <a:ln/>
-        </p:spPr>
-        <p:txBody>
-          <a:bodyPr wrap="square" rtlCol="0" anchor="ctr"/>
-          <a:lstStyle/>
-          <a:p>
-            <a:pPr indent="0" marL="0">
-              <a:buNone/>
-            </a:pPr>
-            <a:r>
-              <a:rPr lang="en-US" sz="2400" b="1" dirty="0">
-                <a:solidFill>
-                  <a:srgbClr val="4FA82F"/>
-                </a:solidFill>
-                <a:latin typeface="Montserrat" pitchFamily="34" charset="0"/>
-                <a:ea typeface="Montserrat" pitchFamily="34" charset="-122"/>
-                <a:cs typeface="Montserrat" pitchFamily="34" charset="-120"/>
-              </a:rPr>
-              <a:t>4</a:t>
-            </a:r>
-            <a:endParaRPr lang="en-US" sz="2400" dirty="0"/>
-          </a:p>
-        </p:txBody>
-      </p:sp>
-      <p:sp>
-        <p:nvSpPr>
-          <p:cNvPr id="27" name="Text 25"/>
-          <p:cNvSpPr/>
-          <p:nvPr/>
-        </p:nvSpPr>
-        <p:spPr>
-          <a:xfrm>
-            <a:off x="1426464" y="3877056"/>
-            <a:ext cx="2518562" cy="457200"/>
-          </a:xfrm>
-          <a:prstGeom prst="rect">
-            <a:avLst/>
-          </a:prstGeom>
-          <a:noFill/>
-          <a:ln/>
-        </p:spPr>
-        <p:txBody>
-          <a:bodyPr wrap="square" rtlCol="0" anchor="ctr"/>
-          <a:lstStyle/>
-          <a:p>
-            <a:pPr indent="0" marL="0">
-              <a:buNone/>
-            </a:pPr>
-            <a:r>
-              <a:rPr lang="en-US" sz="1600" b="1" dirty="0">
-                <a:solidFill>
-                  <a:srgbClr val="0F1B33"/>
-                </a:solidFill>
-                <a:latin typeface="Montserrat" pitchFamily="34" charset="0"/>
-                <a:ea typeface="Montserrat" pitchFamily="34" charset="-122"/>
-                <a:cs typeface="Montserrat" pitchFamily="34" charset="-120"/>
-              </a:rPr>
-              <a:t>Actúa</a:t>
-            </a:r>
-            <a:endParaRPr lang="en-US" sz="1600" dirty="0"/>
-          </a:p>
-        </p:txBody>
-      </p:sp>
-      <p:sp>
-        <p:nvSpPr>
-          <p:cNvPr id="28" name="Text 26"/>
-          <p:cNvSpPr/>
-          <p:nvPr/>
-        </p:nvSpPr>
-        <p:spPr>
-          <a:xfrm>
-            <a:off x="1426464" y="4315968"/>
-            <a:ext cx="2518562" cy="548640"/>
-          </a:xfrm>
-          <a:prstGeom prst="rect">
-            <a:avLst/>
-          </a:prstGeom>
-          <a:noFill/>
-          <a:ln/>
-        </p:spPr>
-        <p:txBody>
-          <a:bodyPr wrap="square" rtlCol="0" anchor="t"/>
-          <a:lstStyle/>
-          <a:p>
-            <a:pPr indent="0" marL="0">
-              <a:lnSpc>
-                <a:spcPct val="102000"/>
-              </a:lnSpc>
-              <a:buNone/>
-            </a:pPr>
-            <a:r>
-              <a:rPr lang="en-US" sz="1050" dirty="0">
-                <a:solidFill>
-                  <a:srgbClr val="2B3A55"/>
-                </a:solidFill>
-                <a:latin typeface="Inter" pitchFamily="34" charset="0"/>
-                <a:ea typeface="Inter" pitchFamily="34" charset="-122"/>
-                <a:cs typeface="Inter" pitchFamily="34" charset="-120"/>
-              </a:rPr>
-              <a:t>tu código ejecuta la tool</a:t>
-            </a:r>
-            <a:endParaRPr lang="en-US" sz="1050" dirty="0"/>
-          </a:p>
-        </p:txBody>
-      </p:sp>
-      <p:sp>
-        <p:nvSpPr>
-          <p:cNvPr id="29" name="Shape 27"/>
-          <p:cNvSpPr/>
-          <p:nvPr/>
-        </p:nvSpPr>
-        <p:spPr>
-          <a:xfrm>
-            <a:off x="4356506" y="3657600"/>
-            <a:ext cx="3478682" cy="1325880"/>
-          </a:xfrm>
-          <a:prstGeom prst="roundRect">
-            <a:avLst>
-              <a:gd name="adj" fmla="val 5517"/>
-            </a:avLst>
-          </a:prstGeom>
-          <a:solidFill>
-            <a:srgbClr val="FFFFFF"/>
-          </a:solidFill>
-          <a:ln w="12700">
-            <a:solidFill>
-              <a:srgbClr val="DFE6F0"/>
-            </a:solidFill>
-            <a:prstDash val="solid"/>
-          </a:ln>
-        </p:spPr>
-      </p:sp>
-      <p:sp>
-        <p:nvSpPr>
-          <p:cNvPr id="30" name="Shape 28"/>
-          <p:cNvSpPr/>
-          <p:nvPr/>
-        </p:nvSpPr>
-        <p:spPr>
-          <a:xfrm>
-            <a:off x="4356506" y="3657600"/>
-            <a:ext cx="3478682" cy="64008"/>
-          </a:xfrm>
-          <a:prstGeom prst="roundRect">
-            <a:avLst>
-              <a:gd name="adj" fmla="val 42857"/>
-            </a:avLst>
-          </a:prstGeom>
-          <a:solidFill>
-            <a:srgbClr val="1E9BD7"/>
-          </a:solidFill>
-          <a:ln w="12700">
-            <a:solidFill>
-              <a:srgbClr val="333333"/>
-            </a:solidFill>
-            <a:prstDash val="solid"/>
-          </a:ln>
-        </p:spPr>
-      </p:sp>
-      <p:sp>
-        <p:nvSpPr>
-          <p:cNvPr id="31" name="Text 29"/>
-          <p:cNvSpPr/>
-          <p:nvPr/>
-        </p:nvSpPr>
-        <p:spPr>
-          <a:xfrm>
-            <a:off x="4575962" y="3822192"/>
-            <a:ext cx="548640" cy="457200"/>
-          </a:xfrm>
-          <a:prstGeom prst="rect">
-            <a:avLst/>
-          </a:prstGeom>
-          <a:noFill/>
-          <a:ln/>
-        </p:spPr>
-        <p:txBody>
-          <a:bodyPr wrap="square" rtlCol="0" anchor="ctr"/>
-          <a:lstStyle/>
-          <a:p>
-            <a:pPr indent="0" marL="0">
-              <a:buNone/>
-            </a:pPr>
-            <a:r>
-              <a:rPr lang="en-US" sz="2400" b="1" dirty="0">
-                <a:solidFill>
-                  <a:srgbClr val="1E9BD7"/>
-                </a:solidFill>
-                <a:latin typeface="Montserrat" pitchFamily="34" charset="0"/>
-                <a:ea typeface="Montserrat" pitchFamily="34" charset="-122"/>
-                <a:cs typeface="Montserrat" pitchFamily="34" charset="-120"/>
-              </a:rPr>
-              <a:t>5</a:t>
-            </a:r>
-            <a:endParaRPr lang="en-US" sz="2400" dirty="0"/>
-          </a:p>
-        </p:txBody>
-      </p:sp>
-      <p:sp>
-        <p:nvSpPr>
-          <p:cNvPr id="32" name="Text 30"/>
-          <p:cNvSpPr/>
-          <p:nvPr/>
-        </p:nvSpPr>
-        <p:spPr>
-          <a:xfrm>
-            <a:off x="5124602" y="3877056"/>
-            <a:ext cx="2518562" cy="457200"/>
-          </a:xfrm>
-          <a:prstGeom prst="rect">
-            <a:avLst/>
-          </a:prstGeom>
-          <a:noFill/>
-          <a:ln/>
-        </p:spPr>
-        <p:txBody>
-          <a:bodyPr wrap="square" rtlCol="0" anchor="ctr"/>
-          <a:lstStyle/>
-          <a:p>
-            <a:pPr indent="0" marL="0">
-              <a:buNone/>
-            </a:pPr>
-            <a:r>
-              <a:rPr lang="en-US" sz="1600" b="1" dirty="0">
-                <a:solidFill>
-                  <a:srgbClr val="0F1B33"/>
-                </a:solidFill>
-                <a:latin typeface="Montserrat" pitchFamily="34" charset="0"/>
-                <a:ea typeface="Montserrat" pitchFamily="34" charset="-122"/>
-                <a:cs typeface="Montserrat" pitchFamily="34" charset="-120"/>
-              </a:rPr>
-              <a:t>Observa</a:t>
-            </a:r>
-            <a:endParaRPr lang="en-US" sz="1600" dirty="0"/>
-          </a:p>
-        </p:txBody>
-      </p:sp>
-      <p:sp>
-        <p:nvSpPr>
-          <p:cNvPr id="33" name="Text 31"/>
-          <p:cNvSpPr/>
-          <p:nvPr/>
-        </p:nvSpPr>
-        <p:spPr>
-          <a:xfrm>
-            <a:off x="5124602" y="4315968"/>
-            <a:ext cx="2518562" cy="548640"/>
-          </a:xfrm>
-          <a:prstGeom prst="rect">
-            <a:avLst/>
-          </a:prstGeom>
-          <a:noFill/>
-          <a:ln/>
-        </p:spPr>
-        <p:txBody>
-          <a:bodyPr wrap="square" rtlCol="0" anchor="t"/>
-          <a:lstStyle/>
-          <a:p>
-            <a:pPr indent="0" marL="0">
-              <a:lnSpc>
-                <a:spcPct val="102000"/>
-              </a:lnSpc>
-              <a:buNone/>
-            </a:pPr>
-            <a:r>
-              <a:rPr lang="en-US" sz="1050" dirty="0">
-                <a:solidFill>
-                  <a:srgbClr val="2B3A55"/>
-                </a:solidFill>
-                <a:latin typeface="Inter" pitchFamily="34" charset="0"/>
-                <a:ea typeface="Inter" pitchFamily="34" charset="-122"/>
-                <a:cs typeface="Inter" pitchFamily="34" charset="-120"/>
-              </a:rPr>
-              <a:t>el resultado vuelve al modelo</a:t>
-            </a:r>
-            <a:endParaRPr lang="en-US" sz="1050" dirty="0"/>
-          </a:p>
-        </p:txBody>
-      </p:sp>
-      <p:sp>
-        <p:nvSpPr>
-          <p:cNvPr id="34" name="Shape 32"/>
-          <p:cNvSpPr/>
-          <p:nvPr/>
-        </p:nvSpPr>
-        <p:spPr>
-          <a:xfrm>
-            <a:off x="8054645" y="3657600"/>
-            <a:ext cx="3478682" cy="1325880"/>
-          </a:xfrm>
-          <a:prstGeom prst="roundRect">
-            <a:avLst>
-              <a:gd name="adj" fmla="val 5517"/>
-            </a:avLst>
-          </a:prstGeom>
-          <a:solidFill>
-            <a:srgbClr val="FFFFFF"/>
-          </a:solidFill>
-          <a:ln w="12700">
-            <a:solidFill>
-              <a:srgbClr val="DFE6F0"/>
-            </a:solidFill>
-            <a:prstDash val="solid"/>
-          </a:ln>
-        </p:spPr>
-      </p:sp>
-      <p:sp>
-        <p:nvSpPr>
-          <p:cNvPr id="35" name="Shape 33"/>
-          <p:cNvSpPr/>
-          <p:nvPr/>
-        </p:nvSpPr>
-        <p:spPr>
-          <a:xfrm>
-            <a:off x="8054645" y="3657600"/>
-            <a:ext cx="3478682" cy="64008"/>
-          </a:xfrm>
-          <a:prstGeom prst="roundRect">
-            <a:avLst>
-              <a:gd name="adj" fmla="val 42857"/>
-            </a:avLst>
-          </a:prstGeom>
-          <a:solidFill>
-            <a:srgbClr val="12245B"/>
-          </a:solidFill>
-          <a:ln w="12700">
-            <a:solidFill>
-              <a:srgbClr val="333333"/>
-            </a:solidFill>
-            <a:prstDash val="solid"/>
-          </a:ln>
-        </p:spPr>
-      </p:sp>
-      <p:sp>
-        <p:nvSpPr>
-          <p:cNvPr id="36" name="Text 34"/>
-          <p:cNvSpPr/>
-          <p:nvPr/>
-        </p:nvSpPr>
-        <p:spPr>
-          <a:xfrm>
-            <a:off x="8274101" y="3822192"/>
-            <a:ext cx="548640" cy="457200"/>
-          </a:xfrm>
-          <a:prstGeom prst="rect">
-            <a:avLst/>
-          </a:prstGeom>
-          <a:noFill/>
-          <a:ln/>
-        </p:spPr>
-        <p:txBody>
-          <a:bodyPr wrap="square" rtlCol="0" anchor="ctr"/>
-          <a:lstStyle/>
-          <a:p>
-            <a:pPr indent="0" marL="0">
-              <a:buNone/>
-            </a:pPr>
-            <a:r>
-              <a:rPr lang="en-US" sz="2400" b="1" dirty="0">
-                <a:solidFill>
-                  <a:srgbClr val="12245B"/>
-                </a:solidFill>
-                <a:latin typeface="Montserrat" pitchFamily="34" charset="0"/>
-                <a:ea typeface="Montserrat" pitchFamily="34" charset="-122"/>
-                <a:cs typeface="Montserrat" pitchFamily="34" charset="-120"/>
-              </a:rPr>
-              <a:t>6</a:t>
-            </a:r>
-            <a:endParaRPr lang="en-US" sz="2400" dirty="0"/>
-          </a:p>
-        </p:txBody>
-      </p:sp>
-      <p:sp>
-        <p:nvSpPr>
-          <p:cNvPr id="37" name="Text 35"/>
-          <p:cNvSpPr/>
-          <p:nvPr/>
-        </p:nvSpPr>
-        <p:spPr>
-          <a:xfrm>
-            <a:off x="8822741" y="3877056"/>
-            <a:ext cx="2518562" cy="457200"/>
-          </a:xfrm>
-          <a:prstGeom prst="rect">
-            <a:avLst/>
-          </a:prstGeom>
-          <a:noFill/>
-          <a:ln/>
-        </p:spPr>
-        <p:txBody>
-          <a:bodyPr wrap="square" rtlCol="0" anchor="ctr"/>
-          <a:lstStyle/>
-          <a:p>
-            <a:pPr indent="0" marL="0">
-              <a:buNone/>
-            </a:pPr>
-            <a:r>
-              <a:rPr lang="en-US" sz="1600" b="1" dirty="0">
-                <a:solidFill>
-                  <a:srgbClr val="0F1B33"/>
-                </a:solidFill>
-                <a:latin typeface="Montserrat" pitchFamily="34" charset="0"/>
-                <a:ea typeface="Montserrat" pitchFamily="34" charset="-122"/>
-                <a:cs typeface="Montserrat" pitchFamily="34" charset="-120"/>
-              </a:rPr>
-              <a:t>Termina</a:t>
-            </a:r>
-            <a:endParaRPr lang="en-US" sz="1600" dirty="0"/>
-          </a:p>
-        </p:txBody>
-      </p:sp>
-      <p:sp>
-        <p:nvSpPr>
-          <p:cNvPr id="38" name="Text 36"/>
-          <p:cNvSpPr/>
-          <p:nvPr/>
-        </p:nvSpPr>
-        <p:spPr>
-          <a:xfrm>
-            <a:off x="8822741" y="4315968"/>
-            <a:ext cx="2518562" cy="548640"/>
-          </a:xfrm>
-          <a:prstGeom prst="rect">
-            <a:avLst/>
-          </a:prstGeom>
-          <a:noFill/>
-          <a:ln/>
-        </p:spPr>
-        <p:txBody>
-          <a:bodyPr wrap="square" rtlCol="0" anchor="t"/>
-          <a:lstStyle/>
-          <a:p>
-            <a:pPr indent="0" marL="0">
-              <a:lnSpc>
-                <a:spcPct val="102000"/>
-              </a:lnSpc>
-              <a:buNone/>
-            </a:pPr>
-            <a:r>
-              <a:rPr lang="en-US" sz="1050" dirty="0">
-                <a:solidFill>
-                  <a:srgbClr val="2B3A55"/>
-                </a:solidFill>
-                <a:latin typeface="Inter" pitchFamily="34" charset="0"/>
-                <a:ea typeface="Inter" pitchFamily="34" charset="-122"/>
-                <a:cs typeface="Inter" pitchFamily="34" charset="-120"/>
-              </a:rPr>
-              <a:t>cuando no pide más tools</a:t>
-            </a:r>
-            <a:endParaRPr lang="en-US" sz="1050" dirty="0"/>
-          </a:p>
-        </p:txBody>
-      </p:sp>
-      <p:sp>
-        <p:nvSpPr>
-          <p:cNvPr id="39" name="Text 37"/>
-          <p:cNvSpPr/>
-          <p:nvPr/>
-        </p:nvSpPr>
-        <p:spPr>
-          <a:xfrm>
-            <a:off x="658368" y="5349240"/>
+      <p:pic>
+        <p:nvPicPr>
+          <p:cNvPr id="9" name="Image 0" descr="/home/jamaya/PiuraAI/fundamentos-agentes/assets/img/diagram-loop.png">    </p:cNvPr>
+          <p:cNvPicPr>
+            <a:picLocks noChangeAspect="1"/>
+          </p:cNvPicPr>
+          <p:nvPr/>
+        </p:nvPicPr>
+        <p:blipFill>
+          <a:blip r:embed="rId1"/>
+          <a:srcRect l="0" r="0" t="0" b="0"/>
+          <a:stretch/>
+        </p:blipFill>
+        <p:spPr>
+          <a:xfrm>
+            <a:off x="993048" y="2011680"/>
+            <a:ext cx="10205600" cy="3474720"/>
+          </a:xfrm>
+          <a:prstGeom prst="rect">
+            <a:avLst/>
+          </a:prstGeom>
+        </p:spPr>
+      </p:pic>
+      <p:sp>
+        <p:nvSpPr>
+          <p:cNvPr id="10" name="Text 7"/>
+          <p:cNvSpPr/>
+          <p:nvPr/>
+        </p:nvSpPr>
+        <p:spPr>
+          <a:xfrm>
+            <a:off x="658368" y="5577840"/>
             <a:ext cx="10874959" cy="457200"/>
           </a:xfrm>
           <a:prstGeom prst="rect">
@@ -25831,537 +22374,38 @@
           </a:p>
         </p:txBody>
       </p:sp>
-      <p:sp>
-        <p:nvSpPr>
-          <p:cNvPr id="8" name="Shape 6"/>
-          <p:cNvSpPr/>
-          <p:nvPr/>
-        </p:nvSpPr>
-        <p:spPr>
-          <a:xfrm>
-            <a:off x="658368" y="2103120"/>
-            <a:ext cx="3478682" cy="2743200"/>
-          </a:xfrm>
-          <a:prstGeom prst="roundRect">
-            <a:avLst>
-              <a:gd name="adj" fmla="val 2667"/>
-            </a:avLst>
-          </a:prstGeom>
-          <a:solidFill>
-            <a:srgbClr val="FFFFFF"/>
-          </a:solidFill>
-          <a:ln w="12700">
-            <a:solidFill>
-              <a:srgbClr val="DFE6F0"/>
-            </a:solidFill>
-            <a:prstDash val="solid"/>
-          </a:ln>
-        </p:spPr>
-      </p:sp>
-      <p:sp>
-        <p:nvSpPr>
-          <p:cNvPr id="9" name="Shape 7"/>
-          <p:cNvSpPr/>
-          <p:nvPr/>
-        </p:nvSpPr>
-        <p:spPr>
-          <a:xfrm>
-            <a:off x="658368" y="2103120"/>
-            <a:ext cx="3478682" cy="73152"/>
-          </a:xfrm>
-          <a:prstGeom prst="roundRect">
-            <a:avLst>
-              <a:gd name="adj" fmla="val 37500"/>
-            </a:avLst>
-          </a:prstGeom>
-          <a:solidFill>
-            <a:srgbClr val="1E9BD7"/>
-          </a:solidFill>
-          <a:ln w="12700">
-            <a:solidFill>
-              <a:srgbClr val="333333"/>
-            </a:solidFill>
-            <a:prstDash val="solid"/>
-          </a:ln>
-        </p:spPr>
-      </p:sp>
-      <p:sp>
-        <p:nvSpPr>
-          <p:cNvPr id="10" name="Text 8"/>
-          <p:cNvSpPr/>
-          <p:nvPr/>
-        </p:nvSpPr>
-        <p:spPr>
-          <a:xfrm>
-            <a:off x="932688" y="2331720"/>
-            <a:ext cx="914400" cy="548640"/>
-          </a:xfrm>
-          <a:prstGeom prst="rect">
-            <a:avLst/>
-          </a:prstGeom>
-          <a:noFill/>
-          <a:ln/>
-        </p:spPr>
-        <p:txBody>
-          <a:bodyPr wrap="square" rtlCol="0" anchor="ctr"/>
-          <a:lstStyle/>
-          <a:p>
-            <a:pPr indent="0" marL="0">
-              <a:buNone/>
-            </a:pPr>
-            <a:r>
-              <a:rPr lang="en-US" sz="3200" b="1" dirty="0">
-                <a:solidFill>
-                  <a:srgbClr val="1E9BD7"/>
-                </a:solidFill>
-                <a:latin typeface="Montserrat" pitchFamily="34" charset="0"/>
-                <a:ea typeface="Montserrat" pitchFamily="34" charset="-122"/>
-                <a:cs typeface="Montserrat" pitchFamily="34" charset="-120"/>
-              </a:rPr>
-              <a:t>1</a:t>
-            </a:r>
-            <a:endParaRPr lang="en-US" sz="3200" dirty="0"/>
-          </a:p>
-        </p:txBody>
-      </p:sp>
-      <p:sp>
-        <p:nvSpPr>
-          <p:cNvPr id="11" name="Text 9"/>
-          <p:cNvSpPr/>
-          <p:nvPr/>
-        </p:nvSpPr>
-        <p:spPr>
-          <a:xfrm>
-            <a:off x="932688" y="3063240"/>
-            <a:ext cx="2930042" cy="640080"/>
-          </a:xfrm>
-          <a:prstGeom prst="rect">
-            <a:avLst/>
-          </a:prstGeom>
-          <a:noFill/>
-          <a:ln/>
-        </p:spPr>
-        <p:txBody>
-          <a:bodyPr wrap="square" rtlCol="0" anchor="t"/>
-          <a:lstStyle/>
-          <a:p>
-            <a:pPr indent="0" marL="0">
-              <a:buNone/>
-            </a:pPr>
-            <a:r>
-              <a:rPr lang="en-US" sz="1600" b="1" dirty="0">
-                <a:solidFill>
-                  <a:srgbClr val="0F1B33"/>
-                </a:solidFill>
-                <a:latin typeface="Montserrat" pitchFamily="34" charset="0"/>
-                <a:ea typeface="Montserrat" pitchFamily="34" charset="-122"/>
-                <a:cs typeface="Montserrat" pitchFamily="34" charset="-120"/>
-              </a:rPr>
-              <a:t>Le presentas un contrato</a:t>
-            </a:r>
-            <a:endParaRPr lang="en-US" sz="1600" dirty="0"/>
-          </a:p>
-        </p:txBody>
-      </p:sp>
-      <p:sp>
-        <p:nvSpPr>
-          <p:cNvPr id="12" name="Text 10"/>
-          <p:cNvSpPr/>
-          <p:nvPr/>
-        </p:nvSpPr>
-        <p:spPr>
-          <a:xfrm>
-            <a:off x="932688" y="3794760"/>
-            <a:ext cx="2930042" cy="914400"/>
-          </a:xfrm>
-          <a:prstGeom prst="rect">
-            <a:avLst/>
-          </a:prstGeom>
-          <a:noFill/>
-          <a:ln/>
-        </p:spPr>
-        <p:txBody>
-          <a:bodyPr wrap="square" rtlCol="0" anchor="t"/>
-          <a:lstStyle/>
-          <a:p>
-            <a:pPr indent="0" marL="0">
-              <a:lnSpc>
-                <a:spcPct val="105000"/>
-              </a:lnSpc>
-              <a:buNone/>
-            </a:pPr>
-            <a:r>
-              <a:rPr lang="en-US" sz="1200" dirty="0">
-                <a:solidFill>
-                  <a:srgbClr val="2B3A55"/>
-                </a:solidFill>
-                <a:latin typeface="Inter" pitchFamily="34" charset="0"/>
-                <a:ea typeface="Inter" pitchFamily="34" charset="-122"/>
-                <a:cs typeface="Inter" pitchFamily="34" charset="-120"/>
-              </a:rPr>
-              <a:t>Nombre, parámetros y descripción. Viajan en la petición (tools=): eso es lo que el modelo ve.</a:t>
-            </a:r>
-            <a:endParaRPr lang="en-US" sz="1200" dirty="0"/>
-          </a:p>
-        </p:txBody>
-      </p:sp>
-      <p:sp>
-        <p:nvSpPr>
-          <p:cNvPr id="13" name="Shape 11"/>
-          <p:cNvSpPr/>
-          <p:nvPr/>
-        </p:nvSpPr>
-        <p:spPr>
-          <a:xfrm>
-            <a:off x="4356506" y="2103120"/>
-            <a:ext cx="3478682" cy="2743200"/>
-          </a:xfrm>
-          <a:prstGeom prst="roundRect">
-            <a:avLst>
-              <a:gd name="adj" fmla="val 2667"/>
-            </a:avLst>
-          </a:prstGeom>
-          <a:solidFill>
-            <a:srgbClr val="FFFFFF"/>
-          </a:solidFill>
-          <a:ln w="12700">
-            <a:solidFill>
-              <a:srgbClr val="DFE6F0"/>
-            </a:solidFill>
-            <a:prstDash val="solid"/>
-          </a:ln>
-        </p:spPr>
-      </p:sp>
-      <p:sp>
-        <p:nvSpPr>
-          <p:cNvPr id="14" name="Shape 12"/>
-          <p:cNvSpPr/>
-          <p:nvPr/>
-        </p:nvSpPr>
-        <p:spPr>
-          <a:xfrm>
-            <a:off x="4356506" y="2103120"/>
-            <a:ext cx="3478682" cy="73152"/>
-          </a:xfrm>
-          <a:prstGeom prst="roundRect">
-            <a:avLst>
-              <a:gd name="adj" fmla="val 37500"/>
-            </a:avLst>
-          </a:prstGeom>
-          <a:solidFill>
-            <a:srgbClr val="D9820A"/>
-          </a:solidFill>
-          <a:ln w="12700">
-            <a:solidFill>
-              <a:srgbClr val="333333"/>
-            </a:solidFill>
-            <a:prstDash val="solid"/>
-          </a:ln>
-        </p:spPr>
-      </p:sp>
-      <p:sp>
-        <p:nvSpPr>
-          <p:cNvPr id="15" name="Text 13"/>
-          <p:cNvSpPr/>
-          <p:nvPr/>
-        </p:nvSpPr>
-        <p:spPr>
-          <a:xfrm>
-            <a:off x="4630826" y="2331720"/>
-            <a:ext cx="914400" cy="548640"/>
-          </a:xfrm>
-          <a:prstGeom prst="rect">
-            <a:avLst/>
-          </a:prstGeom>
-          <a:noFill/>
-          <a:ln/>
-        </p:spPr>
-        <p:txBody>
-          <a:bodyPr wrap="square" rtlCol="0" anchor="ctr"/>
-          <a:lstStyle/>
-          <a:p>
-            <a:pPr indent="0" marL="0">
-              <a:buNone/>
-            </a:pPr>
-            <a:r>
-              <a:rPr lang="en-US" sz="3200" b="1" dirty="0">
-                <a:solidFill>
-                  <a:srgbClr val="D9820A"/>
-                </a:solidFill>
-                <a:latin typeface="Montserrat" pitchFamily="34" charset="0"/>
-                <a:ea typeface="Montserrat" pitchFamily="34" charset="-122"/>
-                <a:cs typeface="Montserrat" pitchFamily="34" charset="-120"/>
-              </a:rPr>
-              <a:t>2</a:t>
-            </a:r>
-            <a:endParaRPr lang="en-US" sz="3200" dirty="0"/>
-          </a:p>
-        </p:txBody>
-      </p:sp>
-      <p:sp>
-        <p:nvSpPr>
-          <p:cNvPr id="16" name="Text 14"/>
-          <p:cNvSpPr/>
-          <p:nvPr/>
-        </p:nvSpPr>
-        <p:spPr>
-          <a:xfrm>
-            <a:off x="4630826" y="3063240"/>
-            <a:ext cx="2930042" cy="640080"/>
-          </a:xfrm>
-          <a:prstGeom prst="rect">
-            <a:avLst/>
-          </a:prstGeom>
-          <a:noFill/>
-          <a:ln/>
-        </p:spPr>
-        <p:txBody>
-          <a:bodyPr wrap="square" rtlCol="0" anchor="t"/>
-          <a:lstStyle/>
-          <a:p>
-            <a:pPr indent="0" marL="0">
-              <a:buNone/>
-            </a:pPr>
-            <a:r>
-              <a:rPr lang="en-US" sz="1600" b="1" dirty="0">
-                <a:solidFill>
-                  <a:srgbClr val="0F1B33"/>
-                </a:solidFill>
-                <a:latin typeface="Montserrat" pitchFamily="34" charset="0"/>
-                <a:ea typeface="Montserrat" pitchFamily="34" charset="-122"/>
-                <a:cs typeface="Montserrat" pitchFamily="34" charset="-120"/>
-              </a:rPr>
-              <a:t>El modelo pide</a:t>
-            </a:r>
-            <a:endParaRPr lang="en-US" sz="1600" dirty="0"/>
-          </a:p>
-        </p:txBody>
-      </p:sp>
-      <p:sp>
-        <p:nvSpPr>
-          <p:cNvPr id="17" name="Text 15"/>
-          <p:cNvSpPr/>
-          <p:nvPr/>
-        </p:nvSpPr>
-        <p:spPr>
-          <a:xfrm>
-            <a:off x="4630826" y="3794760"/>
-            <a:ext cx="2930042" cy="914400"/>
-          </a:xfrm>
-          <a:prstGeom prst="rect">
-            <a:avLst/>
-          </a:prstGeom>
-          <a:noFill/>
-          <a:ln/>
-        </p:spPr>
-        <p:txBody>
-          <a:bodyPr wrap="square" rtlCol="0" anchor="t"/>
-          <a:lstStyle/>
-          <a:p>
-            <a:pPr indent="0" marL="0">
-              <a:lnSpc>
-                <a:spcPct val="105000"/>
-              </a:lnSpc>
-              <a:buNone/>
-            </a:pPr>
-            <a:r>
-              <a:rPr lang="en-US" sz="1200" dirty="0">
-                <a:solidFill>
-                  <a:srgbClr val="2B3A55"/>
-                </a:solidFill>
-                <a:latin typeface="Inter" pitchFamily="34" charset="0"/>
-                <a:ea typeface="Inter" pitchFamily="34" charset="-122"/>
-                <a:cs typeface="Inter" pitchFamily="34" charset="-120"/>
-              </a:rPr>
-              <a:t>Devuelve una petición: "llama a execute_sql con query=...". No ejecuta nada.</a:t>
-            </a:r>
-            <a:endParaRPr lang="en-US" sz="1200" dirty="0"/>
-          </a:p>
-        </p:txBody>
-      </p:sp>
-      <p:sp>
-        <p:nvSpPr>
-          <p:cNvPr id="18" name="Shape 16"/>
-          <p:cNvSpPr/>
-          <p:nvPr/>
-        </p:nvSpPr>
-        <p:spPr>
-          <a:xfrm>
-            <a:off x="8054645" y="2103120"/>
-            <a:ext cx="3478682" cy="2743200"/>
-          </a:xfrm>
-          <a:prstGeom prst="roundRect">
-            <a:avLst>
-              <a:gd name="adj" fmla="val 2667"/>
-            </a:avLst>
-          </a:prstGeom>
-          <a:solidFill>
-            <a:srgbClr val="FFFFFF"/>
-          </a:solidFill>
-          <a:ln w="12700">
-            <a:solidFill>
-              <a:srgbClr val="DFE6F0"/>
-            </a:solidFill>
-            <a:prstDash val="solid"/>
-          </a:ln>
-        </p:spPr>
-      </p:sp>
-      <p:sp>
-        <p:nvSpPr>
-          <p:cNvPr id="19" name="Shape 17"/>
-          <p:cNvSpPr/>
-          <p:nvPr/>
-        </p:nvSpPr>
-        <p:spPr>
-          <a:xfrm>
-            <a:off x="8054645" y="2103120"/>
-            <a:ext cx="3478682" cy="73152"/>
-          </a:xfrm>
-          <a:prstGeom prst="roundRect">
-            <a:avLst>
-              <a:gd name="adj" fmla="val 37500"/>
-            </a:avLst>
-          </a:prstGeom>
-          <a:solidFill>
-            <a:srgbClr val="4FA82F"/>
-          </a:solidFill>
-          <a:ln w="12700">
-            <a:solidFill>
-              <a:srgbClr val="333333"/>
-            </a:solidFill>
-            <a:prstDash val="solid"/>
-          </a:ln>
-        </p:spPr>
-      </p:sp>
-      <p:sp>
-        <p:nvSpPr>
-          <p:cNvPr id="20" name="Text 18"/>
-          <p:cNvSpPr/>
-          <p:nvPr/>
-        </p:nvSpPr>
-        <p:spPr>
-          <a:xfrm>
-            <a:off x="8328965" y="2331720"/>
-            <a:ext cx="914400" cy="548640"/>
-          </a:xfrm>
-          <a:prstGeom prst="rect">
-            <a:avLst/>
-          </a:prstGeom>
-          <a:noFill/>
-          <a:ln/>
-        </p:spPr>
-        <p:txBody>
-          <a:bodyPr wrap="square" rtlCol="0" anchor="ctr"/>
-          <a:lstStyle/>
-          <a:p>
-            <a:pPr indent="0" marL="0">
-              <a:buNone/>
-            </a:pPr>
-            <a:r>
-              <a:rPr lang="en-US" sz="3200" b="1" dirty="0">
-                <a:solidFill>
-                  <a:srgbClr val="4FA82F"/>
-                </a:solidFill>
-                <a:latin typeface="Montserrat" pitchFamily="34" charset="0"/>
-                <a:ea typeface="Montserrat" pitchFamily="34" charset="-122"/>
-                <a:cs typeface="Montserrat" pitchFamily="34" charset="-120"/>
-              </a:rPr>
-              <a:t>3</a:t>
-            </a:r>
-            <a:endParaRPr lang="en-US" sz="3200" dirty="0"/>
-          </a:p>
-        </p:txBody>
-      </p:sp>
-      <p:sp>
-        <p:nvSpPr>
-          <p:cNvPr id="21" name="Text 19"/>
-          <p:cNvSpPr/>
-          <p:nvPr/>
-        </p:nvSpPr>
-        <p:spPr>
-          <a:xfrm>
-            <a:off x="8328965" y="3063240"/>
-            <a:ext cx="2930042" cy="640080"/>
-          </a:xfrm>
-          <a:prstGeom prst="rect">
-            <a:avLst/>
-          </a:prstGeom>
-          <a:noFill/>
-          <a:ln/>
-        </p:spPr>
-        <p:txBody>
-          <a:bodyPr wrap="square" rtlCol="0" anchor="t"/>
-          <a:lstStyle/>
-          <a:p>
-            <a:pPr indent="0" marL="0">
-              <a:buNone/>
-            </a:pPr>
-            <a:r>
-              <a:rPr lang="en-US" sz="1600" b="1" dirty="0">
-                <a:solidFill>
-                  <a:srgbClr val="0F1B33"/>
-                </a:solidFill>
-                <a:latin typeface="Montserrat" pitchFamily="34" charset="0"/>
-                <a:ea typeface="Montserrat" pitchFamily="34" charset="-122"/>
-                <a:cs typeface="Montserrat" pitchFamily="34" charset="-120"/>
-              </a:rPr>
-              <a:t>Tu código ejecuta</a:t>
-            </a:r>
-            <a:endParaRPr lang="en-US" sz="1600" dirty="0"/>
-          </a:p>
-        </p:txBody>
-      </p:sp>
-      <p:sp>
-        <p:nvSpPr>
-          <p:cNvPr id="22" name="Text 20"/>
-          <p:cNvSpPr/>
-          <p:nvPr/>
-        </p:nvSpPr>
-        <p:spPr>
-          <a:xfrm>
-            <a:off x="8328965" y="3794760"/>
-            <a:ext cx="2930042" cy="914400"/>
-          </a:xfrm>
-          <a:prstGeom prst="rect">
-            <a:avLst/>
-          </a:prstGeom>
-          <a:noFill/>
-          <a:ln/>
-        </p:spPr>
-        <p:txBody>
-          <a:bodyPr wrap="square" rtlCol="0" anchor="t"/>
-          <a:lstStyle/>
-          <a:p>
-            <a:pPr indent="0" marL="0">
-              <a:lnSpc>
-                <a:spcPct val="105000"/>
-              </a:lnSpc>
-              <a:buNone/>
-            </a:pPr>
-            <a:r>
-              <a:rPr lang="en-US" sz="1200" dirty="0">
-                <a:solidFill>
-                  <a:srgbClr val="2B3A55"/>
-                </a:solidFill>
-                <a:latin typeface="Inter" pitchFamily="34" charset="0"/>
-                <a:ea typeface="Inter" pitchFamily="34" charset="-122"/>
-                <a:cs typeface="Inter" pitchFamily="34" charset="-120"/>
-              </a:rPr>
-              <a:t>Con tus permisos, tus límites y tu validación. El resultado vuelve como un mensaje.</a:t>
-            </a:r>
-            <a:endParaRPr lang="en-US" sz="1200" dirty="0"/>
-          </a:p>
-        </p:txBody>
-      </p:sp>
-      <p:sp>
-        <p:nvSpPr>
-          <p:cNvPr id="23" name="Text 21"/>
-          <p:cNvSpPr/>
-          <p:nvPr/>
-        </p:nvSpPr>
-        <p:spPr>
-          <a:xfrm>
-            <a:off x="658368" y="5120640"/>
+      <p:pic>
+        <p:nvPicPr>
+          <p:cNvPr id="8" name="Image 0" descr="/home/jamaya/PiuraAI/fundamentos-agentes/assets/img/diagram-toolcalling.png">    </p:cNvPr>
+          <p:cNvPicPr>
+            <a:picLocks noChangeAspect="1"/>
+          </p:cNvPicPr>
+          <p:nvPr/>
+        </p:nvPicPr>
+        <p:blipFill>
+          <a:blip r:embed="rId1"/>
+          <a:srcRect l="0" r="0" t="0" b="0"/>
+          <a:stretch/>
+        </p:blipFill>
+        <p:spPr>
+          <a:xfrm>
+            <a:off x="722593" y="1737360"/>
+            <a:ext cx="10746509" cy="3886200"/>
+          </a:xfrm>
+          <a:prstGeom prst="rect">
+            <a:avLst/>
+          </a:prstGeom>
+        </p:spPr>
+      </p:pic>
+      <p:sp>
+        <p:nvSpPr>
+          <p:cNvPr id="9" name="Text 6"/>
+          <p:cNvSpPr/>
+          <p:nvPr/>
+        </p:nvSpPr>
+        <p:spPr>
+          <a:xfrm>
+            <a:off x="658368" y="5715000"/>
             <a:ext cx="10874959" cy="457200"/>
           </a:xfrm>
           <a:prstGeom prst="rect">

</xml_diff>

<commit_message>
Slide 17: larger multi-line code and 3 cards
</commit_message>
<xml_diff>
--- a/agentes-de-ia/agentes-intro.pptx
+++ b/agentes-de-ia/agentes-intro.pptx
@@ -9227,12 +9227,12 @@
         </p:nvSpPr>
         <p:spPr>
           <a:xfrm>
-            <a:off x="658368" y="1828800"/>
-            <a:ext cx="10874959" cy="777240"/>
+            <a:off x="658368" y="2011680"/>
+            <a:ext cx="5486400" cy="3474720"/>
           </a:xfrm>
           <a:prstGeom prst="roundRect">
             <a:avLst>
-              <a:gd name="adj" fmla="val 9412"/>
+              <a:gd name="adj" fmla="val 2105"/>
             </a:avLst>
           </a:prstGeom>
           <a:solidFill>
@@ -9254,24 +9254,27 @@
         </p:nvSpPr>
         <p:spPr>
           <a:xfrm>
-            <a:off x="1024128" y="1828800"/>
-            <a:ext cx="10143439" cy="777240"/>
-          </a:xfrm>
-          <a:prstGeom prst="rect">
-            <a:avLst/>
-          </a:prstGeom>
-          <a:noFill/>
-          <a:ln/>
-        </p:spPr>
-        <p:txBody>
-          <a:bodyPr wrap="square" rtlCol="0" anchor="ctr"/>
-          <a:lstStyle/>
-          <a:p>
-            <a:pPr indent="0" marL="0">
-              <a:buNone/>
-            </a:pPr>
-            <a:r>
-              <a:rPr lang="en-US" sz="1250" dirty="0">
+            <a:off x="978408" y="2194560"/>
+            <a:ext cx="4846320" cy="3108960"/>
+          </a:xfrm>
+          <a:prstGeom prst="rect">
+            <a:avLst/>
+          </a:prstGeom>
+          <a:noFill/>
+          <a:ln/>
+        </p:spPr>
+        <p:txBody>
+          <a:bodyPr wrap="square" rtlCol="0" anchor="t"/>
+          <a:lstStyle/>
+          <a:p>
+            <a:pPr indent="0" marL="0">
+              <a:lnSpc>
+                <a:spcPct val="125000"/>
+              </a:lnSpc>
+              <a:buNone/>
+            </a:pPr>
+            <a:r>
+              <a:rPr lang="en-US" sz="1500" dirty="0">
                 <a:solidFill>
                   <a:srgbClr val="D7E2F0"/>
                 </a:solidFill>
@@ -9279,13 +9282,17 @@
                 <a:ea typeface="JetBrains Mono" pitchFamily="34" charset="-122"/>
                 <a:cs typeface="JetBrains Mono" pitchFamily="34" charset="-120"/>
               </a:rPr>
-              <a:t>agent = create_agent(</a:t>
-            </a:r>
-            <a:pPr indent="0" marL="0">
-              <a:buNone/>
-            </a:pPr>
-            <a:r>
-              <a:rPr lang="en-US" sz="1250" dirty="0">
+              <a:t>agent = create_agent(
+</a:t>
+            </a:r>
+            <a:pPr indent="0" marL="0">
+              <a:lnSpc>
+                <a:spcPct val="125000"/>
+              </a:lnSpc>
+              <a:buNone/>
+            </a:pPr>
+            <a:r>
+              <a:rPr lang="en-US" sz="1500" dirty="0">
                 <a:solidFill>
                   <a:srgbClr val="38BDF8"/>
                 </a:solidFill>
@@ -9293,13 +9300,16 @@
                 <a:ea typeface="JetBrains Mono" pitchFamily="34" charset="-122"/>
                 <a:cs typeface="JetBrains Mono" pitchFamily="34" charset="-120"/>
               </a:rPr>
-              <a:t>model=</a:t>
-            </a:r>
-            <a:pPr indent="0" marL="0">
-              <a:buNone/>
-            </a:pPr>
-            <a:r>
-              <a:rPr lang="en-US" sz="1250" dirty="0">
+              <a:t>    model=</a:t>
+            </a:r>
+            <a:pPr indent="0" marL="0">
+              <a:lnSpc>
+                <a:spcPct val="125000"/>
+              </a:lnSpc>
+              <a:buNone/>
+            </a:pPr>
+            <a:r>
+              <a:rPr lang="en-US" sz="1500" dirty="0">
                 <a:solidFill>
                   <a:srgbClr val="7AC943"/>
                 </a:solidFill>
@@ -9307,107 +9317,97 @@
                 <a:ea typeface="JetBrains Mono" pitchFamily="34" charset="-122"/>
                 <a:cs typeface="JetBrains Mono" pitchFamily="34" charset="-120"/>
               </a:rPr>
-              <a:t>"openai:gpt-5"</a:t>
-            </a:r>
-            <a:pPr indent="0" marL="0">
-              <a:buNone/>
-            </a:pPr>
-            <a:r>
-              <a:rPr lang="en-US" sz="1250" dirty="0">
-                <a:solidFill>
-                  <a:srgbClr val="D7E2F0"/>
+              <a:t>"openai:gpt-5",
+</a:t>
+            </a:r>
+            <a:pPr indent="0" marL="0">
+              <a:lnSpc>
+                <a:spcPct val="125000"/>
+              </a:lnSpc>
+              <a:buNone/>
+            </a:pPr>
+            <a:r>
+              <a:rPr lang="en-US" sz="1500" dirty="0">
+                <a:solidFill>
+                  <a:srgbClr val="38BDF8"/>
                 </a:solidFill>
                 <a:latin typeface="JetBrains Mono" pitchFamily="34" charset="0"/>
                 <a:ea typeface="JetBrains Mono" pitchFamily="34" charset="-122"/>
                 <a:cs typeface="JetBrains Mono" pitchFamily="34" charset="-120"/>
               </a:rPr>
-              <a:t>, </a:t>
-            </a:r>
-            <a:pPr indent="0" marL="0">
-              <a:buNone/>
-            </a:pPr>
-            <a:r>
-              <a:rPr lang="en-US" sz="1250" dirty="0">
-                <a:solidFill>
-                  <a:srgbClr val="38BDF8"/>
+              <a:t>    tools=</a:t>
+            </a:r>
+            <a:pPr indent="0" marL="0">
+              <a:lnSpc>
+                <a:spcPct val="125000"/>
+              </a:lnSpc>
+              <a:buNone/>
+            </a:pPr>
+            <a:r>
+              <a:rPr lang="en-US" sz="1500" dirty="0">
+                <a:solidFill>
+                  <a:srgbClr val="7AC943"/>
                 </a:solidFill>
                 <a:latin typeface="JetBrains Mono" pitchFamily="34" charset="0"/>
                 <a:ea typeface="JetBrains Mono" pitchFamily="34" charset="-122"/>
                 <a:cs typeface="JetBrains Mono" pitchFamily="34" charset="-120"/>
               </a:rPr>
-              <a:t>tools=</a:t>
-            </a:r>
-            <a:pPr indent="0" marL="0">
-              <a:buNone/>
-            </a:pPr>
-            <a:r>
-              <a:rPr lang="en-US" sz="1250" dirty="0">
-                <a:solidFill>
-                  <a:srgbClr val="7AC943"/>
+              <a:t>[...],
+</a:t>
+            </a:r>
+            <a:pPr indent="0" marL="0">
+              <a:lnSpc>
+                <a:spcPct val="125000"/>
+              </a:lnSpc>
+              <a:buNone/>
+            </a:pPr>
+            <a:r>
+              <a:rPr lang="en-US" sz="1500" dirty="0">
+                <a:solidFill>
+                  <a:srgbClr val="38BDF8"/>
                 </a:solidFill>
                 <a:latin typeface="JetBrains Mono" pitchFamily="34" charset="0"/>
                 <a:ea typeface="JetBrains Mono" pitchFamily="34" charset="-122"/>
                 <a:cs typeface="JetBrains Mono" pitchFamily="34" charset="-120"/>
               </a:rPr>
-              <a:t>[...]</a:t>
-            </a:r>
-            <a:pPr indent="0" marL="0">
-              <a:buNone/>
-            </a:pPr>
-            <a:r>
-              <a:rPr lang="en-US" sz="1250" dirty="0">
-                <a:solidFill>
-                  <a:srgbClr val="D7E2F0"/>
+              <a:t>    system_prompt=</a:t>
+            </a:r>
+            <a:pPr indent="0" marL="0">
+              <a:lnSpc>
+                <a:spcPct val="125000"/>
+              </a:lnSpc>
+              <a:buNone/>
+            </a:pPr>
+            <a:r>
+              <a:rPr lang="en-US" sz="1500" dirty="0">
+                <a:solidFill>
+                  <a:srgbClr val="7AC943"/>
                 </a:solidFill>
                 <a:latin typeface="JetBrains Mono" pitchFamily="34" charset="0"/>
                 <a:ea typeface="JetBrains Mono" pitchFamily="34" charset="-122"/>
                 <a:cs typeface="JetBrains Mono" pitchFamily="34" charset="-120"/>
               </a:rPr>
-              <a:t>, </a:t>
-            </a:r>
-            <a:pPr indent="0" marL="0">
-              <a:buNone/>
-            </a:pPr>
-            <a:r>
-              <a:rPr lang="en-US" sz="1250" dirty="0">
-                <a:solidFill>
-                  <a:srgbClr val="38BDF8"/>
+              <a:t>"...",
+</a:t>
+            </a:r>
+            <a:pPr indent="0" marL="0">
+              <a:lnSpc>
+                <a:spcPct val="125000"/>
+              </a:lnSpc>
+              <a:buNone/>
+            </a:pPr>
+            <a:r>
+              <a:rPr lang="en-US" sz="1500" dirty="0">
+                <a:solidFill>
+                  <a:srgbClr val="D7E2F0"/>
                 </a:solidFill>
                 <a:latin typeface="JetBrains Mono" pitchFamily="34" charset="0"/>
                 <a:ea typeface="JetBrains Mono" pitchFamily="34" charset="-122"/>
                 <a:cs typeface="JetBrains Mono" pitchFamily="34" charset="-120"/>
               </a:rPr>
-              <a:t>system_prompt=</a:t>
-            </a:r>
-            <a:pPr indent="0" marL="0">
-              <a:buNone/>
-            </a:pPr>
-            <a:r>
-              <a:rPr lang="en-US" sz="1250" dirty="0">
-                <a:solidFill>
-                  <a:srgbClr val="7AC943"/>
-                </a:solidFill>
-                <a:latin typeface="JetBrains Mono" pitchFamily="34" charset="0"/>
-                <a:ea typeface="JetBrains Mono" pitchFamily="34" charset="-122"/>
-                <a:cs typeface="JetBrains Mono" pitchFamily="34" charset="-120"/>
-              </a:rPr>
-              <a:t>"..."</a:t>
-            </a:r>
-            <a:pPr indent="0" marL="0">
-              <a:buNone/>
-            </a:pPr>
-            <a:r>
-              <a:rPr lang="en-US" sz="1250" dirty="0">
-                <a:solidFill>
-                  <a:srgbClr val="D7E2F0"/>
-                </a:solidFill>
-                <a:latin typeface="JetBrains Mono" pitchFamily="34" charset="0"/>
-                <a:ea typeface="JetBrains Mono" pitchFamily="34" charset="-122"/>
-                <a:cs typeface="JetBrains Mono" pitchFamily="34" charset="-120"/>
-              </a:rPr>
               <a:t>)</a:t>
             </a:r>
-            <a:endParaRPr lang="en-US" sz="1250" dirty="0"/>
+            <a:endParaRPr lang="en-US" sz="1500" dirty="0"/>
           </a:p>
         </p:txBody>
       </p:sp>
@@ -9419,12 +9419,12 @@
         </p:nvSpPr>
         <p:spPr>
           <a:xfrm>
-            <a:off x="658368" y="2788920"/>
-            <a:ext cx="5327752" cy="914400"/>
+            <a:off x="6419088" y="2011680"/>
+            <a:ext cx="5114239" cy="1051560"/>
           </a:xfrm>
           <a:prstGeom prst="roundRect">
             <a:avLst>
-              <a:gd name="adj" fmla="val 6000"/>
+              <a:gd name="adj" fmla="val 5217"/>
             </a:avLst>
           </a:prstGeom>
           <a:solidFill>
@@ -9446,8 +9446,8 @@
         </p:nvSpPr>
         <p:spPr>
           <a:xfrm>
-            <a:off x="658368" y="2788920"/>
-            <a:ext cx="73152" cy="914400"/>
+            <a:off x="6419088" y="2011680"/>
+            <a:ext cx="73152" cy="1051560"/>
           </a:xfrm>
           <a:prstGeom prst="roundRect">
             <a:avLst>
@@ -9473,8 +9473,8 @@
         </p:nvSpPr>
         <p:spPr>
           <a:xfrm>
-            <a:off x="932688" y="2916936"/>
-            <a:ext cx="4870552" cy="365760"/>
+            <a:off x="6693408" y="2148840"/>
+            <a:ext cx="4657039" cy="365760"/>
           </a:xfrm>
           <a:prstGeom prst="rect">
             <a:avLst/>
@@ -9512,8 +9512,8 @@
         </p:nvSpPr>
         <p:spPr>
           <a:xfrm>
-            <a:off x="932688" y="3264408"/>
-            <a:ext cx="4870552" cy="411480"/>
+            <a:off x="6693408" y="2514600"/>
+            <a:ext cx="4657039" cy="457200"/>
           </a:xfrm>
           <a:prstGeom prst="rect">
             <a:avLst/>
@@ -9529,7 +9529,7 @@
               <a:buNone/>
             </a:pPr>
             <a:r>
-              <a:rPr lang="en-US" sz="1150" dirty="0">
+              <a:rPr lang="en-US" sz="1100" dirty="0">
                 <a:solidFill>
                   <a:srgbClr val="2B3A55"/>
                 </a:solidFill>
@@ -9539,7 +9539,7 @@
               </a:rPr>
               <a:t>Quién es y qué debe lograr.</a:t>
             </a:r>
-            <a:endParaRPr lang="en-US" sz="1150" dirty="0"/>
+            <a:endParaRPr lang="en-US" sz="1100" dirty="0"/>
           </a:p>
         </p:txBody>
       </p:sp>
@@ -9551,12 +9551,12 @@
         </p:nvSpPr>
         <p:spPr>
           <a:xfrm>
-            <a:off x="6205576" y="2788920"/>
-            <a:ext cx="5327752" cy="914400"/>
+            <a:off x="6419088" y="3218688"/>
+            <a:ext cx="5114239" cy="1051560"/>
           </a:xfrm>
           <a:prstGeom prst="roundRect">
             <a:avLst>
-              <a:gd name="adj" fmla="val 6000"/>
+              <a:gd name="adj" fmla="val 5217"/>
             </a:avLst>
           </a:prstGeom>
           <a:solidFill>
@@ -9578,8 +9578,8 @@
         </p:nvSpPr>
         <p:spPr>
           <a:xfrm>
-            <a:off x="6205576" y="2788920"/>
-            <a:ext cx="73152" cy="914400"/>
+            <a:off x="6419088" y="3218688"/>
+            <a:ext cx="73152" cy="1051560"/>
           </a:xfrm>
           <a:prstGeom prst="roundRect">
             <a:avLst>
@@ -9605,8 +9605,8 @@
         </p:nvSpPr>
         <p:spPr>
           <a:xfrm>
-            <a:off x="6479896" y="2916936"/>
-            <a:ext cx="4870552" cy="365760"/>
+            <a:off x="6693408" y="3355848"/>
+            <a:ext cx="4657039" cy="365760"/>
           </a:xfrm>
           <a:prstGeom prst="rect">
             <a:avLst/>
@@ -9644,8 +9644,8 @@
         </p:nvSpPr>
         <p:spPr>
           <a:xfrm>
-            <a:off x="6479896" y="3264408"/>
-            <a:ext cx="4870552" cy="411480"/>
+            <a:off x="6693408" y="3721608"/>
+            <a:ext cx="4657039" cy="457200"/>
           </a:xfrm>
           <a:prstGeom prst="rect">
             <a:avLst/>
@@ -9661,7 +9661,7 @@
               <a:buNone/>
             </a:pPr>
             <a:r>
-              <a:rPr lang="en-US" sz="1150" dirty="0">
+              <a:rPr lang="en-US" sz="1100" dirty="0">
                 <a:solidFill>
                   <a:srgbClr val="2B3A55"/>
                 </a:solidFill>
@@ -9669,9 +9669,9 @@
                 <a:ea typeface="Inter" pitchFamily="34" charset="-122"/>
                 <a:cs typeface="Inter" pitchFamily="34" charset="-120"/>
               </a:rPr>
-              <a:t>Qué puede y qué no; cuándo pausar.</a:t>
-            </a:r>
-            <a:endParaRPr lang="en-US" sz="1150" dirty="0"/>
+              <a:t>Qué puede y qué no; cuándo pausar. No inventar: usar una tool o decirlo.</a:t>
+            </a:r>
+            <a:endParaRPr lang="en-US" sz="1100" dirty="0"/>
           </a:p>
         </p:txBody>
       </p:sp>
@@ -9683,12 +9683,12 @@
         </p:nvSpPr>
         <p:spPr>
           <a:xfrm>
-            <a:off x="658368" y="3840480"/>
-            <a:ext cx="5327752" cy="914400"/>
+            <a:off x="6419088" y="4425696"/>
+            <a:ext cx="5114239" cy="1051560"/>
           </a:xfrm>
           <a:prstGeom prst="roundRect">
             <a:avLst>
-              <a:gd name="adj" fmla="val 6000"/>
+              <a:gd name="adj" fmla="val 5217"/>
             </a:avLst>
           </a:prstGeom>
           <a:solidFill>
@@ -9710,8 +9710,8 @@
         </p:nvSpPr>
         <p:spPr>
           <a:xfrm>
-            <a:off x="658368" y="3840480"/>
-            <a:ext cx="73152" cy="914400"/>
+            <a:off x="6419088" y="4425696"/>
+            <a:ext cx="73152" cy="1051560"/>
           </a:xfrm>
           <a:prstGeom prst="roundRect">
             <a:avLst>
@@ -9737,8 +9737,8 @@
         </p:nvSpPr>
         <p:spPr>
           <a:xfrm>
-            <a:off x="932688" y="3968496"/>
-            <a:ext cx="4870552" cy="365760"/>
+            <a:off x="6693408" y="4562856"/>
+            <a:ext cx="4657039" cy="365760"/>
           </a:xfrm>
           <a:prstGeom prst="rect">
             <a:avLst/>
@@ -9776,8 +9776,8 @@
         </p:nvSpPr>
         <p:spPr>
           <a:xfrm>
-            <a:off x="932688" y="4315968"/>
-            <a:ext cx="4870552" cy="411480"/>
+            <a:off x="6693408" y="4928616"/>
+            <a:ext cx="4657039" cy="457200"/>
           </a:xfrm>
           <a:prstGeom prst="rect">
             <a:avLst/>
@@ -9793,7 +9793,7 @@
               <a:buNone/>
             </a:pPr>
             <a:r>
-              <a:rPr lang="en-US" sz="1150" dirty="0">
+              <a:rPr lang="en-US" sz="1100" dirty="0">
                 <a:solidFill>
                   <a:srgbClr val="2B3A55"/>
                 </a:solidFill>
@@ -9803,151 +9803,19 @@
               </a:rPr>
               <a:t>Cómo responde: idioma, longitud y estilo.</a:t>
             </a:r>
-            <a:endParaRPr lang="en-US" sz="1150" dirty="0"/>
-          </a:p>
-        </p:txBody>
-      </p:sp>
-      <p:sp>
-        <p:nvSpPr>
-          <p:cNvPr id="22" name="Shape 20"/>
-          <p:cNvSpPr/>
-          <p:nvPr/>
-        </p:nvSpPr>
-        <p:spPr>
-          <a:xfrm>
-            <a:off x="6205576" y="3840480"/>
-            <a:ext cx="5327752" cy="914400"/>
-          </a:xfrm>
-          <a:prstGeom prst="roundRect">
-            <a:avLst>
-              <a:gd name="adj" fmla="val 6000"/>
-            </a:avLst>
-          </a:prstGeom>
-          <a:solidFill>
-            <a:srgbClr val="FFFFFF"/>
-          </a:solidFill>
-          <a:ln w="12700">
-            <a:solidFill>
-              <a:srgbClr val="DFE6F0"/>
-            </a:solidFill>
-            <a:prstDash val="solid"/>
-          </a:ln>
-        </p:spPr>
-      </p:sp>
-      <p:sp>
-        <p:nvSpPr>
-          <p:cNvPr id="23" name="Shape 21"/>
-          <p:cNvSpPr/>
-          <p:nvPr/>
-        </p:nvSpPr>
-        <p:spPr>
-          <a:xfrm>
-            <a:off x="6205576" y="3840480"/>
-            <a:ext cx="73152" cy="914400"/>
-          </a:xfrm>
-          <a:prstGeom prst="roundRect">
-            <a:avLst>
-              <a:gd name="adj" fmla="val 50000"/>
-            </a:avLst>
-          </a:prstGeom>
-          <a:solidFill>
-            <a:srgbClr val="4FA82F"/>
-          </a:solidFill>
-          <a:ln w="12700">
-            <a:solidFill>
-              <a:srgbClr val="333333"/>
-            </a:solidFill>
-            <a:prstDash val="solid"/>
-          </a:ln>
-        </p:spPr>
-      </p:sp>
-      <p:sp>
-        <p:nvSpPr>
-          <p:cNvPr id="24" name="Text 22"/>
-          <p:cNvSpPr/>
-          <p:nvPr/>
-        </p:nvSpPr>
-        <p:spPr>
-          <a:xfrm>
-            <a:off x="6479896" y="3968496"/>
-            <a:ext cx="4870552" cy="365760"/>
-          </a:xfrm>
-          <a:prstGeom prst="rect">
-            <a:avLst/>
-          </a:prstGeom>
-          <a:noFill/>
-          <a:ln/>
-        </p:spPr>
-        <p:txBody>
-          <a:bodyPr wrap="square" rtlCol="0" anchor="ctr"/>
-          <a:lstStyle/>
-          <a:p>
-            <a:pPr indent="0" marL="0">
-              <a:buNone/>
-            </a:pPr>
-            <a:r>
-              <a:rPr lang="en-US" sz="1500" b="1" dirty="0">
-                <a:solidFill>
-                  <a:srgbClr val="0F1B33"/>
-                </a:solidFill>
-                <a:latin typeface="Montserrat" pitchFamily="34" charset="0"/>
-                <a:ea typeface="Montserrat" pitchFamily="34" charset="-122"/>
-                <a:cs typeface="Montserrat" pitchFamily="34" charset="-120"/>
-              </a:rPr>
-              <a:t>Cuando no sabe</a:t>
-            </a:r>
-            <a:endParaRPr lang="en-US" sz="1500" dirty="0"/>
-          </a:p>
-        </p:txBody>
-      </p:sp>
-      <p:sp>
-        <p:nvSpPr>
-          <p:cNvPr id="25" name="Text 23"/>
-          <p:cNvSpPr/>
-          <p:nvPr/>
-        </p:nvSpPr>
-        <p:spPr>
-          <a:xfrm>
-            <a:off x="6479896" y="4315968"/>
-            <a:ext cx="4870552" cy="411480"/>
-          </a:xfrm>
-          <a:prstGeom prst="rect">
-            <a:avLst/>
-          </a:prstGeom>
-          <a:noFill/>
-          <a:ln/>
-        </p:spPr>
-        <p:txBody>
-          <a:bodyPr wrap="square" rtlCol="0" anchor="t"/>
-          <a:lstStyle/>
-          <a:p>
-            <a:pPr indent="0" marL="0">
-              <a:buNone/>
-            </a:pPr>
-            <a:r>
-              <a:rPr lang="en-US" sz="1150" dirty="0">
-                <a:solidFill>
-                  <a:srgbClr val="2B3A55"/>
-                </a:solidFill>
-                <a:latin typeface="Inter" pitchFamily="34" charset="0"/>
-                <a:ea typeface="Inter" pitchFamily="34" charset="-122"/>
-                <a:cs typeface="Inter" pitchFamily="34" charset="-120"/>
-              </a:rPr>
-              <a:t>No inventar: usar una tool o decirlo.</a:t>
-            </a:r>
-            <a:endParaRPr lang="en-US" sz="1150" dirty="0"/>
-          </a:p>
-        </p:txBody>
-      </p:sp>
-      <p:sp>
-        <p:nvSpPr>
-          <p:cNvPr id="26" name="Text 24"/>
-          <p:cNvSpPr/>
-          <p:nvPr/>
-        </p:nvSpPr>
-        <p:spPr>
-          <a:xfrm>
-            <a:off x="658368" y="5074920"/>
+            <a:endParaRPr lang="en-US" sz="1100" dirty="0"/>
+          </a:p>
+        </p:txBody>
+      </p:sp>
+      <p:sp>
+        <p:nvSpPr>
+          <p:cNvPr id="22" name="Text 20"/>
+          <p:cNvSpPr/>
+          <p:nvPr/>
+        </p:nvSpPr>
+        <p:spPr>
+          <a:xfrm>
+            <a:off x="658368" y="5623560"/>
             <a:ext cx="10874959" cy="457200"/>
           </a:xfrm>
           <a:prstGeom prst="rect">

</xml_diff>

<commit_message>
Slide 19: larger multi-line code in a column
</commit_message>
<xml_diff>
--- a/agentes-de-ia/agentes-intro.pptx
+++ b/agentes-de-ia/agentes-intro.pptx
@@ -10948,12 +10948,12 @@
         </p:nvSpPr>
         <p:spPr>
           <a:xfrm>
-            <a:off x="658368" y="1828800"/>
-            <a:ext cx="10874959" cy="731520"/>
+            <a:off x="658368" y="2011680"/>
+            <a:ext cx="5486400" cy="3474720"/>
           </a:xfrm>
           <a:prstGeom prst="roundRect">
             <a:avLst>
-              <a:gd name="adj" fmla="val 10000"/>
+              <a:gd name="adj" fmla="val 2105"/>
             </a:avLst>
           </a:prstGeom>
           <a:solidFill>
@@ -10975,24 +10975,27 @@
         </p:nvSpPr>
         <p:spPr>
           <a:xfrm>
-            <a:off x="1024128" y="1828800"/>
-            <a:ext cx="10143439" cy="731520"/>
-          </a:xfrm>
-          <a:prstGeom prst="rect">
-            <a:avLst/>
-          </a:prstGeom>
-          <a:noFill/>
-          <a:ln/>
-        </p:spPr>
-        <p:txBody>
-          <a:bodyPr wrap="square" rtlCol="0" anchor="ctr"/>
-          <a:lstStyle/>
-          <a:p>
-            <a:pPr indent="0" marL="0">
-              <a:buNone/>
-            </a:pPr>
-            <a:r>
-              <a:rPr lang="en-US" sz="1400" dirty="0">
+            <a:off x="978408" y="2194560"/>
+            <a:ext cx="4846320" cy="3108960"/>
+          </a:xfrm>
+          <a:prstGeom prst="rect">
+            <a:avLst/>
+          </a:prstGeom>
+          <a:noFill/>
+          <a:ln/>
+        </p:spPr>
+        <p:txBody>
+          <a:bodyPr wrap="square" rtlCol="0" anchor="t"/>
+          <a:lstStyle/>
+          <a:p>
+            <a:pPr indent="0" marL="0">
+              <a:lnSpc>
+                <a:spcPct val="120000"/>
+              </a:lnSpc>
+              <a:buNone/>
+            </a:pPr>
+            <a:r>
+              <a:rPr lang="en-US" sz="1450" dirty="0">
                 <a:solidFill>
                   <a:srgbClr val="38BDF8"/>
                 </a:solidFill>
@@ -11000,37 +11003,271 @@
                 <a:ea typeface="JetBrains Mono" pitchFamily="34" charset="-122"/>
                 <a:cs typeface="JetBrains Mono" pitchFamily="34" charset="-120"/>
               </a:rPr>
-              <a:t>model=</a:t>
-            </a:r>
-            <a:pPr indent="0" marL="0">
-              <a:buNone/>
-            </a:pPr>
-            <a:r>
-              <a:rPr lang="en-US" sz="1400" dirty="0">
-                <a:solidFill>
-                  <a:srgbClr val="7AC943"/>
+              <a:t>model</a:t>
+            </a:r>
+            <a:pPr indent="0" marL="0">
+              <a:lnSpc>
+                <a:spcPct val="120000"/>
+              </a:lnSpc>
+              <a:buNone/>
+            </a:pPr>
+            <a:r>
+              <a:rPr lang="en-US" sz="1450" dirty="0">
+                <a:solidFill>
+                  <a:srgbClr val="D7E2F0"/>
                 </a:solidFill>
                 <a:latin typeface="JetBrains Mono" pitchFamily="34" charset="0"/>
                 <a:ea typeface="JetBrains Mono" pitchFamily="34" charset="-122"/>
                 <a:cs typeface="JetBrains Mono" pitchFamily="34" charset="-120"/>
               </a:rPr>
-              <a:t>"openai:gpt-5"</a:t>
-            </a:r>
-            <a:pPr indent="0" marL="0">
-              <a:buNone/>
-            </a:pPr>
-            <a:r>
-              <a:rPr lang="en-US" sz="1400" dirty="0">
-                <a:solidFill>
-                  <a:srgbClr val="7C8AA0"/>
+              <a:t> = </a:t>
+            </a:r>
+            <a:pPr indent="0" marL="0">
+              <a:lnSpc>
+                <a:spcPct val="120000"/>
+              </a:lnSpc>
+              <a:buNone/>
+            </a:pPr>
+            <a:r>
+              <a:rPr lang="en-US" sz="1450" dirty="0">
+                <a:solidFill>
+                  <a:srgbClr val="7AC943"/>
                 </a:solidFill>
                 <a:latin typeface="JetBrains Mono" pitchFamily="34" charset="0"/>
                 <a:ea typeface="JetBrains Mono" pitchFamily="34" charset="-122"/>
                 <a:cs typeface="JetBrains Mono" pitchFamily="34" charset="-120"/>
               </a:rPr>
-              <a:t>   # o anthropic:..., google:..., ollama:...</a:t>
-            </a:r>
-            <a:endParaRPr lang="en-US" sz="1400" dirty="0"/>
+              <a:t>"openai:gpt-5"
+</a:t>
+            </a:r>
+            <a:pPr indent="0" marL="0">
+              <a:lnSpc>
+                <a:spcPct val="120000"/>
+              </a:lnSpc>
+              <a:buNone/>
+            </a:pPr>
+            <a:r>
+              <a:rPr lang="en-US" sz="1450" dirty="0">
+                <a:solidFill>
+                  <a:srgbClr val="7C8AA0"/>
+                </a:solidFill>
+                <a:latin typeface="JetBrains Mono" pitchFamily="34" charset="0"/>
+                <a:ea typeface="JetBrains Mono" pitchFamily="34" charset="-122"/>
+                <a:cs typeface="JetBrains Mono" pitchFamily="34" charset="-120"/>
+              </a:rPr>
+              <a:t># o anthropic:..., google:..., ollama:...
+</a:t>
+            </a:r>
+            <a:pPr indent="0" marL="0">
+              <a:lnSpc>
+                <a:spcPct val="120000"/>
+              </a:lnSpc>
+              <a:buNone/>
+            </a:pPr>
+            <a:r>
+              <a:rPr lang="en-US" sz="1450" dirty="0">
+                <a:solidFill>
+                  <a:srgbClr val="38BDF8"/>
+                </a:solidFill>
+                <a:latin typeface="JetBrains Mono" pitchFamily="34" charset="0"/>
+                <a:ea typeface="JetBrains Mono" pitchFamily="34" charset="-122"/>
+                <a:cs typeface="JetBrains Mono" pitchFamily="34" charset="-120"/>
+              </a:rPr>
+              <a:t>agent</a:t>
+            </a:r>
+            <a:pPr indent="0" marL="0">
+              <a:lnSpc>
+                <a:spcPct val="120000"/>
+              </a:lnSpc>
+              <a:buNone/>
+            </a:pPr>
+            <a:r>
+              <a:rPr lang="en-US" sz="1450" dirty="0">
+                <a:solidFill>
+                  <a:srgbClr val="D7E2F0"/>
+                </a:solidFill>
+                <a:latin typeface="JetBrains Mono" pitchFamily="34" charset="0"/>
+                <a:ea typeface="JetBrains Mono" pitchFamily="34" charset="-122"/>
+                <a:cs typeface="JetBrains Mono" pitchFamily="34" charset="-120"/>
+              </a:rPr>
+              <a:t> = </a:t>
+            </a:r>
+            <a:pPr indent="0" marL="0">
+              <a:lnSpc>
+                <a:spcPct val="120000"/>
+              </a:lnSpc>
+              <a:buNone/>
+            </a:pPr>
+            <a:r>
+              <a:rPr lang="en-US" sz="1450" dirty="0">
+                <a:solidFill>
+                  <a:srgbClr val="7AC943"/>
+                </a:solidFill>
+                <a:latin typeface="JetBrains Mono" pitchFamily="34" charset="0"/>
+                <a:ea typeface="JetBrains Mono" pitchFamily="34" charset="-122"/>
+                <a:cs typeface="JetBrains Mono" pitchFamily="34" charset="-120"/>
+              </a:rPr>
+              <a:t>create_agent(
+</a:t>
+            </a:r>
+            <a:pPr indent="0" marL="0">
+              <a:lnSpc>
+                <a:spcPct val="120000"/>
+              </a:lnSpc>
+              <a:buNone/>
+            </a:pPr>
+            <a:r>
+              <a:rPr lang="en-US" sz="1450" dirty="0">
+                <a:solidFill>
+                  <a:srgbClr val="38BDF8"/>
+                </a:solidFill>
+                <a:latin typeface="JetBrains Mono" pitchFamily="34" charset="0"/>
+                <a:ea typeface="JetBrains Mono" pitchFamily="34" charset="-122"/>
+                <a:cs typeface="JetBrains Mono" pitchFamily="34" charset="-120"/>
+              </a:rPr>
+              <a:t>    model</a:t>
+            </a:r>
+            <a:pPr indent="0" marL="0">
+              <a:lnSpc>
+                <a:spcPct val="120000"/>
+              </a:lnSpc>
+              <a:buNone/>
+            </a:pPr>
+            <a:r>
+              <a:rPr lang="en-US" sz="1450" dirty="0">
+                <a:solidFill>
+                  <a:srgbClr val="D7E2F0"/>
+                </a:solidFill>
+                <a:latin typeface="JetBrains Mono" pitchFamily="34" charset="0"/>
+                <a:ea typeface="JetBrains Mono" pitchFamily="34" charset="-122"/>
+                <a:cs typeface="JetBrains Mono" pitchFamily="34" charset="-120"/>
+              </a:rPr>
+              <a:t>=model,
+</a:t>
+            </a:r>
+            <a:pPr indent="0" marL="0">
+              <a:lnSpc>
+                <a:spcPct val="120000"/>
+              </a:lnSpc>
+              <a:buNone/>
+            </a:pPr>
+            <a:r>
+              <a:rPr lang="en-US" sz="1450" dirty="0">
+                <a:solidFill>
+                  <a:srgbClr val="38BDF8"/>
+                </a:solidFill>
+                <a:latin typeface="JetBrains Mono" pitchFamily="34" charset="0"/>
+                <a:ea typeface="JetBrains Mono" pitchFamily="34" charset="-122"/>
+                <a:cs typeface="JetBrains Mono" pitchFamily="34" charset="-120"/>
+              </a:rPr>
+              <a:t>    tools</a:t>
+            </a:r>
+            <a:pPr indent="0" marL="0">
+              <a:lnSpc>
+                <a:spcPct val="120000"/>
+              </a:lnSpc>
+              <a:buNone/>
+            </a:pPr>
+            <a:r>
+              <a:rPr lang="en-US" sz="1450" dirty="0">
+                <a:solidFill>
+                  <a:srgbClr val="7AC943"/>
+                </a:solidFill>
+                <a:latin typeface="JetBrains Mono" pitchFamily="34" charset="0"/>
+                <a:ea typeface="JetBrains Mono" pitchFamily="34" charset="-122"/>
+                <a:cs typeface="JetBrains Mono" pitchFamily="34" charset="-120"/>
+              </a:rPr>
+              <a:t>=[...],
+</a:t>
+            </a:r>
+            <a:pPr indent="0" marL="0">
+              <a:lnSpc>
+                <a:spcPct val="120000"/>
+              </a:lnSpc>
+              <a:buNone/>
+            </a:pPr>
+            <a:r>
+              <a:rPr lang="en-US" sz="1450" dirty="0">
+                <a:solidFill>
+                  <a:srgbClr val="38BDF8"/>
+                </a:solidFill>
+                <a:latin typeface="JetBrains Mono" pitchFamily="34" charset="0"/>
+                <a:ea typeface="JetBrains Mono" pitchFamily="34" charset="-122"/>
+                <a:cs typeface="JetBrains Mono" pitchFamily="34" charset="-120"/>
+              </a:rPr>
+              <a:t>    middleware</a:t>
+            </a:r>
+            <a:pPr indent="0" marL="0">
+              <a:lnSpc>
+                <a:spcPct val="120000"/>
+              </a:lnSpc>
+              <a:buNone/>
+            </a:pPr>
+            <a:r>
+              <a:rPr lang="en-US" sz="1450" dirty="0">
+                <a:solidFill>
+                  <a:srgbClr val="7AC943"/>
+                </a:solidFill>
+                <a:latin typeface="JetBrains Mono" pitchFamily="34" charset="0"/>
+                <a:ea typeface="JetBrains Mono" pitchFamily="34" charset="-122"/>
+                <a:cs typeface="JetBrains Mono" pitchFamily="34" charset="-120"/>
+              </a:rPr>
+              <a:t>=[...],
+</a:t>
+            </a:r>
+            <a:pPr indent="0" marL="0">
+              <a:lnSpc>
+                <a:spcPct val="120000"/>
+              </a:lnSpc>
+              <a:buNone/>
+            </a:pPr>
+            <a:r>
+              <a:rPr lang="en-US" sz="1450" dirty="0">
+                <a:solidFill>
+                  <a:srgbClr val="38BDF8"/>
+                </a:solidFill>
+                <a:latin typeface="JetBrains Mono" pitchFamily="34" charset="0"/>
+                <a:ea typeface="JetBrains Mono" pitchFamily="34" charset="-122"/>
+                <a:cs typeface="JetBrains Mono" pitchFamily="34" charset="-120"/>
+              </a:rPr>
+              <a:t>    response_format</a:t>
+            </a:r>
+            <a:pPr indent="0" marL="0">
+              <a:lnSpc>
+                <a:spcPct val="120000"/>
+              </a:lnSpc>
+              <a:buNone/>
+            </a:pPr>
+            <a:r>
+              <a:rPr lang="en-US" sz="1450" dirty="0">
+                <a:solidFill>
+                  <a:srgbClr val="7AC943"/>
+                </a:solidFill>
+                <a:latin typeface="JetBrains Mono" pitchFamily="34" charset="0"/>
+                <a:ea typeface="JetBrains Mono" pitchFamily="34" charset="-122"/>
+                <a:cs typeface="JetBrains Mono" pitchFamily="34" charset="-120"/>
+              </a:rPr>
+              <a:t>=Answer,
+</a:t>
+            </a:r>
+            <a:pPr indent="0" marL="0">
+              <a:lnSpc>
+                <a:spcPct val="120000"/>
+              </a:lnSpc>
+              <a:buNone/>
+            </a:pPr>
+            <a:r>
+              <a:rPr lang="en-US" sz="1450" dirty="0">
+                <a:solidFill>
+                  <a:srgbClr val="D7E2F0"/>
+                </a:solidFill>
+                <a:latin typeface="JetBrains Mono" pitchFamily="34" charset="0"/>
+                <a:ea typeface="JetBrains Mono" pitchFamily="34" charset="-122"/>
+                <a:cs typeface="JetBrains Mono" pitchFamily="34" charset="-120"/>
+              </a:rPr>
+              <a:t>)</a:t>
+            </a:r>
+            <a:endParaRPr lang="en-US" sz="1450" dirty="0"/>
           </a:p>
         </p:txBody>
       </p:sp>
@@ -11042,12 +11279,12 @@
         </p:nvSpPr>
         <p:spPr>
           <a:xfrm>
-            <a:off x="658368" y="2743200"/>
-            <a:ext cx="3478682" cy="2377440"/>
+            <a:off x="6419088" y="2011680"/>
+            <a:ext cx="5114239" cy="1097280"/>
           </a:xfrm>
           <a:prstGeom prst="roundRect">
             <a:avLst>
-              <a:gd name="adj" fmla="val 3077"/>
+              <a:gd name="adj" fmla="val 5000"/>
             </a:avLst>
           </a:prstGeom>
           <a:solidFill>
@@ -11069,12 +11306,12 @@
         </p:nvSpPr>
         <p:spPr>
           <a:xfrm>
-            <a:off x="658368" y="2743200"/>
-            <a:ext cx="3478682" cy="73152"/>
+            <a:off x="6419088" y="2011680"/>
+            <a:ext cx="73152" cy="1097280"/>
           </a:xfrm>
           <a:prstGeom prst="roundRect">
             <a:avLst>
-              <a:gd name="adj" fmla="val 37500"/>
+              <a:gd name="adj" fmla="val 50000"/>
             </a:avLst>
           </a:prstGeom>
           <a:solidFill>
@@ -11096,24 +11333,24 @@
         </p:nvSpPr>
         <p:spPr>
           <a:xfrm>
-            <a:off x="914400" y="2971800"/>
-            <a:ext cx="2966618" cy="548640"/>
-          </a:xfrm>
-          <a:prstGeom prst="rect">
-            <a:avLst/>
-          </a:prstGeom>
-          <a:noFill/>
-          <a:ln/>
-        </p:spPr>
-        <p:txBody>
-          <a:bodyPr wrap="square" rtlCol="0" anchor="t"/>
-          <a:lstStyle/>
-          <a:p>
-            <a:pPr indent="0" marL="0">
-              <a:buNone/>
-            </a:pPr>
-            <a:r>
-              <a:rPr lang="en-US" sz="1700" b="1" dirty="0">
+            <a:off x="6693408" y="2130552"/>
+            <a:ext cx="4657039" cy="365760"/>
+          </a:xfrm>
+          <a:prstGeom prst="rect">
+            <a:avLst/>
+          </a:prstGeom>
+          <a:noFill/>
+          <a:ln/>
+        </p:spPr>
+        <p:txBody>
+          <a:bodyPr wrap="square" rtlCol="0" anchor="ctr"/>
+          <a:lstStyle/>
+          <a:p>
+            <a:pPr indent="0" marL="0">
+              <a:buNone/>
+            </a:pPr>
+            <a:r>
+              <a:rPr lang="en-US" sz="1500" b="1" dirty="0">
                 <a:solidFill>
                   <a:srgbClr val="0F1B33"/>
                 </a:solidFill>
@@ -11123,7 +11360,7 @@
               </a:rPr>
               <a:t>Modelo sustituible</a:t>
             </a:r>
-            <a:endParaRPr lang="en-US" sz="1700" dirty="0"/>
+            <a:endParaRPr lang="en-US" sz="1500" dirty="0"/>
           </a:p>
         </p:txBody>
       </p:sp>
@@ -11135,8 +11372,8 @@
         </p:nvSpPr>
         <p:spPr>
           <a:xfrm>
-            <a:off x="914400" y="3611880"/>
-            <a:ext cx="2966618" cy="1371600"/>
+            <a:off x="6693408" y="2487168"/>
+            <a:ext cx="4657039" cy="566928"/>
           </a:xfrm>
           <a:prstGeom prst="rect">
             <a:avLst/>
@@ -11150,12 +11387,12 @@
           <a:p>
             <a:pPr indent="0" marL="0">
               <a:lnSpc>
-                <a:spcPct val="106000"/>
+                <a:spcPct val="102000"/>
               </a:lnSpc>
               <a:buNone/>
             </a:pPr>
             <a:r>
-              <a:rPr lang="en-US" sz="1200" dirty="0">
+              <a:rPr lang="en-US" sz="1050" dirty="0">
                 <a:solidFill>
                   <a:srgbClr val="2B3A55"/>
                 </a:solidFill>
@@ -11165,7 +11402,7 @@
               </a:rPr>
               <a:t>Cambia de proveedor con una línea: init_chat_model unifica la interfaz, y las content blocks dan un formato común a texto, imágenes y más.</a:t>
             </a:r>
-            <a:endParaRPr lang="en-US" sz="1200" dirty="0"/>
+            <a:endParaRPr lang="en-US" sz="1050" dirty="0"/>
           </a:p>
         </p:txBody>
       </p:sp>
@@ -11177,12 +11414,12 @@
         </p:nvSpPr>
         <p:spPr>
           <a:xfrm>
-            <a:off x="4356506" y="2743200"/>
-            <a:ext cx="3478682" cy="2377440"/>
+            <a:off x="6419088" y="3218688"/>
+            <a:ext cx="5114239" cy="1097280"/>
           </a:xfrm>
           <a:prstGeom prst="roundRect">
             <a:avLst>
-              <a:gd name="adj" fmla="val 3077"/>
+              <a:gd name="adj" fmla="val 5000"/>
             </a:avLst>
           </a:prstGeom>
           <a:solidFill>
@@ -11204,12 +11441,12 @@
         </p:nvSpPr>
         <p:spPr>
           <a:xfrm>
-            <a:off x="4356506" y="2743200"/>
-            <a:ext cx="3478682" cy="73152"/>
+            <a:off x="6419088" y="3218688"/>
+            <a:ext cx="73152" cy="1097280"/>
           </a:xfrm>
           <a:prstGeom prst="roundRect">
             <a:avLst>
-              <a:gd name="adj" fmla="val 37500"/>
+              <a:gd name="adj" fmla="val 50000"/>
             </a:avLst>
           </a:prstGeom>
           <a:solidFill>
@@ -11231,24 +11468,24 @@
         </p:nvSpPr>
         <p:spPr>
           <a:xfrm>
-            <a:off x="4612538" y="2971800"/>
-            <a:ext cx="2966618" cy="548640"/>
-          </a:xfrm>
-          <a:prstGeom prst="rect">
-            <a:avLst/>
-          </a:prstGeom>
-          <a:noFill/>
-          <a:ln/>
-        </p:spPr>
-        <p:txBody>
-          <a:bodyPr wrap="square" rtlCol="0" anchor="t"/>
-          <a:lstStyle/>
-          <a:p>
-            <a:pPr indent="0" marL="0">
-              <a:buNone/>
-            </a:pPr>
-            <a:r>
-              <a:rPr lang="en-US" sz="1700" b="1" dirty="0">
+            <a:off x="6693408" y="3337560"/>
+            <a:ext cx="4657039" cy="365760"/>
+          </a:xfrm>
+          <a:prstGeom prst="rect">
+            <a:avLst/>
+          </a:prstGeom>
+          <a:noFill/>
+          <a:ln/>
+        </p:spPr>
+        <p:txBody>
+          <a:bodyPr wrap="square" rtlCol="0" anchor="ctr"/>
+          <a:lstStyle/>
+          <a:p>
+            <a:pPr indent="0" marL="0">
+              <a:buNone/>
+            </a:pPr>
+            <a:r>
+              <a:rPr lang="en-US" sz="1500" b="1" dirty="0">
                 <a:solidFill>
                   <a:srgbClr val="0F1B33"/>
                 </a:solidFill>
@@ -11258,7 +11495,7 @@
               </a:rPr>
               <a:t>Middleware</a:t>
             </a:r>
-            <a:endParaRPr lang="en-US" sz="1700" dirty="0"/>
+            <a:endParaRPr lang="en-US" sz="1500" dirty="0"/>
           </a:p>
         </p:txBody>
       </p:sp>
@@ -11270,8 +11507,8 @@
         </p:nvSpPr>
         <p:spPr>
           <a:xfrm>
-            <a:off x="4612538" y="3611880"/>
-            <a:ext cx="2966618" cy="1371600"/>
+            <a:off x="6693408" y="3694176"/>
+            <a:ext cx="4657039" cy="566928"/>
           </a:xfrm>
           <a:prstGeom prst="rect">
             <a:avLst/>
@@ -11285,12 +11522,12 @@
           <a:p>
             <a:pPr indent="0" marL="0">
               <a:lnSpc>
-                <a:spcPct val="106000"/>
+                <a:spcPct val="102000"/>
               </a:lnSpc>
               <a:buNone/>
             </a:pPr>
             <a:r>
-              <a:rPr lang="en-US" sz="1200" dirty="0">
+              <a:rPr lang="en-US" sz="1050" dirty="0">
                 <a:solidFill>
                   <a:srgbClr val="2B3A55"/>
                 </a:solidFill>
@@ -11300,7 +11537,7 @@
               </a:rPr>
               <a:t>Hooks antes y después del modelo, y de cada tool: contexto, guardrails (PII), aprobación, resiliencia y subagentes. No es un runtime aparte.</a:t>
             </a:r>
-            <a:endParaRPr lang="en-US" sz="1200" dirty="0"/>
+            <a:endParaRPr lang="en-US" sz="1050" dirty="0"/>
           </a:p>
         </p:txBody>
       </p:sp>
@@ -11312,12 +11549,12 @@
         </p:nvSpPr>
         <p:spPr>
           <a:xfrm>
-            <a:off x="8054645" y="2743200"/>
-            <a:ext cx="3478682" cy="2377440"/>
+            <a:off x="6419088" y="4425696"/>
+            <a:ext cx="5114239" cy="1097280"/>
           </a:xfrm>
           <a:prstGeom prst="roundRect">
             <a:avLst>
-              <a:gd name="adj" fmla="val 3077"/>
+              <a:gd name="adj" fmla="val 5000"/>
             </a:avLst>
           </a:prstGeom>
           <a:solidFill>
@@ -11339,12 +11576,12 @@
         </p:nvSpPr>
         <p:spPr>
           <a:xfrm>
-            <a:off x="8054645" y="2743200"/>
-            <a:ext cx="3478682" cy="73152"/>
+            <a:off x="6419088" y="4425696"/>
+            <a:ext cx="73152" cy="1097280"/>
           </a:xfrm>
           <a:prstGeom prst="roundRect">
             <a:avLst>
-              <a:gd name="adj" fmla="val 37500"/>
+              <a:gd name="adj" fmla="val 50000"/>
             </a:avLst>
           </a:prstGeom>
           <a:solidFill>
@@ -11366,24 +11603,24 @@
         </p:nvSpPr>
         <p:spPr>
           <a:xfrm>
-            <a:off x="8310677" y="2971800"/>
-            <a:ext cx="2966618" cy="548640"/>
-          </a:xfrm>
-          <a:prstGeom prst="rect">
-            <a:avLst/>
-          </a:prstGeom>
-          <a:noFill/>
-          <a:ln/>
-        </p:spPr>
-        <p:txBody>
-          <a:bodyPr wrap="square" rtlCol="0" anchor="t"/>
-          <a:lstStyle/>
-          <a:p>
-            <a:pPr indent="0" marL="0">
-              <a:buNone/>
-            </a:pPr>
-            <a:r>
-              <a:rPr lang="en-US" sz="1700" b="1" dirty="0">
+            <a:off x="6693408" y="4544568"/>
+            <a:ext cx="4657039" cy="365760"/>
+          </a:xfrm>
+          <a:prstGeom prst="rect">
+            <a:avLst/>
+          </a:prstGeom>
+          <a:noFill/>
+          <a:ln/>
+        </p:spPr>
+        <p:txBody>
+          <a:bodyPr wrap="square" rtlCol="0" anchor="ctr"/>
+          <a:lstStyle/>
+          <a:p>
+            <a:pPr indent="0" marL="0">
+              <a:buNone/>
+            </a:pPr>
+            <a:r>
+              <a:rPr lang="en-US" sz="1500" b="1" dirty="0">
                 <a:solidFill>
                   <a:srgbClr val="0F1B33"/>
                 </a:solidFill>
@@ -11393,7 +11630,7 @@
               </a:rPr>
               <a:t>Salida</a:t>
             </a:r>
-            <a:endParaRPr lang="en-US" sz="1700" dirty="0"/>
+            <a:endParaRPr lang="en-US" sz="1500" dirty="0"/>
           </a:p>
         </p:txBody>
       </p:sp>
@@ -11405,8 +11642,8 @@
         </p:nvSpPr>
         <p:spPr>
           <a:xfrm>
-            <a:off x="8310677" y="3611880"/>
-            <a:ext cx="2966618" cy="1371600"/>
+            <a:off x="6693408" y="4901184"/>
+            <a:ext cx="4657039" cy="566928"/>
           </a:xfrm>
           <a:prstGeom prst="rect">
             <a:avLst/>
@@ -11420,12 +11657,12 @@
           <a:p>
             <a:pPr indent="0" marL="0">
               <a:lnSpc>
-                <a:spcPct val="106000"/>
+                <a:spcPct val="102000"/>
               </a:lnSpc>
               <a:buNone/>
             </a:pPr>
             <a:r>
-              <a:rPr lang="en-US" sz="1200" dirty="0">
+              <a:rPr lang="en-US" sz="1050" dirty="0">
                 <a:solidFill>
                   <a:srgbClr val="2B3A55"/>
                 </a:solidFill>
@@ -11435,7 +11672,7 @@
               </a:rPr>
               <a:t>Estructurada (Pydantic, response_format → structured_response) para integrar; y streaming para ver la respuesta en vivo.</a:t>
             </a:r>
-            <a:endParaRPr lang="en-US" sz="1200" dirty="0"/>
+            <a:endParaRPr lang="en-US" sz="1050" dirty="0"/>
           </a:p>
         </p:txBody>
       </p:sp>
@@ -11447,7 +11684,7 @@
         </p:nvSpPr>
         <p:spPr>
           <a:xfrm>
-            <a:off x="658368" y="5257800"/>
+            <a:off x="658368" y="5806440"/>
             <a:ext cx="10874959" cy="457200"/>
           </a:xfrm>
           <a:prstGeom prst="rect">

</xml_diff>

<commit_message>
Slide 22: redraw RAG flow connector and give closing card breathing room
</commit_message>
<xml_diff>
--- a/agentes-de-ia/agentes-intro.pptx
+++ b/agentes-de-ia/agentes-intro.pptx
@@ -13484,8 +13484,8 @@
         </p:blipFill>
         <p:spPr>
           <a:xfrm>
-            <a:off x="1172192" y="1737360"/>
-            <a:ext cx="9847311" cy="3200400"/>
+            <a:off x="1312868" y="1737360"/>
+            <a:ext cx="9565959" cy="3108960"/>
           </a:xfrm>
           <a:prstGeom prst="rect">
             <a:avLst/>
@@ -13500,12 +13500,12 @@
         </p:nvSpPr>
         <p:spPr>
           <a:xfrm>
-            <a:off x="658368" y="5074920"/>
-            <a:ext cx="10874959" cy="1051560"/>
+            <a:off x="658368" y="4983480"/>
+            <a:ext cx="10874959" cy="1188720"/>
           </a:xfrm>
           <a:prstGeom prst="roundRect">
             <a:avLst>
-              <a:gd name="adj" fmla="val 6957"/>
+              <a:gd name="adj" fmla="val 6154"/>
             </a:avLst>
           </a:prstGeom>
           <a:solidFill>
@@ -13527,8 +13527,8 @@
         </p:nvSpPr>
         <p:spPr>
           <a:xfrm>
-            <a:off x="978408" y="5074920"/>
-            <a:ext cx="10234879" cy="1051560"/>
+            <a:off x="978408" y="4983480"/>
+            <a:ext cx="10234879" cy="1188720"/>
           </a:xfrm>
           <a:prstGeom prst="rect">
             <a:avLst/>
@@ -13542,7 +13542,7 @@
           <a:p>
             <a:pPr indent="0" marL="0">
               <a:lnSpc>
-                <a:spcPct val="108000"/>
+                <a:spcPct val="115000"/>
               </a:lnSpc>
               <a:buNone/>
             </a:pPr>

</xml_diff>